<commit_message>
Actualizar informe de avance y presentación con la publicación en iOS
</commit_message>
<xml_diff>
--- a/Fase 2/Evidencias Proyecto/Presentación Proyecto.pptx
+++ b/Fase 2/Evidencias Proyecto/Presentación Proyecto.pptx
@@ -16,9 +16,10 @@
     <p:sldId id="264" r:id="rId10"/>
     <p:sldId id="265" r:id="rId11"/>
     <p:sldId id="266" r:id="rId12"/>
+    <p:sldId id="267" r:id="rId13"/>
   </p:sldIdLst>
   <p:notesMasterIdLst>
-    <p:notesMasterId r:id="rId13"/>
+    <p:notesMasterId r:id="rId14"/>
   </p:notesMasterIdLst>
   <p:sldSz cx="9144000" cy="5143500"/>
   <p:notesSz cx="5143500" cy="9144000"/>
@@ -117,7 +118,7 @@
   <p:extLst>
     <p:ext uri="{521415D9-36F7-43E2-AB2F-B90AF26B5E84}">
       <p14:sectionLst xmlns:p14="http://schemas.microsoft.com/office/powerpoint/2010/main">
-        <p14:section name="Evaluación 2" id="{dc922777-3dee-9174-096b-64220d59be08}">
+        <p14:section name="Evaluación 2" id="{d68fcb68-8712-0bb7-1b48-41bf5127b62e}">
           <p14:sldIdLst>
             <p14:sldId id="256"/>
             <p14:sldId id="257"/>
@@ -130,6 +131,7 @@
             <p14:sldId id="264"/>
             <p14:sldId id="265"/>
             <p14:sldId id="266"/>
+            <p14:sldId id="267"/>
           </p14:sldIdLst>
         </p14:section>
       </p14:sectionLst>
@@ -624,7 +626,7 @@
           <a:p>
             <a:r>
               <a:rPr lang="en-US" dirty="0"/>
-              <a:t>Y esta es la administración. El dueño ve en el panel cuántos clientes tiene, cuántos socios están activos y las visitas del día y de la semana, además de los premios que más se canjean. Desde ahí edita el menú real del local, que tiene cuarenta y tres platos, crea premios y promociones sin publicar una nueva versión de la app, y gestiona al personal. Si la conexión lo permite, ahora les muestro la app funcionando en vivo.</a:t>
+              <a:t>Esta es la parte del personal. El mesero abre el escáner y lee el QR del cliente con la cámara. La visita se suma al instante y la pantalla del cliente cambia sola. Para canjear, el cliente abre un QR de canje; el mesero lo escanea y el premio queda reservado. Cuando lo lleva a la mesa, confirma la entrega. Por eso el canje es en dos pasos.</a:t>
             </a:r>
             <a:endParaRPr lang="en-US" dirty="0"/>
           </a:p>
@@ -712,7 +714,7 @@
           <a:p>
             <a:r>
               <a:rPr lang="en-US" dirty="0"/>
-              <a:t>Eso es Clancy's Rewards. El próximo paso es terminar la seguridad y subir la app a la nube. Todo el proyecto está en el repositorio de GitHub. Muchas gracias, quedo atento a sus preguntas.</a:t>
+              <a:t>Y esta es la administración. El dueño ve en el panel cuántos clientes tiene, cuántos socios están activos y las visitas del día y de la semana, además de los premios que más se canjean. Desde ahí edita el menú real del local, que tiene cuarenta y tres platos, crea premios y promociones sin publicar una nueva versión de la app, y gestiona al personal. Si la conexión lo permite, ahora les muestro la app funcionando en vivo.</a:t>
             </a:r>
             <a:endParaRPr lang="en-US" dirty="0"/>
           </a:p>
@@ -736,6 +738,94 @@
             <a:fld id="{F7021451-1387-4CA6-816F-3879F97B5CBC}" type="slidenum">
               <a:rPr lang="en-US"/>
               <a:t>11</a:t>
+            </a:fld>
+            <a:endParaRPr lang="en-US"/>
+          </a:p>
+        </p:txBody>
+      </p:sp>
+    </p:spTree>
+    <p:extLst>
+      <p:ext uri="{BB962C8B-B14F-4D97-AF65-F5344CB8AC3E}">
+        <p14:creationId xmlns:p14="http://schemas.microsoft.com/office/powerpoint/2010/main" val="1024086991"/>
+      </p:ext>
+    </p:extLst>
+  </p:cSld>
+  <p:clrMapOvr>
+    <a:masterClrMapping/>
+  </p:clrMapOvr>
+</p:notes>
+</file>
+
+<file path=ppt/notesSlides/notesSlide12.xml><?xml version="1.0" encoding="utf-8"?>
+<p:notes xmlns:a="http://schemas.openxmlformats.org/drawingml/2006/main" xmlns:r="http://schemas.openxmlformats.org/officeDocument/2006/relationships" xmlns:p="http://schemas.openxmlformats.org/presentationml/2006/main">
+  <p:cSld>
+    <p:spTree>
+      <p:nvGrpSpPr>
+        <p:cNvPr id="1" name=""/>
+        <p:cNvGrpSpPr/>
+        <p:nvPr/>
+      </p:nvGrpSpPr>
+      <p:grpSpPr>
+        <a:xfrm>
+          <a:off x="0" y="0"/>
+          <a:ext cx="0" cy="0"/>
+          <a:chOff x="0" y="0"/>
+          <a:chExt cx="0" cy="0"/>
+        </a:xfrm>
+      </p:grpSpPr>
+      <p:sp>
+        <p:nvSpPr>
+          <p:cNvPr id="2" name="Slide Image Placeholder 1"/>
+          <p:cNvSpPr>
+            <a:spLocks noGrp="1" noRot="1" noChangeAspect="1"/>
+          </p:cNvSpPr>
+          <p:nvPr>
+            <p:ph type="sldImg"/>
+          </p:nvPr>
+        </p:nvSpPr>
+        <p:spPr/>
+      </p:sp>
+      <p:sp>
+        <p:nvSpPr>
+          <p:cNvPr id="3" name="Notes Placeholder 2"/>
+          <p:cNvSpPr>
+            <a:spLocks noGrp="1"/>
+          </p:cNvSpPr>
+          <p:nvPr>
+            <p:ph type="body" idx="1"/>
+          </p:nvPr>
+        </p:nvSpPr>
+        <p:spPr/>
+        <p:txBody>
+          <a:bodyPr/>
+          <a:lstStyle/>
+          <a:p>
+            <a:r>
+              <a:rPr lang="en-US" dirty="0"/>
+              <a:t>Eso es Clancy's Rewards. El próximo paso es terminar la seguridad y subir la app a la nube. Todo el proyecto está en el repositorio de GitHub. Muchas gracias, quedo atento a sus preguntas.</a:t>
+            </a:r>
+            <a:endParaRPr lang="en-US" dirty="0"/>
+          </a:p>
+        </p:txBody>
+      </p:sp>
+      <p:sp>
+        <p:nvSpPr>
+          <p:cNvPr id="4" name="Slide Number Placeholder 3"/>
+          <p:cNvSpPr>
+            <a:spLocks noGrp="1"/>
+          </p:cNvSpPr>
+          <p:nvPr>
+            <p:ph type="sldNum" sz="quarter" idx="10"/>
+          </p:nvPr>
+        </p:nvSpPr>
+        <p:spPr/>
+        <p:txBody>
+          <a:bodyPr/>
+          <a:lstStyle/>
+          <a:p>
+            <a:fld id="{F7021451-1387-4CA6-816F-3879F97B5CBC}" type="slidenum">
+              <a:rPr lang="en-US"/>
+              <a:t>12</a:t>
             </a:fld>
             <a:endParaRPr lang="en-US"/>
           </a:p>
@@ -976,7 +1066,7 @@
           <a:p>
             <a:r>
               <a:rPr lang="en-US" dirty="0"/>
-              <a:t>Estos son los requisitos principales; la matriz completa, con veintiséis requisitos y sus criterios de aceptación, está en Excel en el repositorio. A la izquierda están los funcionales: registro con correo o con Google, la tarjeta de socio, el QR de un solo uso, el escaneo del personal, el canje en dos pasos y la edición del menú, los premios y las promociones. Todos ya funcionan en el prototipo. A la derecha, los no funcionales. La seguridad básica ya está: contraseñas cifradas, permisos por rol y credenciales fuera del código. Lo que falta, como limitar los intentos de login, subir el servidor a la nube y cumplir la ley de datos europea, ya tiene su sprint asignado.</a:t>
+              <a:t>Estos son los requisitos principales; la matriz completa, con veintiocho requisitos y sus criterios de aceptación, está en Excel en el repositorio. A la izquierda, los funcionales: registro, tarjeta de socio, QR de un solo uso, escaneo, canje en dos pasos y edición del menú y los premios. Todos ya funcionan. A la derecha, los no funcionales: la seguridad básica ya está, y lo que falta, como limitar intentos, la nube, la ley de datos europea y la publicación en las dos tiendas, ya tiene su sprint.</a:t>
             </a:r>
             <a:endParaRPr lang="en-US" dirty="0"/>
           </a:p>
@@ -1064,7 +1154,7 @@
           <a:p>
             <a:r>
               <a:rPr lang="en-US" dirty="0"/>
-              <a:t>Trabajo con Scrum, en sprints de dos semanas. Lo elegí porque cada dos semanas tengo algo funcionando para mostrar, recibo feedback de la docente y del local, y si algo cambia, ajusto el sprint siguiente. El orden sigue una regla simple: primero lo que impide publicar. Por eso parto por la seguridad. Después viene la nube, porque Google Play pide catorce días de prueba cerrada y tiene que empezar a tiempo. Después la privacidad y las pruebas, que son requisito antes de abrir la app al público. Y al final, la prueba con el personal y la publicación. Hoy el Sprint 0 está completado y estoy en el Sprint 1. Todo esto está en GitHub: cada sprint es un milestone y cada tarea es un issue.</a:t>
+              <a:t>Trabajo con Scrum, en sprints de dos semanas, porque cada dos semanas tengo algo funcionando para mostrar, recibo feedback y ajusto el sprint siguiente. La regla del orden es simple: primero lo que impide publicar. Por eso parto por la seguridad. Después viene la nube y el build para Android e iPhone, porque Google Play pide catorce días de prueba cerrada y Apple una cuenta verificada. Luego privacidad y pruebas, y al final la publicación. Hoy el Sprint 0 está completado y estoy en el Sprint 1. Todo está en GitHub: cada sprint es un milestone y cada tarea un issue.</a:t>
             </a:r>
             <a:endParaRPr lang="en-US" dirty="0"/>
           </a:p>
@@ -1152,7 +1242,7 @@
           <a:p>
             <a:r>
               <a:rPr lang="en-US" dirty="0"/>
-              <a:t>La arquitectura es cliente-servidor en tres capas. La app está hecha en React Native con Expo, y es la misma app para los tres roles. La app se comunica con una API en Python con FastAPI, que es donde están las reglas: quién puede escanear, si el QR venció o ya se usó, y cuántas visitas lleva cada cliente. Los datos se guardan en MongoDB. Por fuera se conecta con Google para el inicio de sesión y con un servicio de notificaciones. Hoy todo corre en mi computador, y en el Sprint 2 pasa a la nube, con los datos guardados en Europa.</a:t>
+              <a:t>La arquitectura es cliente-servidor en tres capas. La app está hecha en React Native con Expo y es la misma para los tres roles. Se comunica con una API en Python con FastAPI, donde están las reglas: quién puede escanear, si el QR venció o ya se usó, y cuántas visitas lleva cada cliente. Los datos se guardan en MongoDB. Hoy corre en mi computador, y en el Sprint 2 pasa a la nube, con los datos en Europa.</a:t>
             </a:r>
             <a:endParaRPr lang="en-US" dirty="0"/>
           </a:p>
@@ -1240,7 +1330,7 @@
           <a:p>
             <a:r>
               <a:rPr lang="en-US" dirty="0"/>
-              <a:t>Sobre el modelo de negocio. Para el local, la propuesta de valor es cambiar la tarjeta de papel por algo que no se pierde ni se falsifica, y que le muestra quién vuelve. Para el cliente, es recibir premios por volver sin andar con una tarjeta. Quien paga es el local, y quienes la usan son los clientes, los meseros y la administración. Para que sea sostenible, la voy a ofrecer al local con un pago inicial de dos mil quinientos euros para terminarla y publicarla, más una mantención de setenta y cinco a noventa euros por semana. Operarla cuesta poco, porque el servidor y la base de datos parten en planes gratuitos. Y más adelante, el mismo sistema se puede ofrecer a otros bares.</a:t>
+              <a:t>La profesora me hizo ver que publicar solo en Google Play dejaba fuera a mucha gente: en Irlanda, casi la mitad de los teléfonos son iPhone. Por eso la app también se va a publicar en la App Store. Para compilar para iPhone normalmente se necesita un Mac, y no tengo uno. Pero como la app está hecha con Expo, se compila en la nube con EAS Build, se prueba en iPhones reales con TestFlight y después pasa la revisión de Apple. Si aparece un error que solo se arregla con Xcode, arriendo un Mac en la nube por horas. Apple además exige ofrecer inicio de sesión con Apple si hay login con Google, así que lo agregué al Sprint 2. El costo nuevo es la cuenta de Apple, noventa y nueve dólares al año, que entra en el presupuesto inicial.</a:t>
             </a:r>
             <a:endParaRPr lang="en-US" dirty="0"/>
           </a:p>
@@ -1328,7 +1418,7 @@
           <a:p>
             <a:r>
               <a:rPr lang="en-US" dirty="0"/>
-              <a:t>Ahora les muestro las pantallas de la app. Esto es lo que ve el cliente. Primero la bienvenida, donde se registra o entra con Google. Después su tarjeta de socio, con las visitas que lleva y el próximo premio. Cuando llega al local, abre su QR, que dura tres minutos y sirve una sola vez. Y en premios ve todo lo que puede canjear.</a:t>
+              <a:t>Sobre el modelo de negocio. Para el local, la app reemplaza la tarjeta de papel por algo que no se pierde ni se falsifica, y le muestra quién vuelve. Para el cliente, son premios por volver sin andar con una tarjeta. Quien paga es el local. La voy a ofrecer con un pago inicial de dos mil quinientos euros para terminarla y publicarla, más una mantención de setenta y cinco a noventa euros por semana. Ese pago cubre las cuentas de las dos tiendas, y la renovación anual de Apple queda dentro de la mantención.</a:t>
             </a:r>
             <a:endParaRPr lang="en-US" dirty="0"/>
           </a:p>
@@ -1416,7 +1506,7 @@
           <a:p>
             <a:r>
               <a:rPr lang="en-US" dirty="0"/>
-              <a:t>Esta es la parte del personal. El mesero abre el escáner y lee el QR del cliente con la cámara. La visita se suma al instante y la pantalla del cliente cambia sola. Para canjear, el cliente abre un QR de canje; el mesero lo escanea y el premio queda reservado. Cuando lo lleva a la mesa, confirma la entrega. Por eso el canje es en dos pasos.</a:t>
+              <a:t>Ahora les muestro las pantallas de la app. Esto es lo que ve el cliente. Primero la bienvenida, donde se registra o entra con Google. Después su tarjeta de socio, con las visitas que lleva y el próximo premio. Cuando llega al local, abre su QR, que dura tres minutos y sirve una sola vez. Y en premios ve todo lo que puede canjear.</a:t>
             </a:r>
             <a:endParaRPr lang="en-US" dirty="0"/>
           </a:p>
@@ -2669,7 +2759,7 @@
                 <a:ea typeface="Arial" pitchFamily="34" charset="-122"/>
                 <a:cs typeface="Arial" pitchFamily="34" charset="-120"/>
               </a:rPr>
-              <a:t>Mockups de la app: la administración</a:t>
+              <a:t>Mockups de la app: el personal en el local</a:t>
             </a:r>
             <a:endParaRPr lang="en-US" sz="2400" dirty="0"/>
           </a:p>
@@ -2683,109 +2773,7 @@
         </p:nvSpPr>
         <p:spPr>
           <a:xfrm>
-            <a:off x="768096" y="1088136"/>
-            <a:ext cx="1757540" cy="3675888"/>
-          </a:xfrm>
-          <a:prstGeom prst="roundRect">
-            <a:avLst>
-              <a:gd name="adj" fmla="val 7284"/>
-            </a:avLst>
-          </a:prstGeom>
-          <a:solidFill>
-            <a:srgbClr val="3A3A3A"/>
-          </a:solidFill>
-          <a:ln w="12700">
-            <a:solidFill>
-              <a:srgbClr val="3A3A3A"/>
-            </a:solidFill>
-            <a:prstDash val="solid"/>
-          </a:ln>
-        </p:spPr>
-      </p:sp>
-      <p:pic>
-        <p:nvPicPr>
-          <p:cNvPr id="4" name="Image 0" descr="/mnt/user-data/uploads/Capturas_Presentacion/10 - Panel del dueno.jpg">    </p:cNvPr>
-          <p:cNvPicPr>
-            <a:picLocks noChangeAspect="1"/>
-          </p:cNvPicPr>
-          <p:nvPr/>
-        </p:nvPicPr>
-        <p:blipFill>
-          <a:blip r:embed="rId1"/>
-          <a:stretch>
-            <a:fillRect/>
-          </a:stretch>
-        </p:blipFill>
-        <p:spPr>
-          <a:xfrm>
-            <a:off x="822960" y="1143000"/>
-            <a:ext cx="1647812" cy="3566160"/>
-          </a:xfrm>
-          <a:prstGeom prst="rect">
-            <a:avLst/>
-          </a:prstGeom>
-        </p:spPr>
-      </p:pic>
-      <p:sp>
-        <p:nvSpPr>
-          <p:cNvPr id="5" name="Shape 2"/>
-          <p:cNvSpPr/>
-          <p:nvPr/>
-        </p:nvSpPr>
-        <p:spPr>
-          <a:xfrm>
-            <a:off x="2825496" y="1088136"/>
-            <a:ext cx="1757540" cy="3675888"/>
-          </a:xfrm>
-          <a:prstGeom prst="roundRect">
-            <a:avLst>
-              <a:gd name="adj" fmla="val 7284"/>
-            </a:avLst>
-          </a:prstGeom>
-          <a:solidFill>
-            <a:srgbClr val="3A3A3A"/>
-          </a:solidFill>
-          <a:ln w="12700">
-            <a:solidFill>
-              <a:srgbClr val="3A3A3A"/>
-            </a:solidFill>
-            <a:prstDash val="solid"/>
-          </a:ln>
-        </p:spPr>
-      </p:sp>
-      <p:pic>
-        <p:nvPicPr>
-          <p:cNvPr id="6" name="Image 1" descr="/mnt/user-data/uploads/Capturas_Presentacion/09 - Menu de la casa.jpg">    </p:cNvPr>
-          <p:cNvPicPr>
-            <a:picLocks noChangeAspect="1"/>
-          </p:cNvPicPr>
-          <p:nvPr/>
-        </p:nvPicPr>
-        <p:blipFill>
-          <a:blip r:embed="rId2"/>
-          <a:stretch>
-            <a:fillRect/>
-          </a:stretch>
-        </p:blipFill>
-        <p:spPr>
-          <a:xfrm>
-            <a:off x="2880360" y="1143000"/>
-            <a:ext cx="1647812" cy="3566160"/>
-          </a:xfrm>
-          <a:prstGeom prst="rect">
-            <a:avLst/>
-          </a:prstGeom>
-        </p:spPr>
-      </p:pic>
-      <p:sp>
-        <p:nvSpPr>
-          <p:cNvPr id="7" name="Shape 3"/>
-          <p:cNvSpPr/>
-          <p:nvPr/>
-        </p:nvSpPr>
-        <p:spPr>
-          <a:xfrm>
-            <a:off x="768096" y="813816"/>
+            <a:off x="402336" y="813816"/>
             <a:ext cx="1757540" cy="256032"/>
           </a:xfrm>
           <a:prstGeom prst="roundRect">
@@ -2806,13 +2794,13 @@
       </p:sp>
       <p:sp>
         <p:nvSpPr>
-          <p:cNvPr id="8" name="Text 4"/>
-          <p:cNvSpPr txBox="1"/>
-          <p:nvPr/>
-        </p:nvSpPr>
-        <p:spPr>
-          <a:xfrm>
-            <a:off x="768096" y="813816"/>
+          <p:cNvPr id="4" name="Text 2"/>
+          <p:cNvSpPr txBox="1"/>
+          <p:nvPr/>
+        </p:nvSpPr>
+        <p:spPr>
+          <a:xfrm>
+            <a:off x="402336" y="813816"/>
             <a:ext cx="1757540" cy="256032"/>
           </a:xfrm>
           <a:prstGeom prst="rect">
@@ -2834,7 +2822,7 @@
                   <a:srgbClr val="111111"/>
                 </a:solidFill>
               </a:rPr>
-              <a:t>1. Panel del dueño</a:t>
+              <a:t>1. Escáner</a:t>
             </a:r>
             <a:endParaRPr lang="en-US" sz="1100" dirty="0"/>
           </a:p>
@@ -2842,13 +2830,64 @@
       </p:sp>
       <p:sp>
         <p:nvSpPr>
-          <p:cNvPr id="9" name="Shape 5"/>
+          <p:cNvPr id="5" name="Shape 3"/>
           <p:cNvSpPr/>
           <p:nvPr/>
         </p:nvSpPr>
         <p:spPr>
           <a:xfrm>
-            <a:off x="2825496" y="813816"/>
+            <a:off x="402336" y="1088136"/>
+            <a:ext cx="1757540" cy="3675888"/>
+          </a:xfrm>
+          <a:prstGeom prst="roundRect">
+            <a:avLst>
+              <a:gd name="adj" fmla="val 7284"/>
+            </a:avLst>
+          </a:prstGeom>
+          <a:solidFill>
+            <a:srgbClr val="2B2B2B"/>
+          </a:solidFill>
+          <a:ln w="12700">
+            <a:solidFill>
+              <a:srgbClr val="2B2B2B"/>
+            </a:solidFill>
+            <a:prstDash val="solid"/>
+          </a:ln>
+        </p:spPr>
+      </p:sp>
+      <p:pic>
+        <p:nvPicPr>
+          <p:cNvPr id="6" name="Image 0" descr="/mnt/user-data/uploads/Capturas_Presentacion/04 - Escaner del mesero.jpg">    </p:cNvPr>
+          <p:cNvPicPr>
+            <a:picLocks noChangeAspect="1"/>
+          </p:cNvPicPr>
+          <p:nvPr/>
+        </p:nvPicPr>
+        <p:blipFill>
+          <a:blip r:embed="rId1"/>
+          <a:stretch>
+            <a:fillRect/>
+          </a:stretch>
+        </p:blipFill>
+        <p:spPr>
+          <a:xfrm>
+            <a:off x="457200" y="1143000"/>
+            <a:ext cx="1647812" cy="3566160"/>
+          </a:xfrm>
+          <a:prstGeom prst="rect">
+            <a:avLst/>
+          </a:prstGeom>
+        </p:spPr>
+      </p:pic>
+      <p:sp>
+        <p:nvSpPr>
+          <p:cNvPr id="7" name="Shape 4"/>
+          <p:cNvSpPr/>
+          <p:nvPr/>
+        </p:nvSpPr>
+        <p:spPr>
+          <a:xfrm>
+            <a:off x="2596265" y="813816"/>
             <a:ext cx="1757540" cy="256032"/>
           </a:xfrm>
           <a:prstGeom prst="roundRect">
@@ -2869,13 +2908,13 @@
       </p:sp>
       <p:sp>
         <p:nvSpPr>
-          <p:cNvPr id="10" name="Text 6"/>
-          <p:cNvSpPr txBox="1"/>
-          <p:nvPr/>
-        </p:nvSpPr>
-        <p:spPr>
-          <a:xfrm>
-            <a:off x="2825496" y="813816"/>
+          <p:cNvPr id="8" name="Text 5"/>
+          <p:cNvSpPr txBox="1"/>
+          <p:nvPr/>
+        </p:nvSpPr>
+        <p:spPr>
+          <a:xfrm>
+            <a:off x="2596265" y="813816"/>
             <a:ext cx="1757540" cy="256032"/>
           </a:xfrm>
           <a:prstGeom prst="rect">
@@ -2897,7 +2936,7 @@
                   <a:srgbClr val="111111"/>
                 </a:solidFill>
               </a:rPr>
-              <a:t>2. Menú de la casa</a:t>
+              <a:t>2. Visita sumada</a:t>
             </a:r>
             <a:endParaRPr lang="en-US" sz="1100" dirty="0"/>
           </a:p>
@@ -2905,31 +2944,82 @@
       </p:sp>
       <p:sp>
         <p:nvSpPr>
-          <p:cNvPr id="11" name="Shape 7"/>
+          <p:cNvPr id="9" name="Shape 6"/>
           <p:cNvSpPr/>
           <p:nvPr/>
         </p:nvSpPr>
         <p:spPr>
           <a:xfrm>
-            <a:off x="5120640" y="1143000"/>
-            <a:ext cx="3566160" cy="3566160"/>
+            <a:off x="2596265" y="1088136"/>
+            <a:ext cx="1757540" cy="3675888"/>
           </a:xfrm>
           <a:prstGeom prst="roundRect">
             <a:avLst>
-              <a:gd name="adj" fmla="val 2051"/>
+              <a:gd name="adj" fmla="val 7284"/>
             </a:avLst>
           </a:prstGeom>
           <a:solidFill>
-            <a:srgbClr val="1F1F1F"/>
+            <a:srgbClr val="2B2B2B"/>
           </a:solidFill>
           <a:ln w="12700">
             <a:solidFill>
-              <a:srgbClr val="1F1F1F"/>
+              <a:srgbClr val="2B2B2B"/>
             </a:solidFill>
             <a:prstDash val="solid"/>
           </a:ln>
         </p:spPr>
       </p:sp>
+      <p:pic>
+        <p:nvPicPr>
+          <p:cNvPr id="10" name="Image 1" descr="/mnt/user-data/uploads/Capturas_Presentacion/05 - Resultado de visita.jpg">    </p:cNvPr>
+          <p:cNvPicPr>
+            <a:picLocks noChangeAspect="1"/>
+          </p:cNvPicPr>
+          <p:nvPr/>
+        </p:nvPicPr>
+        <p:blipFill>
+          <a:blip r:embed="rId2"/>
+          <a:stretch>
+            <a:fillRect/>
+          </a:stretch>
+        </p:blipFill>
+        <p:spPr>
+          <a:xfrm>
+            <a:off x="2651129" y="1143000"/>
+            <a:ext cx="1647812" cy="3566160"/>
+          </a:xfrm>
+          <a:prstGeom prst="rect">
+            <a:avLst/>
+          </a:prstGeom>
+        </p:spPr>
+      </p:pic>
+      <p:sp>
+        <p:nvSpPr>
+          <p:cNvPr id="11" name="Shape 7"/>
+          <p:cNvSpPr/>
+          <p:nvPr/>
+        </p:nvSpPr>
+        <p:spPr>
+          <a:xfrm>
+            <a:off x="4790195" y="813816"/>
+            <a:ext cx="1757540" cy="256032"/>
+          </a:xfrm>
+          <a:prstGeom prst="roundRect">
+            <a:avLst>
+              <a:gd name="adj" fmla="val 21429"/>
+            </a:avLst>
+          </a:prstGeom>
+          <a:solidFill>
+            <a:srgbClr val="F5C400"/>
+          </a:solidFill>
+          <a:ln w="12700">
+            <a:solidFill>
+              <a:srgbClr val="F5C400"/>
+            </a:solidFill>
+            <a:prstDash val="solid"/>
+          </a:ln>
+        </p:spPr>
+      </p:sp>
       <p:sp>
         <p:nvSpPr>
           <p:cNvPr id="12" name="Text 8"/>
@@ -2938,149 +3028,199 @@
         </p:nvSpPr>
         <p:spPr>
           <a:xfrm>
-            <a:off x="5349240" y="1325880"/>
-            <a:ext cx="3108960" cy="320040"/>
-          </a:xfrm>
-          <a:prstGeom prst="rect">
-            <a:avLst/>
-          </a:prstGeom>
-          <a:noFill/>
-          <a:ln/>
-        </p:spPr>
-        <p:txBody>
-          <a:bodyPr wrap="square" lIns="0" tIns="0" rIns="0" bIns="0" rtlCol="0" anchor="t"/>
-          <a:lstStyle/>
-          <a:p>
-            <a:pPr indent="0" marL="0">
-              <a:buNone/>
-            </a:pPr>
-            <a:r>
-              <a:rPr lang="en-US" sz="1500" b="1" dirty="0">
-                <a:solidFill>
-                  <a:srgbClr val="F5C400"/>
-                </a:solidFill>
-                <a:latin typeface="Arial" pitchFamily="34" charset="0"/>
-                <a:ea typeface="Arial" pitchFamily="34" charset="-122"/>
-                <a:cs typeface="Arial" pitchFamily="34" charset="-120"/>
-              </a:rPr>
-              <a:t>Desde el panel, el local:</a:t>
-            </a:r>
-            <a:endParaRPr lang="en-US" sz="1500" dirty="0"/>
-          </a:p>
-        </p:txBody>
-      </p:sp>
-      <p:sp>
-        <p:nvSpPr>
-          <p:cNvPr id="13" name="Text 9"/>
-          <p:cNvSpPr txBox="1"/>
-          <p:nvPr/>
-        </p:nvSpPr>
-        <p:spPr>
-          <a:xfrm>
-            <a:off x="5349240" y="1783080"/>
-            <a:ext cx="3108960" cy="2743200"/>
-          </a:xfrm>
-          <a:prstGeom prst="rect">
-            <a:avLst/>
-          </a:prstGeom>
-          <a:noFill/>
-          <a:ln/>
-        </p:spPr>
-        <p:txBody>
-          <a:bodyPr wrap="square" lIns="0" tIns="0" rIns="0" bIns="0" rtlCol="0" anchor="t"/>
-          <a:lstStyle/>
-          <a:p>
-            <a:pPr marL="342900" indent="-342900">
-              <a:spcAft>
-                <a:spcPts val="800"/>
-              </a:spcAft>
-              <a:buSzPct val="100000"/>
-              <a:buChar char="•"/>
-            </a:pPr>
-            <a:r>
-              <a:rPr lang="en-US" sz="1400" dirty="0">
-                <a:solidFill>
-                  <a:srgbClr val="FFFFFF"/>
-                </a:solidFill>
-              </a:rPr>
-              <a:t>Ve clientes, socios activos y visitas del día y de la semana.</a:t>
-            </a:r>
-            <a:endParaRPr lang="en-US" sz="1400" dirty="0"/>
-          </a:p>
-          <a:p>
-            <a:pPr marL="342900" indent="-342900">
-              <a:spcAft>
-                <a:spcPts val="800"/>
-              </a:spcAft>
-              <a:buSzPct val="100000"/>
-              <a:buChar char="•"/>
-            </a:pPr>
-            <a:r>
-              <a:rPr lang="en-US" sz="1400" dirty="0">
-                <a:solidFill>
-                  <a:srgbClr val="FFFFFF"/>
-                </a:solidFill>
-              </a:rPr>
-              <a:t>Ve qué premios se canjean más.</a:t>
-            </a:r>
-            <a:endParaRPr lang="en-US" sz="1400" dirty="0"/>
-          </a:p>
-          <a:p>
-            <a:pPr marL="342900" indent="-342900">
-              <a:spcAft>
-                <a:spcPts val="800"/>
-              </a:spcAft>
-              <a:buSzPct val="100000"/>
-              <a:buChar char="•"/>
-            </a:pPr>
-            <a:r>
-              <a:rPr lang="en-US" sz="1400" dirty="0">
-                <a:solidFill>
-                  <a:srgbClr val="FFFFFF"/>
-                </a:solidFill>
-              </a:rPr>
-              <a:t>Edita el menú real del local: 43 platos.</a:t>
-            </a:r>
-            <a:endParaRPr lang="en-US" sz="1400" dirty="0"/>
-          </a:p>
-          <a:p>
-            <a:pPr marL="342900" indent="-342900">
-              <a:spcAft>
-                <a:spcPts val="800"/>
-              </a:spcAft>
-              <a:buSzPct val="100000"/>
-              <a:buChar char="•"/>
-            </a:pPr>
-            <a:r>
-              <a:rPr lang="en-US" sz="1400" dirty="0">
-                <a:solidFill>
-                  <a:srgbClr val="FFFFFF"/>
-                </a:solidFill>
-              </a:rPr>
-              <a:t>Crea premios y promociones sin publicar una nueva versión.</a:t>
-            </a:r>
-            <a:endParaRPr lang="en-US" sz="1400" dirty="0"/>
-          </a:p>
-          <a:p>
-            <a:pPr marL="342900" indent="-342900">
-              <a:spcAft>
-                <a:spcPts val="800"/>
-              </a:spcAft>
-              <a:buSzPct val="100000"/>
-              <a:buChar char="•"/>
-            </a:pPr>
-            <a:r>
-              <a:rPr lang="en-US" sz="1400" dirty="0">
-                <a:solidFill>
-                  <a:srgbClr val="FFFFFF"/>
-                </a:solidFill>
-              </a:rPr>
-              <a:t>Gestiona al personal y sus roles.</a:t>
-            </a:r>
-            <a:endParaRPr lang="en-US" sz="1400" dirty="0"/>
-          </a:p>
-        </p:txBody>
-      </p:sp>
+            <a:off x="4790195" y="813816"/>
+            <a:ext cx="1757540" cy="256032"/>
+          </a:xfrm>
+          <a:prstGeom prst="rect">
+            <a:avLst/>
+          </a:prstGeom>
+          <a:noFill/>
+          <a:ln/>
+        </p:spPr>
+        <p:txBody>
+          <a:bodyPr wrap="square" lIns="0" tIns="0" rIns="0" bIns="0" rtlCol="0" anchor="ctr"/>
+          <a:lstStyle/>
+          <a:p>
+            <a:pPr algn="ctr" indent="0" marL="0">
+              <a:buNone/>
+            </a:pPr>
+            <a:r>
+              <a:rPr lang="en-US" sz="1100" b="1" dirty="0">
+                <a:solidFill>
+                  <a:srgbClr val="111111"/>
+                </a:solidFill>
+              </a:rPr>
+              <a:t>3. QR de canje</a:t>
+            </a:r>
+            <a:endParaRPr lang="en-US" sz="1100" dirty="0"/>
+          </a:p>
+        </p:txBody>
+      </p:sp>
+      <p:sp>
+        <p:nvSpPr>
+          <p:cNvPr id="13" name="Shape 9"/>
+          <p:cNvSpPr/>
+          <p:nvPr/>
+        </p:nvSpPr>
+        <p:spPr>
+          <a:xfrm>
+            <a:off x="4790195" y="1088136"/>
+            <a:ext cx="1757540" cy="3675888"/>
+          </a:xfrm>
+          <a:prstGeom prst="roundRect">
+            <a:avLst>
+              <a:gd name="adj" fmla="val 7284"/>
+            </a:avLst>
+          </a:prstGeom>
+          <a:solidFill>
+            <a:srgbClr val="2B2B2B"/>
+          </a:solidFill>
+          <a:ln w="12700">
+            <a:solidFill>
+              <a:srgbClr val="2B2B2B"/>
+            </a:solidFill>
+            <a:prstDash val="solid"/>
+          </a:ln>
+        </p:spPr>
+      </p:sp>
+      <p:pic>
+        <p:nvPicPr>
+          <p:cNvPr id="14" name="Image 2" descr="/mnt/user-data/uploads/Capturas_Presentacion/07 - QR de canje.jpg">    </p:cNvPr>
+          <p:cNvPicPr>
+            <a:picLocks noChangeAspect="1"/>
+          </p:cNvPicPr>
+          <p:nvPr/>
+        </p:nvPicPr>
+        <p:blipFill>
+          <a:blip r:embed="rId3"/>
+          <a:stretch>
+            <a:fillRect/>
+          </a:stretch>
+        </p:blipFill>
+        <p:spPr>
+          <a:xfrm>
+            <a:off x="4845059" y="1143000"/>
+            <a:ext cx="1647812" cy="3566160"/>
+          </a:xfrm>
+          <a:prstGeom prst="rect">
+            <a:avLst/>
+          </a:prstGeom>
+        </p:spPr>
+      </p:pic>
+      <p:sp>
+        <p:nvSpPr>
+          <p:cNvPr id="15" name="Shape 10"/>
+          <p:cNvSpPr/>
+          <p:nvPr/>
+        </p:nvSpPr>
+        <p:spPr>
+          <a:xfrm>
+            <a:off x="6984124" y="813816"/>
+            <a:ext cx="1757540" cy="256032"/>
+          </a:xfrm>
+          <a:prstGeom prst="roundRect">
+            <a:avLst>
+              <a:gd name="adj" fmla="val 21429"/>
+            </a:avLst>
+          </a:prstGeom>
+          <a:solidFill>
+            <a:srgbClr val="F5C400"/>
+          </a:solidFill>
+          <a:ln w="12700">
+            <a:solidFill>
+              <a:srgbClr val="F5C400"/>
+            </a:solidFill>
+            <a:prstDash val="solid"/>
+          </a:ln>
+        </p:spPr>
+      </p:sp>
+      <p:sp>
+        <p:nvSpPr>
+          <p:cNvPr id="16" name="Text 11"/>
+          <p:cNvSpPr txBox="1"/>
+          <p:nvPr/>
+        </p:nvSpPr>
+        <p:spPr>
+          <a:xfrm>
+            <a:off x="6984124" y="813816"/>
+            <a:ext cx="1757540" cy="256032"/>
+          </a:xfrm>
+          <a:prstGeom prst="rect">
+            <a:avLst/>
+          </a:prstGeom>
+          <a:noFill/>
+          <a:ln/>
+        </p:spPr>
+        <p:txBody>
+          <a:bodyPr wrap="square" lIns="0" tIns="0" rIns="0" bIns="0" rtlCol="0" anchor="ctr"/>
+          <a:lstStyle/>
+          <a:p>
+            <a:pPr algn="ctr" indent="0" marL="0">
+              <a:buNone/>
+            </a:pPr>
+            <a:r>
+              <a:rPr lang="en-US" sz="1100" b="1" dirty="0">
+                <a:solidFill>
+                  <a:srgbClr val="111111"/>
+                </a:solidFill>
+              </a:rPr>
+              <a:t>4. Entregar premio</a:t>
+            </a:r>
+            <a:endParaRPr lang="en-US" sz="1100" dirty="0"/>
+          </a:p>
+        </p:txBody>
+      </p:sp>
+      <p:sp>
+        <p:nvSpPr>
+          <p:cNvPr id="17" name="Shape 12"/>
+          <p:cNvSpPr/>
+          <p:nvPr/>
+        </p:nvSpPr>
+        <p:spPr>
+          <a:xfrm>
+            <a:off x="6984124" y="1088136"/>
+            <a:ext cx="1757540" cy="3675888"/>
+          </a:xfrm>
+          <a:prstGeom prst="roundRect">
+            <a:avLst>
+              <a:gd name="adj" fmla="val 7284"/>
+            </a:avLst>
+          </a:prstGeom>
+          <a:solidFill>
+            <a:srgbClr val="2B2B2B"/>
+          </a:solidFill>
+          <a:ln w="12700">
+            <a:solidFill>
+              <a:srgbClr val="2B2B2B"/>
+            </a:solidFill>
+            <a:prstDash val="solid"/>
+          </a:ln>
+        </p:spPr>
+      </p:sp>
+      <p:pic>
+        <p:nvPicPr>
+          <p:cNvPr id="18" name="Image 3" descr="/mnt/user-data/uploads/Capturas_Presentacion/08 - Canje - entregar al cliente.jpg">    </p:cNvPr>
+          <p:cNvPicPr>
+            <a:picLocks noChangeAspect="1"/>
+          </p:cNvPicPr>
+          <p:nvPr/>
+        </p:nvPicPr>
+        <p:blipFill>
+          <a:blip r:embed="rId4"/>
+          <a:stretch>
+            <a:fillRect/>
+          </a:stretch>
+        </p:blipFill>
+        <p:spPr>
+          <a:xfrm>
+            <a:off x="7038988" y="1143000"/>
+            <a:ext cx="1647812" cy="3566160"/>
+          </a:xfrm>
+          <a:prstGeom prst="rect">
+            <a:avLst/>
+          </a:prstGeom>
+        </p:spPr>
+      </p:pic>
       <p:sp>
         <p:nvSpPr>
           <p:cNvPr id="25" name="Slide Number Placeholder 0"/>
@@ -3161,6 +3301,523 @@
         </p:nvSpPr>
         <p:spPr>
           <a:xfrm>
+            <a:off x="457200" y="201168"/>
+            <a:ext cx="8229600" cy="548640"/>
+          </a:xfrm>
+          <a:prstGeom prst="rect">
+            <a:avLst/>
+          </a:prstGeom>
+          <a:noFill/>
+          <a:ln/>
+        </p:spPr>
+        <p:txBody>
+          <a:bodyPr wrap="square" lIns="0" tIns="0" rIns="0" bIns="0" rtlCol="0" anchor="ctr"/>
+          <a:lstStyle/>
+          <a:p>
+            <a:pPr algn="l" indent="0" marL="0">
+              <a:buNone/>
+            </a:pPr>
+            <a:r>
+              <a:rPr lang="en-US" sz="2400" b="1" dirty="0">
+                <a:solidFill>
+                  <a:srgbClr val="FFFFFF"/>
+                </a:solidFill>
+                <a:latin typeface="Arial" pitchFamily="34" charset="0"/>
+                <a:ea typeface="Arial" pitchFamily="34" charset="-122"/>
+                <a:cs typeface="Arial" pitchFamily="34" charset="-120"/>
+              </a:rPr>
+              <a:t>Mockups de la app: la administración</a:t>
+            </a:r>
+            <a:endParaRPr lang="en-US" sz="2400" dirty="0"/>
+          </a:p>
+        </p:txBody>
+      </p:sp>
+      <p:sp>
+        <p:nvSpPr>
+          <p:cNvPr id="3" name="Shape 1"/>
+          <p:cNvSpPr/>
+          <p:nvPr/>
+        </p:nvSpPr>
+        <p:spPr>
+          <a:xfrm>
+            <a:off x="768096" y="1088136"/>
+            <a:ext cx="1757540" cy="3675888"/>
+          </a:xfrm>
+          <a:prstGeom prst="roundRect">
+            <a:avLst>
+              <a:gd name="adj" fmla="val 7284"/>
+            </a:avLst>
+          </a:prstGeom>
+          <a:solidFill>
+            <a:srgbClr val="3A3A3A"/>
+          </a:solidFill>
+          <a:ln w="12700">
+            <a:solidFill>
+              <a:srgbClr val="3A3A3A"/>
+            </a:solidFill>
+            <a:prstDash val="solid"/>
+          </a:ln>
+        </p:spPr>
+      </p:sp>
+      <p:pic>
+        <p:nvPicPr>
+          <p:cNvPr id="4" name="Image 0" descr="/mnt/user-data/uploads/Capturas_Presentacion/10 - Panel del dueno.jpg">    </p:cNvPr>
+          <p:cNvPicPr>
+            <a:picLocks noChangeAspect="1"/>
+          </p:cNvPicPr>
+          <p:nvPr/>
+        </p:nvPicPr>
+        <p:blipFill>
+          <a:blip r:embed="rId1"/>
+          <a:stretch>
+            <a:fillRect/>
+          </a:stretch>
+        </p:blipFill>
+        <p:spPr>
+          <a:xfrm>
+            <a:off x="822960" y="1143000"/>
+            <a:ext cx="1647812" cy="3566160"/>
+          </a:xfrm>
+          <a:prstGeom prst="rect">
+            <a:avLst/>
+          </a:prstGeom>
+        </p:spPr>
+      </p:pic>
+      <p:sp>
+        <p:nvSpPr>
+          <p:cNvPr id="5" name="Shape 2"/>
+          <p:cNvSpPr/>
+          <p:nvPr/>
+        </p:nvSpPr>
+        <p:spPr>
+          <a:xfrm>
+            <a:off x="2825496" y="1088136"/>
+            <a:ext cx="1757540" cy="3675888"/>
+          </a:xfrm>
+          <a:prstGeom prst="roundRect">
+            <a:avLst>
+              <a:gd name="adj" fmla="val 7284"/>
+            </a:avLst>
+          </a:prstGeom>
+          <a:solidFill>
+            <a:srgbClr val="3A3A3A"/>
+          </a:solidFill>
+          <a:ln w="12700">
+            <a:solidFill>
+              <a:srgbClr val="3A3A3A"/>
+            </a:solidFill>
+            <a:prstDash val="solid"/>
+          </a:ln>
+        </p:spPr>
+      </p:sp>
+      <p:pic>
+        <p:nvPicPr>
+          <p:cNvPr id="6" name="Image 1" descr="/mnt/user-data/uploads/Capturas_Presentacion/09 - Menu de la casa.jpg">    </p:cNvPr>
+          <p:cNvPicPr>
+            <a:picLocks noChangeAspect="1"/>
+          </p:cNvPicPr>
+          <p:nvPr/>
+        </p:nvPicPr>
+        <p:blipFill>
+          <a:blip r:embed="rId2"/>
+          <a:stretch>
+            <a:fillRect/>
+          </a:stretch>
+        </p:blipFill>
+        <p:spPr>
+          <a:xfrm>
+            <a:off x="2880360" y="1143000"/>
+            <a:ext cx="1647812" cy="3566160"/>
+          </a:xfrm>
+          <a:prstGeom prst="rect">
+            <a:avLst/>
+          </a:prstGeom>
+        </p:spPr>
+      </p:pic>
+      <p:sp>
+        <p:nvSpPr>
+          <p:cNvPr id="7" name="Shape 3"/>
+          <p:cNvSpPr/>
+          <p:nvPr/>
+        </p:nvSpPr>
+        <p:spPr>
+          <a:xfrm>
+            <a:off x="768096" y="813816"/>
+            <a:ext cx="1757540" cy="256032"/>
+          </a:xfrm>
+          <a:prstGeom prst="roundRect">
+            <a:avLst>
+              <a:gd name="adj" fmla="val 21429"/>
+            </a:avLst>
+          </a:prstGeom>
+          <a:solidFill>
+            <a:srgbClr val="F5C400"/>
+          </a:solidFill>
+          <a:ln w="12700">
+            <a:solidFill>
+              <a:srgbClr val="F5C400"/>
+            </a:solidFill>
+            <a:prstDash val="solid"/>
+          </a:ln>
+        </p:spPr>
+      </p:sp>
+      <p:sp>
+        <p:nvSpPr>
+          <p:cNvPr id="8" name="Text 4"/>
+          <p:cNvSpPr txBox="1"/>
+          <p:nvPr/>
+        </p:nvSpPr>
+        <p:spPr>
+          <a:xfrm>
+            <a:off x="768096" y="813816"/>
+            <a:ext cx="1757540" cy="256032"/>
+          </a:xfrm>
+          <a:prstGeom prst="rect">
+            <a:avLst/>
+          </a:prstGeom>
+          <a:noFill/>
+          <a:ln/>
+        </p:spPr>
+        <p:txBody>
+          <a:bodyPr wrap="square" lIns="0" tIns="0" rIns="0" bIns="0" rtlCol="0" anchor="ctr"/>
+          <a:lstStyle/>
+          <a:p>
+            <a:pPr algn="ctr" indent="0" marL="0">
+              <a:buNone/>
+            </a:pPr>
+            <a:r>
+              <a:rPr lang="en-US" sz="1100" b="1" dirty="0">
+                <a:solidFill>
+                  <a:srgbClr val="111111"/>
+                </a:solidFill>
+              </a:rPr>
+              <a:t>1. Panel del dueño</a:t>
+            </a:r>
+            <a:endParaRPr lang="en-US" sz="1100" dirty="0"/>
+          </a:p>
+        </p:txBody>
+      </p:sp>
+      <p:sp>
+        <p:nvSpPr>
+          <p:cNvPr id="9" name="Shape 5"/>
+          <p:cNvSpPr/>
+          <p:nvPr/>
+        </p:nvSpPr>
+        <p:spPr>
+          <a:xfrm>
+            <a:off x="2825496" y="813816"/>
+            <a:ext cx="1757540" cy="256032"/>
+          </a:xfrm>
+          <a:prstGeom prst="roundRect">
+            <a:avLst>
+              <a:gd name="adj" fmla="val 21429"/>
+            </a:avLst>
+          </a:prstGeom>
+          <a:solidFill>
+            <a:srgbClr val="F5C400"/>
+          </a:solidFill>
+          <a:ln w="12700">
+            <a:solidFill>
+              <a:srgbClr val="F5C400"/>
+            </a:solidFill>
+            <a:prstDash val="solid"/>
+          </a:ln>
+        </p:spPr>
+      </p:sp>
+      <p:sp>
+        <p:nvSpPr>
+          <p:cNvPr id="10" name="Text 6"/>
+          <p:cNvSpPr txBox="1"/>
+          <p:nvPr/>
+        </p:nvSpPr>
+        <p:spPr>
+          <a:xfrm>
+            <a:off x="2825496" y="813816"/>
+            <a:ext cx="1757540" cy="256032"/>
+          </a:xfrm>
+          <a:prstGeom prst="rect">
+            <a:avLst/>
+          </a:prstGeom>
+          <a:noFill/>
+          <a:ln/>
+        </p:spPr>
+        <p:txBody>
+          <a:bodyPr wrap="square" lIns="0" tIns="0" rIns="0" bIns="0" rtlCol="0" anchor="ctr"/>
+          <a:lstStyle/>
+          <a:p>
+            <a:pPr algn="ctr" indent="0" marL="0">
+              <a:buNone/>
+            </a:pPr>
+            <a:r>
+              <a:rPr lang="en-US" sz="1100" b="1" dirty="0">
+                <a:solidFill>
+                  <a:srgbClr val="111111"/>
+                </a:solidFill>
+              </a:rPr>
+              <a:t>2. Menú de la casa</a:t>
+            </a:r>
+            <a:endParaRPr lang="en-US" sz="1100" dirty="0"/>
+          </a:p>
+        </p:txBody>
+      </p:sp>
+      <p:sp>
+        <p:nvSpPr>
+          <p:cNvPr id="11" name="Shape 7"/>
+          <p:cNvSpPr/>
+          <p:nvPr/>
+        </p:nvSpPr>
+        <p:spPr>
+          <a:xfrm>
+            <a:off x="5120640" y="1143000"/>
+            <a:ext cx="3566160" cy="3566160"/>
+          </a:xfrm>
+          <a:prstGeom prst="roundRect">
+            <a:avLst>
+              <a:gd name="adj" fmla="val 2051"/>
+            </a:avLst>
+          </a:prstGeom>
+          <a:solidFill>
+            <a:srgbClr val="1F1F1F"/>
+          </a:solidFill>
+          <a:ln w="12700">
+            <a:solidFill>
+              <a:srgbClr val="1F1F1F"/>
+            </a:solidFill>
+            <a:prstDash val="solid"/>
+          </a:ln>
+        </p:spPr>
+      </p:sp>
+      <p:sp>
+        <p:nvSpPr>
+          <p:cNvPr id="12" name="Text 8"/>
+          <p:cNvSpPr txBox="1"/>
+          <p:nvPr/>
+        </p:nvSpPr>
+        <p:spPr>
+          <a:xfrm>
+            <a:off x="5349240" y="1325880"/>
+            <a:ext cx="3108960" cy="320040"/>
+          </a:xfrm>
+          <a:prstGeom prst="rect">
+            <a:avLst/>
+          </a:prstGeom>
+          <a:noFill/>
+          <a:ln/>
+        </p:spPr>
+        <p:txBody>
+          <a:bodyPr wrap="square" lIns="0" tIns="0" rIns="0" bIns="0" rtlCol="0" anchor="t"/>
+          <a:lstStyle/>
+          <a:p>
+            <a:pPr indent="0" marL="0">
+              <a:buNone/>
+            </a:pPr>
+            <a:r>
+              <a:rPr lang="en-US" sz="1500" b="1" dirty="0">
+                <a:solidFill>
+                  <a:srgbClr val="F5C400"/>
+                </a:solidFill>
+                <a:latin typeface="Arial" pitchFamily="34" charset="0"/>
+                <a:ea typeface="Arial" pitchFamily="34" charset="-122"/>
+                <a:cs typeface="Arial" pitchFamily="34" charset="-120"/>
+              </a:rPr>
+              <a:t>Desde el panel, el local:</a:t>
+            </a:r>
+            <a:endParaRPr lang="en-US" sz="1500" dirty="0"/>
+          </a:p>
+        </p:txBody>
+      </p:sp>
+      <p:sp>
+        <p:nvSpPr>
+          <p:cNvPr id="13" name="Text 9"/>
+          <p:cNvSpPr txBox="1"/>
+          <p:nvPr/>
+        </p:nvSpPr>
+        <p:spPr>
+          <a:xfrm>
+            <a:off x="5349240" y="1783080"/>
+            <a:ext cx="3108960" cy="2743200"/>
+          </a:xfrm>
+          <a:prstGeom prst="rect">
+            <a:avLst/>
+          </a:prstGeom>
+          <a:noFill/>
+          <a:ln/>
+        </p:spPr>
+        <p:txBody>
+          <a:bodyPr wrap="square" lIns="0" tIns="0" rIns="0" bIns="0" rtlCol="0" anchor="t"/>
+          <a:lstStyle/>
+          <a:p>
+            <a:pPr marL="342900" indent="-342900">
+              <a:spcAft>
+                <a:spcPts val="800"/>
+              </a:spcAft>
+              <a:buSzPct val="100000"/>
+              <a:buChar char="•"/>
+            </a:pPr>
+            <a:r>
+              <a:rPr lang="en-US" sz="1400" dirty="0">
+                <a:solidFill>
+                  <a:srgbClr val="FFFFFF"/>
+                </a:solidFill>
+              </a:rPr>
+              <a:t>Ve clientes, socios activos y visitas del día y de la semana.</a:t>
+            </a:r>
+            <a:endParaRPr lang="en-US" sz="1400" dirty="0"/>
+          </a:p>
+          <a:p>
+            <a:pPr marL="342900" indent="-342900">
+              <a:spcAft>
+                <a:spcPts val="800"/>
+              </a:spcAft>
+              <a:buSzPct val="100000"/>
+              <a:buChar char="•"/>
+            </a:pPr>
+            <a:r>
+              <a:rPr lang="en-US" sz="1400" dirty="0">
+                <a:solidFill>
+                  <a:srgbClr val="FFFFFF"/>
+                </a:solidFill>
+              </a:rPr>
+              <a:t>Ve qué premios se canjean más.</a:t>
+            </a:r>
+            <a:endParaRPr lang="en-US" sz="1400" dirty="0"/>
+          </a:p>
+          <a:p>
+            <a:pPr marL="342900" indent="-342900">
+              <a:spcAft>
+                <a:spcPts val="800"/>
+              </a:spcAft>
+              <a:buSzPct val="100000"/>
+              <a:buChar char="•"/>
+            </a:pPr>
+            <a:r>
+              <a:rPr lang="en-US" sz="1400" dirty="0">
+                <a:solidFill>
+                  <a:srgbClr val="FFFFFF"/>
+                </a:solidFill>
+              </a:rPr>
+              <a:t>Edita el menú real del local: 43 platos.</a:t>
+            </a:r>
+            <a:endParaRPr lang="en-US" sz="1400" dirty="0"/>
+          </a:p>
+          <a:p>
+            <a:pPr marL="342900" indent="-342900">
+              <a:spcAft>
+                <a:spcPts val="800"/>
+              </a:spcAft>
+              <a:buSzPct val="100000"/>
+              <a:buChar char="•"/>
+            </a:pPr>
+            <a:r>
+              <a:rPr lang="en-US" sz="1400" dirty="0">
+                <a:solidFill>
+                  <a:srgbClr val="FFFFFF"/>
+                </a:solidFill>
+              </a:rPr>
+              <a:t>Crea premios y promociones sin publicar una nueva versión.</a:t>
+            </a:r>
+            <a:endParaRPr lang="en-US" sz="1400" dirty="0"/>
+          </a:p>
+          <a:p>
+            <a:pPr marL="342900" indent="-342900">
+              <a:spcAft>
+                <a:spcPts val="800"/>
+              </a:spcAft>
+              <a:buSzPct val="100000"/>
+              <a:buChar char="•"/>
+            </a:pPr>
+            <a:r>
+              <a:rPr lang="en-US" sz="1400" dirty="0">
+                <a:solidFill>
+                  <a:srgbClr val="FFFFFF"/>
+                </a:solidFill>
+              </a:rPr>
+              <a:t>Gestiona al personal y sus roles.</a:t>
+            </a:r>
+            <a:endParaRPr lang="en-US" sz="1400" dirty="0"/>
+          </a:p>
+        </p:txBody>
+      </p:sp>
+      <p:sp>
+        <p:nvSpPr>
+          <p:cNvPr id="25" name="Slide Number Placeholder 0"/>
+          <p:cNvSpPr>
+            <a:spLocks noGrp="1"/>
+          </p:cNvSpPr>
+          <p:nvPr>
+            <p:ph type="sldNum" sz="quarter" idx="4294967295"/>
+          </p:nvPr>
+        </p:nvSpPr>
+        <p:spPr>
+          <a:xfrm>
+            <a:off x="8229600" y="4800600"/>
+            <a:ext cx="457200" cy="228600"/>
+          </a:xfrm>
+          <a:prstGeom prst="rect">
+            <a:avLst/>
+          </a:prstGeom>
+          <a:extLst>
+            <a:ext uri="{C572A759-6A51-4108-AA02-DFA0A04FC94B}">
+              <ma14:wrappingTextBoxFlag xmlns:ma14="http://schemas.microsoft.com/office/mac/drawingml/2011/main" val="0"/>
+            </a:ext>
+          </a:extLst>
+        </p:spPr>
+        <p:txBody>
+          <a:bodyPr/>
+          <a:lstStyle>
+            <a:lvl1pPr>
+              <a:defRPr sz="1000">
+                <a:solidFill>
+                  <a:srgbClr val="A6A6A6"/>
+                </a:solidFill>
+              </a:defRPr>
+            </a:lvl1pPr>
+          </a:lstStyle>
+          <a:p>
+            <a:pPr algn="r"/>
+            <a:fld id="{F7021451-1387-4CA6-816F-3879F97B5CBC}" type="slidenum">
+              <a:rPr b="0" lang="en-US"/>
+              <a:t>11</a:t>
+            </a:fld>
+            <a:endParaRPr lang="en-US"/>
+          </a:p>
+        </p:txBody>
+      </p:sp>
+    </p:spTree>
+  </p:cSld>
+  <p:clrMapOvr>
+    <a:masterClrMapping/>
+  </p:clrMapOvr>
+</p:sld>
+</file>
+
+<file path=ppt/slides/slide12.xml><?xml version="1.0" encoding="utf-8"?>
+<p:sld xmlns:a="http://schemas.openxmlformats.org/drawingml/2006/main" xmlns:r="http://schemas.openxmlformats.org/officeDocument/2006/relationships" xmlns:p="http://schemas.openxmlformats.org/presentationml/2006/main">
+  <p:cSld name="Slide 12">
+    <p:spTree>
+      <p:nvGrpSpPr>
+        <p:cNvPr id="1" name=""/>
+        <p:cNvGrpSpPr/>
+        <p:nvPr/>
+      </p:nvGrpSpPr>
+      <p:grpSpPr>
+        <a:xfrm>
+          <a:off x="0" y="0"/>
+          <a:ext cx="0" cy="0"/>
+          <a:chOff x="0" y="0"/>
+          <a:chExt cx="0" cy="0"/>
+        </a:xfrm>
+      </p:grpSpPr>
+      <p:sp>
+        <p:nvSpPr>
+          <p:cNvPr id="2" name="Text 0"/>
+          <p:cNvSpPr/>
+          <p:nvPr>
+            <p:ph idx="100" type="title" hasCustomPrompt="1"/>
+          </p:nvPr>
+        </p:nvSpPr>
+        <p:spPr>
+          <a:xfrm>
             <a:off x="548640" y="1417320"/>
             <a:ext cx="4480560" cy="1188720"/>
           </a:xfrm>
@@ -6696,7 +7353,7 @@
                   <a:srgbClr val="111111"/>
                 </a:solidFill>
               </a:rPr>
-              <a:t>RNF-11</a:t>
+              <a:t>RNF-09</a:t>
             </a:r>
             <a:endParaRPr lang="en-US" sz="1200" dirty="0"/>
           </a:p>
@@ -6732,7 +7389,7 @@
                   <a:srgbClr val="111111"/>
                 </a:solidFill>
               </a:rPr>
-              <a:t>Calidad: pruebas automáticas y con usuarios</a:t>
+              <a:t>Publicación en Google Play y App Store</a:t>
             </a:r>
             <a:endParaRPr lang="en-US" sz="1200" dirty="0"/>
           </a:p>
@@ -6795,7 +7452,7 @@
                   <a:srgbClr val="111111"/>
                 </a:solidFill>
               </a:rPr>
-              <a:t>Sprint 3</a:t>
+              <a:t>Sprint 2</a:t>
             </a:r>
             <a:endParaRPr lang="en-US" sz="1000" dirty="0"/>
           </a:p>
@@ -6831,7 +7488,7 @@
                   <a:srgbClr val="6B6B6B"/>
                 </a:solidFill>
               </a:rPr>
-              <a:t>Matriz completa con 26 requisitos, criterios de aceptación y estado: Matriz_de_Requisitos.xlsx en el repositorio.</a:t>
+              <a:t>Matriz completa con 28 requisitos, criterios de aceptación y estado: Matriz_de_Requisitos.xlsx en el repositorio.</a:t>
             </a:r>
             <a:endParaRPr lang="en-US" sz="1100" dirty="0"/>
           </a:p>
@@ -7393,7 +8050,7 @@
                   <a:srgbClr val="111111"/>
                 </a:solidFill>
               </a:rPr>
-              <a:t>Nube</a:t>
+              <a:t>Nube: Android e iOS</a:t>
             </a:r>
             <a:endParaRPr lang="en-US" sz="1300" dirty="0"/>
           </a:p>
@@ -7429,7 +8086,7 @@
                   <a:srgbClr val="111111"/>
                 </a:solidFill>
               </a:rPr>
-              <a:t>Google Play pide 14 días de prueba cerrada antes de publicar, así que debe partir a tiempo.</a:t>
+              <a:t>Google Play pide 14 días de prueba cerrada y Apple una cuenta verificada: deben partir a tiempo.</a:t>
             </a:r>
             <a:endParaRPr lang="en-US" sz="1100" dirty="0"/>
           </a:p>
@@ -7699,7 +8356,7 @@
                   <a:srgbClr val="111111"/>
                 </a:solidFill>
               </a:rPr>
-              <a:t>Prueba con el personal del local y publicación en Google Play.</a:t>
+              <a:t>Prueba con el personal y publicación en Google Play y App Store.</a:t>
             </a:r>
             <a:endParaRPr lang="en-US" sz="1100" dirty="0"/>
           </a:p>
@@ -9062,7 +9719,7 @@
                 <a:ea typeface="Arial" pitchFamily="34" charset="-122"/>
                 <a:cs typeface="Arial" pitchFamily="34" charset="-120"/>
               </a:rPr>
-              <a:t>Modelo de negocio: pago inicial y mantención</a:t>
+              <a:t>Lanzamiento en Android e iOS, sin Mac</a:t>
             </a:r>
             <a:endParaRPr lang="en-US" sz="2600" dirty="0"/>
           </a:p>
@@ -9077,11 +9734,149 @@
         <p:spPr>
           <a:xfrm>
             <a:off x="457200" y="1051560"/>
-            <a:ext cx="2606040" cy="3520440"/>
+            <a:ext cx="2560320" cy="3520440"/>
           </a:xfrm>
           <a:prstGeom prst="roundRect">
             <a:avLst>
-              <a:gd name="adj" fmla="val 2807"/>
+              <a:gd name="adj" fmla="val 2857"/>
+            </a:avLst>
+          </a:prstGeom>
+          <a:solidFill>
+            <a:srgbClr val="111111"/>
+          </a:solidFill>
+          <a:ln w="12700">
+            <a:solidFill>
+              <a:srgbClr val="111111"/>
+            </a:solidFill>
+            <a:prstDash val="solid"/>
+          </a:ln>
+        </p:spPr>
+      </p:sp>
+      <p:sp>
+        <p:nvSpPr>
+          <p:cNvPr id="4" name="Text 2"/>
+          <p:cNvSpPr txBox="1"/>
+          <p:nvPr/>
+        </p:nvSpPr>
+        <p:spPr>
+          <a:xfrm>
+            <a:off x="685800" y="1234440"/>
+            <a:ext cx="2194560" cy="822960"/>
+          </a:xfrm>
+          <a:prstGeom prst="rect">
+            <a:avLst/>
+          </a:prstGeom>
+          <a:noFill/>
+          <a:ln/>
+        </p:spPr>
+        <p:txBody>
+          <a:bodyPr wrap="square" lIns="0" tIns="0" rIns="0" bIns="0" rtlCol="0" anchor="t"/>
+          <a:lstStyle/>
+          <a:p>
+            <a:pPr indent="0" marL="0">
+              <a:buNone/>
+            </a:pPr>
+            <a:r>
+              <a:rPr lang="en-US" sz="4800" b="1" dirty="0">
+                <a:solidFill>
+                  <a:srgbClr val="F5C400"/>
+                </a:solidFill>
+                <a:latin typeface="Arial" pitchFamily="34" charset="0"/>
+                <a:ea typeface="Arial" pitchFamily="34" charset="-122"/>
+                <a:cs typeface="Arial" pitchFamily="34" charset="-120"/>
+              </a:rPr>
+              <a:t>47 %</a:t>
+            </a:r>
+            <a:endParaRPr lang="en-US" sz="4800" dirty="0"/>
+          </a:p>
+        </p:txBody>
+      </p:sp>
+      <p:sp>
+        <p:nvSpPr>
+          <p:cNvPr id="5" name="Text 3"/>
+          <p:cNvSpPr txBox="1"/>
+          <p:nvPr/>
+        </p:nvSpPr>
+        <p:spPr>
+          <a:xfrm>
+            <a:off x="685800" y="2103120"/>
+            <a:ext cx="2148840" cy="822960"/>
+          </a:xfrm>
+          <a:prstGeom prst="rect">
+            <a:avLst/>
+          </a:prstGeom>
+          <a:noFill/>
+          <a:ln/>
+        </p:spPr>
+        <p:txBody>
+          <a:bodyPr wrap="square" lIns="0" tIns="0" rIns="0" bIns="0" rtlCol="0" anchor="t"/>
+          <a:lstStyle/>
+          <a:p>
+            <a:pPr indent="0" marL="0">
+              <a:buNone/>
+            </a:pPr>
+            <a:r>
+              <a:rPr lang="en-US" sz="1400" dirty="0">
+                <a:solidFill>
+                  <a:srgbClr val="FFFFFF"/>
+                </a:solidFill>
+              </a:rPr>
+              <a:t>de los teléfonos en Irlanda usa iOS (StatCounter, septiembre de 2026).</a:t>
+            </a:r>
+            <a:endParaRPr lang="en-US" sz="1400" dirty="0"/>
+          </a:p>
+        </p:txBody>
+      </p:sp>
+      <p:sp>
+        <p:nvSpPr>
+          <p:cNvPr id="6" name="Text 4"/>
+          <p:cNvSpPr txBox="1"/>
+          <p:nvPr/>
+        </p:nvSpPr>
+        <p:spPr>
+          <a:xfrm>
+            <a:off x="685800" y="3108960"/>
+            <a:ext cx="2148840" cy="1188720"/>
+          </a:xfrm>
+          <a:prstGeom prst="rect">
+            <a:avLst/>
+          </a:prstGeom>
+          <a:noFill/>
+          <a:ln/>
+        </p:spPr>
+        <p:txBody>
+          <a:bodyPr wrap="square" lIns="0" tIns="0" rIns="0" bIns="0" rtlCol="0" anchor="t"/>
+          <a:lstStyle/>
+          <a:p>
+            <a:pPr indent="0" marL="0">
+              <a:buNone/>
+            </a:pPr>
+            <a:r>
+              <a:rPr lang="en-US" sz="1300" dirty="0">
+                <a:solidFill>
+                  <a:srgbClr val="FFFFFF"/>
+                </a:solidFill>
+              </a:rPr>
+              <a:t>Por la retroalimentación de la Fase 1, la app se publica en Google Play y en App Store.</a:t>
+            </a:r>
+            <a:endParaRPr lang="en-US" sz="1300" dirty="0"/>
+          </a:p>
+        </p:txBody>
+      </p:sp>
+      <p:sp>
+        <p:nvSpPr>
+          <p:cNvPr id="7" name="Shape 5"/>
+          <p:cNvSpPr/>
+          <p:nvPr/>
+        </p:nvSpPr>
+        <p:spPr>
+          <a:xfrm>
+            <a:off x="3291840" y="1051560"/>
+            <a:ext cx="1188720" cy="1188720"/>
+          </a:xfrm>
+          <a:prstGeom prst="roundRect">
+            <a:avLst>
+              <a:gd name="adj" fmla="val 6154"/>
             </a:avLst>
           </a:prstGeom>
           <a:solidFill>
@@ -9097,63 +9892,39 @@
       </p:sp>
       <p:sp>
         <p:nvSpPr>
-          <p:cNvPr id="4" name="Shape 2"/>
+          <p:cNvPr id="8" name="Shape 6"/>
           <p:cNvSpPr/>
           <p:nvPr/>
         </p:nvSpPr>
         <p:spPr>
           <a:xfrm>
-            <a:off x="658368" y="1207008"/>
-            <a:ext cx="457200" cy="457200"/>
+            <a:off x="3401568" y="1143000"/>
+            <a:ext cx="329184" cy="329184"/>
           </a:xfrm>
           <a:prstGeom prst="ellipse">
             <a:avLst/>
           </a:prstGeom>
           <a:solidFill>
-            <a:srgbClr val="111111"/>
+            <a:srgbClr val="F5C400"/>
           </a:solidFill>
           <a:ln w="12700">
             <a:solidFill>
-              <a:srgbClr val="111111"/>
+              <a:srgbClr val="F5C400"/>
             </a:solidFill>
             <a:prstDash val="solid"/>
           </a:ln>
         </p:spPr>
       </p:sp>
-      <p:pic>
-        <p:nvPicPr>
-          <p:cNvPr id="5" name="Image 0" descr="preencoded.png">    </p:cNvPr>
-          <p:cNvPicPr>
-            <a:picLocks noChangeAspect="1"/>
-          </p:cNvPicPr>
-          <p:nvPr/>
-        </p:nvPicPr>
-        <p:blipFill>
-          <a:blip r:embed="rId1"/>
-          <a:stretch>
-            <a:fillRect/>
-          </a:stretch>
-        </p:blipFill>
-        <p:spPr>
-          <a:xfrm>
-            <a:off x="772668" y="1321308"/>
-            <a:ext cx="228600" cy="228600"/>
-          </a:xfrm>
-          <a:prstGeom prst="rect">
-            <a:avLst/>
-          </a:prstGeom>
-        </p:spPr>
-      </p:pic>
-      <p:sp>
-        <p:nvSpPr>
-          <p:cNvPr id="6" name="Text 3"/>
-          <p:cNvSpPr txBox="1"/>
-          <p:nvPr/>
-        </p:nvSpPr>
-        <p:spPr>
-          <a:xfrm>
-            <a:off x="1234440" y="1207008"/>
-            <a:ext cx="1737360" cy="457200"/>
+      <p:sp>
+        <p:nvSpPr>
+          <p:cNvPr id="9" name="Text 7"/>
+          <p:cNvSpPr txBox="1"/>
+          <p:nvPr/>
+        </p:nvSpPr>
+        <p:spPr>
+          <a:xfrm>
+            <a:off x="3401568" y="1143000"/>
+            <a:ext cx="329184" cy="329184"/>
           </a:xfrm>
           <a:prstGeom prst="rect">
             <a:avLst/>
@@ -9165,153 +9936,96 @@
           <a:bodyPr wrap="square" lIns="0" tIns="0" rIns="0" bIns="0" rtlCol="0" anchor="ctr"/>
           <a:lstStyle/>
           <a:p>
+            <a:pPr algn="ctr" indent="0" marL="0">
+              <a:buNone/>
+            </a:pPr>
+            <a:r>
+              <a:rPr lang="en-US" sz="1300" b="1" dirty="0">
+                <a:solidFill>
+                  <a:srgbClr val="111111"/>
+                </a:solidFill>
+              </a:rPr>
+              <a:t>1</a:t>
+            </a:r>
+            <a:endParaRPr lang="en-US" sz="1300" dirty="0"/>
+          </a:p>
+        </p:txBody>
+      </p:sp>
+      <p:sp>
+        <p:nvSpPr>
+          <p:cNvPr id="10" name="Text 8"/>
+          <p:cNvSpPr txBox="1"/>
+          <p:nvPr/>
+        </p:nvSpPr>
+        <p:spPr>
+          <a:xfrm>
+            <a:off x="3401568" y="1536192"/>
+            <a:ext cx="1005840" cy="658368"/>
+          </a:xfrm>
+          <a:prstGeom prst="rect">
+            <a:avLst/>
+          </a:prstGeom>
+          <a:noFill/>
+          <a:ln/>
+        </p:spPr>
+        <p:txBody>
+          <a:bodyPr wrap="square" lIns="0" tIns="0" rIns="0" bIns="0" rtlCol="0" anchor="t"/>
+          <a:lstStyle/>
+          <a:p>
             <a:pPr indent="0" marL="0">
               <a:buNone/>
             </a:pPr>
             <a:r>
-              <a:rPr lang="en-US" sz="1500" b="1" dirty="0">
+              <a:rPr lang="en-US" sz="1200" b="1" dirty="0">
                 <a:solidFill>
                   <a:srgbClr val="111111"/>
                 </a:solidFill>
-                <a:latin typeface="Arial" pitchFamily="34" charset="0"/>
-                <a:ea typeface="Arial" pitchFamily="34" charset="-122"/>
-                <a:cs typeface="Arial" pitchFamily="34" charset="-120"/>
-              </a:rPr>
-              <a:t>Propuesta de valor</a:t>
-            </a:r>
-            <a:endParaRPr lang="en-US" sz="1500" dirty="0"/>
-          </a:p>
-        </p:txBody>
-      </p:sp>
-      <p:sp>
-        <p:nvSpPr>
-          <p:cNvPr id="7" name="Text 4"/>
-          <p:cNvSpPr txBox="1"/>
-          <p:nvPr/>
-        </p:nvSpPr>
-        <p:spPr>
-          <a:xfrm>
-            <a:off x="658368" y="1874520"/>
-            <a:ext cx="2240280" cy="2606040"/>
-          </a:xfrm>
-          <a:prstGeom prst="rect">
-            <a:avLst/>
-          </a:prstGeom>
-          <a:noFill/>
-          <a:ln/>
-        </p:spPr>
-        <p:txBody>
-          <a:bodyPr wrap="square" lIns="0" tIns="0" rIns="0" bIns="0" rtlCol="0" anchor="t"/>
-          <a:lstStyle/>
-          <a:p>
-            <a:pPr indent="0" marL="0">
-              <a:spcAft>
-                <a:spcPts val="1200"/>
-              </a:spcAft>
-              <a:buNone/>
-            </a:pPr>
-            <a:r>
-              <a:rPr lang="en-US" sz="1400" b="1" dirty="0">
-                <a:solidFill>
-                  <a:srgbClr val="111111"/>
-                </a:solidFill>
-              </a:rPr>
-              <a:t>Para el local: </a:t>
-            </a:r>
-            <a:pPr indent="0" marL="0">
-              <a:spcAft>
-                <a:spcPts val="1200"/>
-              </a:spcAft>
-              <a:buNone/>
-            </a:pPr>
-            <a:r>
-              <a:rPr lang="en-US" sz="1400" dirty="0">
-                <a:solidFill>
-                  <a:srgbClr val="111111"/>
-                </a:solidFill>
-              </a:rPr>
-              <a:t>reemplaza la tarjeta de papel y evita sellos falsos.</a:t>
-            </a:r>
-            <a:endParaRPr lang="en-US" sz="1400" dirty="0"/>
-          </a:p>
-          <a:p>
-            <a:pPr indent="0" marL="0">
-              <a:spcAft>
-                <a:spcPts val="1200"/>
-              </a:spcAft>
-              <a:buNone/>
-            </a:pPr>
-            <a:r>
-              <a:rPr lang="en-US" sz="1400" b="1" dirty="0">
-                <a:solidFill>
-                  <a:srgbClr val="111111"/>
-                </a:solidFill>
-              </a:rPr>
-              <a:t>Para el local: </a:t>
-            </a:r>
-            <a:pPr indent="0" marL="0">
-              <a:spcAft>
-                <a:spcPts val="1200"/>
-              </a:spcAft>
-              <a:buNone/>
-            </a:pPr>
-            <a:r>
-              <a:rPr lang="en-US" sz="1400" dirty="0">
-                <a:solidFill>
-                  <a:srgbClr val="111111"/>
-                </a:solidFill>
-              </a:rPr>
-              <a:t>muestra quién vuelve y qué premio funciona.</a:t>
-            </a:r>
-            <a:endParaRPr lang="en-US" sz="1400" dirty="0"/>
-          </a:p>
-          <a:p>
-            <a:pPr indent="0" marL="0">
-              <a:spcAft>
-                <a:spcPts val="1200"/>
-              </a:spcAft>
-              <a:buNone/>
-            </a:pPr>
-            <a:r>
-              <a:rPr lang="en-US" sz="1400" b="1" dirty="0">
-                <a:solidFill>
-                  <a:srgbClr val="111111"/>
-                </a:solidFill>
-              </a:rPr>
-              <a:t>Para el cliente: </a:t>
-            </a:r>
-            <a:pPr indent="0" marL="0">
-              <a:spcAft>
-                <a:spcPts val="1200"/>
-              </a:spcAft>
-              <a:buNone/>
-            </a:pPr>
-            <a:r>
-              <a:rPr lang="en-US" sz="1400" dirty="0">
-                <a:solidFill>
-                  <a:srgbClr val="111111"/>
-                </a:solidFill>
-              </a:rPr>
-              <a:t>premios por volver, sin tarjeta que perder.</a:t>
-            </a:r>
-            <a:endParaRPr lang="en-US" sz="1400" dirty="0"/>
-          </a:p>
-        </p:txBody>
-      </p:sp>
-      <p:sp>
-        <p:nvSpPr>
-          <p:cNvPr id="8" name="Shape 5"/>
+              </a:rPr>
+              <a:t>Mismo código Expo</a:t>
+            </a:r>
+            <a:endParaRPr lang="en-US" sz="1200" dirty="0"/>
+          </a:p>
+        </p:txBody>
+      </p:sp>
+      <p:sp>
+        <p:nvSpPr>
+          <p:cNvPr id="11" name="Shape 9"/>
           <p:cNvSpPr/>
           <p:nvPr/>
         </p:nvSpPr>
         <p:spPr>
           <a:xfrm>
-            <a:off x="3246120" y="1051560"/>
-            <a:ext cx="2606040" cy="3520440"/>
+            <a:off x="4498848" y="1517904"/>
+            <a:ext cx="146304" cy="256032"/>
+          </a:xfrm>
+          <a:prstGeom prst="rightArrow">
+            <a:avLst/>
+          </a:prstGeom>
+          <a:solidFill>
+            <a:srgbClr val="F5C400"/>
+          </a:solidFill>
+          <a:ln w="12700">
+            <a:solidFill>
+              <a:srgbClr val="F5C400"/>
+            </a:solidFill>
+            <a:prstDash val="solid"/>
+          </a:ln>
+        </p:spPr>
+      </p:sp>
+      <p:sp>
+        <p:nvSpPr>
+          <p:cNvPr id="12" name="Shape 10"/>
+          <p:cNvSpPr/>
+          <p:nvPr/>
+        </p:nvSpPr>
+        <p:spPr>
+          <a:xfrm>
+            <a:off x="4663440" y="1051560"/>
+            <a:ext cx="1188720" cy="1188720"/>
           </a:xfrm>
           <a:prstGeom prst="roundRect">
             <a:avLst>
-              <a:gd name="adj" fmla="val 2807"/>
+              <a:gd name="adj" fmla="val 6154"/>
             </a:avLst>
           </a:prstGeom>
           <a:solidFill>
@@ -9327,63 +10041,39 @@
       </p:sp>
       <p:sp>
         <p:nvSpPr>
-          <p:cNvPr id="9" name="Shape 6"/>
+          <p:cNvPr id="13" name="Shape 11"/>
           <p:cNvSpPr/>
           <p:nvPr/>
         </p:nvSpPr>
         <p:spPr>
           <a:xfrm>
-            <a:off x="3447288" y="1207008"/>
-            <a:ext cx="457200" cy="457200"/>
+            <a:off x="4773168" y="1143000"/>
+            <a:ext cx="329184" cy="329184"/>
           </a:xfrm>
           <a:prstGeom prst="ellipse">
             <a:avLst/>
           </a:prstGeom>
           <a:solidFill>
-            <a:srgbClr val="111111"/>
+            <a:srgbClr val="F5C400"/>
           </a:solidFill>
           <a:ln w="12700">
             <a:solidFill>
-              <a:srgbClr val="111111"/>
+              <a:srgbClr val="F5C400"/>
             </a:solidFill>
             <a:prstDash val="solid"/>
           </a:ln>
         </p:spPr>
       </p:sp>
-      <p:pic>
-        <p:nvPicPr>
-          <p:cNvPr id="10" name="Image 1" descr="preencoded.png">    </p:cNvPr>
-          <p:cNvPicPr>
-            <a:picLocks noChangeAspect="1"/>
-          </p:cNvPicPr>
-          <p:nvPr/>
-        </p:nvPicPr>
-        <p:blipFill>
-          <a:blip r:embed="rId2"/>
-          <a:stretch>
-            <a:fillRect/>
-          </a:stretch>
-        </p:blipFill>
-        <p:spPr>
-          <a:xfrm>
-            <a:off x="3561588" y="1321308"/>
-            <a:ext cx="228600" cy="228600"/>
-          </a:xfrm>
-          <a:prstGeom prst="rect">
-            <a:avLst/>
-          </a:prstGeom>
-        </p:spPr>
-      </p:pic>
-      <p:sp>
-        <p:nvSpPr>
-          <p:cNvPr id="11" name="Text 7"/>
-          <p:cNvSpPr txBox="1"/>
-          <p:nvPr/>
-        </p:nvSpPr>
-        <p:spPr>
-          <a:xfrm>
-            <a:off x="4023360" y="1207008"/>
-            <a:ext cx="1737360" cy="457200"/>
+      <p:sp>
+        <p:nvSpPr>
+          <p:cNvPr id="14" name="Text 12"/>
+          <p:cNvSpPr txBox="1"/>
+          <p:nvPr/>
+        </p:nvSpPr>
+        <p:spPr>
+          <a:xfrm>
+            <a:off x="4773168" y="1143000"/>
+            <a:ext cx="329184" cy="329184"/>
           </a:xfrm>
           <a:prstGeom prst="rect">
             <a:avLst/>
@@ -9395,11 +10085,455 @@
           <a:bodyPr wrap="square" lIns="0" tIns="0" rIns="0" bIns="0" rtlCol="0" anchor="ctr"/>
           <a:lstStyle/>
           <a:p>
+            <a:pPr algn="ctr" indent="0" marL="0">
+              <a:buNone/>
+            </a:pPr>
+            <a:r>
+              <a:rPr lang="en-US" sz="1300" b="1" dirty="0">
+                <a:solidFill>
+                  <a:srgbClr val="111111"/>
+                </a:solidFill>
+              </a:rPr>
+              <a:t>2</a:t>
+            </a:r>
+            <a:endParaRPr lang="en-US" sz="1300" dirty="0"/>
+          </a:p>
+        </p:txBody>
+      </p:sp>
+      <p:sp>
+        <p:nvSpPr>
+          <p:cNvPr id="15" name="Text 13"/>
+          <p:cNvSpPr txBox="1"/>
+          <p:nvPr/>
+        </p:nvSpPr>
+        <p:spPr>
+          <a:xfrm>
+            <a:off x="4773168" y="1536192"/>
+            <a:ext cx="1005840" cy="658368"/>
+          </a:xfrm>
+          <a:prstGeom prst="rect">
+            <a:avLst/>
+          </a:prstGeom>
+          <a:noFill/>
+          <a:ln/>
+        </p:spPr>
+        <p:txBody>
+          <a:bodyPr wrap="square" lIns="0" tIns="0" rIns="0" bIns="0" rtlCol="0" anchor="t"/>
+          <a:lstStyle/>
+          <a:p>
             <a:pPr indent="0" marL="0">
               <a:buNone/>
             </a:pPr>
             <a:r>
-              <a:rPr lang="en-US" sz="1500" b="1" dirty="0">
+              <a:rPr lang="en-US" sz="1200" b="1" dirty="0">
+                <a:solidFill>
+                  <a:srgbClr val="111111"/>
+                </a:solidFill>
+              </a:rPr>
+              <a:t>EAS Build compila iOS en la nube</a:t>
+            </a:r>
+            <a:endParaRPr lang="en-US" sz="1200" dirty="0"/>
+          </a:p>
+        </p:txBody>
+      </p:sp>
+      <p:sp>
+        <p:nvSpPr>
+          <p:cNvPr id="16" name="Shape 14"/>
+          <p:cNvSpPr/>
+          <p:nvPr/>
+        </p:nvSpPr>
+        <p:spPr>
+          <a:xfrm>
+            <a:off x="5870448" y="1517904"/>
+            <a:ext cx="146304" cy="256032"/>
+          </a:xfrm>
+          <a:prstGeom prst="rightArrow">
+            <a:avLst/>
+          </a:prstGeom>
+          <a:solidFill>
+            <a:srgbClr val="F5C400"/>
+          </a:solidFill>
+          <a:ln w="12700">
+            <a:solidFill>
+              <a:srgbClr val="F5C400"/>
+            </a:solidFill>
+            <a:prstDash val="solid"/>
+          </a:ln>
+        </p:spPr>
+      </p:sp>
+      <p:sp>
+        <p:nvSpPr>
+          <p:cNvPr id="17" name="Shape 15"/>
+          <p:cNvSpPr/>
+          <p:nvPr/>
+        </p:nvSpPr>
+        <p:spPr>
+          <a:xfrm>
+            <a:off x="6035040" y="1051560"/>
+            <a:ext cx="1188720" cy="1188720"/>
+          </a:xfrm>
+          <a:prstGeom prst="roundRect">
+            <a:avLst>
+              <a:gd name="adj" fmla="val 6154"/>
+            </a:avLst>
+          </a:prstGeom>
+          <a:solidFill>
+            <a:srgbClr val="F2F2F2"/>
+          </a:solidFill>
+          <a:ln w="12700">
+            <a:solidFill>
+              <a:srgbClr val="F2F2F2"/>
+            </a:solidFill>
+            <a:prstDash val="solid"/>
+          </a:ln>
+        </p:spPr>
+      </p:sp>
+      <p:sp>
+        <p:nvSpPr>
+          <p:cNvPr id="18" name="Shape 16"/>
+          <p:cNvSpPr/>
+          <p:nvPr/>
+        </p:nvSpPr>
+        <p:spPr>
+          <a:xfrm>
+            <a:off x="6144768" y="1143000"/>
+            <a:ext cx="329184" cy="329184"/>
+          </a:xfrm>
+          <a:prstGeom prst="ellipse">
+            <a:avLst/>
+          </a:prstGeom>
+          <a:solidFill>
+            <a:srgbClr val="F5C400"/>
+          </a:solidFill>
+          <a:ln w="12700">
+            <a:solidFill>
+              <a:srgbClr val="F5C400"/>
+            </a:solidFill>
+            <a:prstDash val="solid"/>
+          </a:ln>
+        </p:spPr>
+      </p:sp>
+      <p:sp>
+        <p:nvSpPr>
+          <p:cNvPr id="19" name="Text 17"/>
+          <p:cNvSpPr txBox="1"/>
+          <p:nvPr/>
+        </p:nvSpPr>
+        <p:spPr>
+          <a:xfrm>
+            <a:off x="6144768" y="1143000"/>
+            <a:ext cx="329184" cy="329184"/>
+          </a:xfrm>
+          <a:prstGeom prst="rect">
+            <a:avLst/>
+          </a:prstGeom>
+          <a:noFill/>
+          <a:ln/>
+        </p:spPr>
+        <p:txBody>
+          <a:bodyPr wrap="square" lIns="0" tIns="0" rIns="0" bIns="0" rtlCol="0" anchor="ctr"/>
+          <a:lstStyle/>
+          <a:p>
+            <a:pPr algn="ctr" indent="0" marL="0">
+              <a:buNone/>
+            </a:pPr>
+            <a:r>
+              <a:rPr lang="en-US" sz="1300" b="1" dirty="0">
+                <a:solidFill>
+                  <a:srgbClr val="111111"/>
+                </a:solidFill>
+              </a:rPr>
+              <a:t>3</a:t>
+            </a:r>
+            <a:endParaRPr lang="en-US" sz="1300" dirty="0"/>
+          </a:p>
+        </p:txBody>
+      </p:sp>
+      <p:sp>
+        <p:nvSpPr>
+          <p:cNvPr id="20" name="Text 18"/>
+          <p:cNvSpPr txBox="1"/>
+          <p:nvPr/>
+        </p:nvSpPr>
+        <p:spPr>
+          <a:xfrm>
+            <a:off x="6144768" y="1536192"/>
+            <a:ext cx="1005840" cy="658368"/>
+          </a:xfrm>
+          <a:prstGeom prst="rect">
+            <a:avLst/>
+          </a:prstGeom>
+          <a:noFill/>
+          <a:ln/>
+        </p:spPr>
+        <p:txBody>
+          <a:bodyPr wrap="square" lIns="0" tIns="0" rIns="0" bIns="0" rtlCol="0" anchor="t"/>
+          <a:lstStyle/>
+          <a:p>
+            <a:pPr indent="0" marL="0">
+              <a:buNone/>
+            </a:pPr>
+            <a:r>
+              <a:rPr lang="en-US" sz="1200" b="1" dirty="0">
+                <a:solidFill>
+                  <a:srgbClr val="111111"/>
+                </a:solidFill>
+              </a:rPr>
+              <a:t>TestFlight: prueba en iPhones reales</a:t>
+            </a:r>
+            <a:endParaRPr lang="en-US" sz="1200" dirty="0"/>
+          </a:p>
+        </p:txBody>
+      </p:sp>
+      <p:sp>
+        <p:nvSpPr>
+          <p:cNvPr id="21" name="Shape 19"/>
+          <p:cNvSpPr/>
+          <p:nvPr/>
+        </p:nvSpPr>
+        <p:spPr>
+          <a:xfrm>
+            <a:off x="7242048" y="1517904"/>
+            <a:ext cx="146304" cy="256032"/>
+          </a:xfrm>
+          <a:prstGeom prst="rightArrow">
+            <a:avLst/>
+          </a:prstGeom>
+          <a:solidFill>
+            <a:srgbClr val="F5C400"/>
+          </a:solidFill>
+          <a:ln w="12700">
+            <a:solidFill>
+              <a:srgbClr val="F5C400"/>
+            </a:solidFill>
+            <a:prstDash val="solid"/>
+          </a:ln>
+        </p:spPr>
+      </p:sp>
+      <p:sp>
+        <p:nvSpPr>
+          <p:cNvPr id="22" name="Shape 20"/>
+          <p:cNvSpPr/>
+          <p:nvPr/>
+        </p:nvSpPr>
+        <p:spPr>
+          <a:xfrm>
+            <a:off x="7406640" y="1051560"/>
+            <a:ext cx="1188720" cy="1188720"/>
+          </a:xfrm>
+          <a:prstGeom prst="roundRect">
+            <a:avLst>
+              <a:gd name="adj" fmla="val 6154"/>
+            </a:avLst>
+          </a:prstGeom>
+          <a:solidFill>
+            <a:srgbClr val="F2F2F2"/>
+          </a:solidFill>
+          <a:ln w="12700">
+            <a:solidFill>
+              <a:srgbClr val="F2F2F2"/>
+            </a:solidFill>
+            <a:prstDash val="solid"/>
+          </a:ln>
+        </p:spPr>
+      </p:sp>
+      <p:sp>
+        <p:nvSpPr>
+          <p:cNvPr id="23" name="Shape 21"/>
+          <p:cNvSpPr/>
+          <p:nvPr/>
+        </p:nvSpPr>
+        <p:spPr>
+          <a:xfrm>
+            <a:off x="7516368" y="1143000"/>
+            <a:ext cx="329184" cy="329184"/>
+          </a:xfrm>
+          <a:prstGeom prst="ellipse">
+            <a:avLst/>
+          </a:prstGeom>
+          <a:solidFill>
+            <a:srgbClr val="F5C400"/>
+          </a:solidFill>
+          <a:ln w="12700">
+            <a:solidFill>
+              <a:srgbClr val="F5C400"/>
+            </a:solidFill>
+            <a:prstDash val="solid"/>
+          </a:ln>
+        </p:spPr>
+      </p:sp>
+      <p:sp>
+        <p:nvSpPr>
+          <p:cNvPr id="24" name="Text 22"/>
+          <p:cNvSpPr txBox="1"/>
+          <p:nvPr/>
+        </p:nvSpPr>
+        <p:spPr>
+          <a:xfrm>
+            <a:off x="7516368" y="1143000"/>
+            <a:ext cx="329184" cy="329184"/>
+          </a:xfrm>
+          <a:prstGeom prst="rect">
+            <a:avLst/>
+          </a:prstGeom>
+          <a:noFill/>
+          <a:ln/>
+        </p:spPr>
+        <p:txBody>
+          <a:bodyPr wrap="square" lIns="0" tIns="0" rIns="0" bIns="0" rtlCol="0" anchor="ctr"/>
+          <a:lstStyle/>
+          <a:p>
+            <a:pPr algn="ctr" indent="0" marL="0">
+              <a:buNone/>
+            </a:pPr>
+            <a:r>
+              <a:rPr lang="en-US" sz="1300" b="1" dirty="0">
+                <a:solidFill>
+                  <a:srgbClr val="111111"/>
+                </a:solidFill>
+              </a:rPr>
+              <a:t>4</a:t>
+            </a:r>
+            <a:endParaRPr lang="en-US" sz="1300" dirty="0"/>
+          </a:p>
+        </p:txBody>
+      </p:sp>
+      <p:sp>
+        <p:nvSpPr>
+          <p:cNvPr id="25" name="Text 23"/>
+          <p:cNvSpPr txBox="1"/>
+          <p:nvPr/>
+        </p:nvSpPr>
+        <p:spPr>
+          <a:xfrm>
+            <a:off x="7516368" y="1536192"/>
+            <a:ext cx="1005840" cy="658368"/>
+          </a:xfrm>
+          <a:prstGeom prst="rect">
+            <a:avLst/>
+          </a:prstGeom>
+          <a:noFill/>
+          <a:ln/>
+        </p:spPr>
+        <p:txBody>
+          <a:bodyPr wrap="square" lIns="0" tIns="0" rIns="0" bIns="0" rtlCol="0" anchor="t"/>
+          <a:lstStyle/>
+          <a:p>
+            <a:pPr indent="0" marL="0">
+              <a:buNone/>
+            </a:pPr>
+            <a:r>
+              <a:rPr lang="en-US" sz="1200" b="1" dirty="0">
+                <a:solidFill>
+                  <a:srgbClr val="111111"/>
+                </a:solidFill>
+              </a:rPr>
+              <a:t>Revisión de Apple y App Store</a:t>
+            </a:r>
+            <a:endParaRPr lang="en-US" sz="1200" dirty="0"/>
+          </a:p>
+        </p:txBody>
+      </p:sp>
+      <p:sp>
+        <p:nvSpPr>
+          <p:cNvPr id="26" name="Shape 24"/>
+          <p:cNvSpPr/>
+          <p:nvPr/>
+        </p:nvSpPr>
+        <p:spPr>
+          <a:xfrm>
+            <a:off x="3291840" y="2423160"/>
+            <a:ext cx="5394960" cy="868680"/>
+          </a:xfrm>
+          <a:prstGeom prst="roundRect">
+            <a:avLst>
+              <a:gd name="adj" fmla="val 8421"/>
+            </a:avLst>
+          </a:prstGeom>
+          <a:solidFill>
+            <a:srgbClr val="FFF4BF"/>
+          </a:solidFill>
+          <a:ln w="12700">
+            <a:solidFill>
+              <a:srgbClr val="FFF4BF"/>
+            </a:solidFill>
+            <a:prstDash val="solid"/>
+          </a:ln>
+        </p:spPr>
+      </p:sp>
+      <p:sp>
+        <p:nvSpPr>
+          <p:cNvPr id="27" name="Text 25"/>
+          <p:cNvSpPr txBox="1"/>
+          <p:nvPr/>
+        </p:nvSpPr>
+        <p:spPr>
+          <a:xfrm>
+            <a:off x="3474720" y="2487168"/>
+            <a:ext cx="5074920" cy="749808"/>
+          </a:xfrm>
+          <a:prstGeom prst="rect">
+            <a:avLst/>
+          </a:prstGeom>
+          <a:noFill/>
+          <a:ln/>
+        </p:spPr>
+        <p:txBody>
+          <a:bodyPr wrap="square" lIns="0" tIns="0" rIns="0" bIns="0" rtlCol="0" anchor="ctr"/>
+          <a:lstStyle/>
+          <a:p>
+            <a:pPr indent="0" marL="0">
+              <a:buNone/>
+            </a:pPr>
+            <a:r>
+              <a:rPr lang="en-US" sz="1200" b="1" dirty="0">
+                <a:solidFill>
+                  <a:srgbClr val="111111"/>
+                </a:solidFill>
+              </a:rPr>
+              <a:t>Qué exige Apple: </a:t>
+            </a:r>
+            <a:pPr indent="0" marL="0">
+              <a:buNone/>
+            </a:pPr>
+            <a:r>
+              <a:rPr lang="en-US" sz="1200" dirty="0">
+                <a:solidFill>
+                  <a:srgbClr val="111111"/>
+                </a:solidFill>
+              </a:rPr>
+              <a:t>iniciar sesión con Apple si la app ofrece login con Google (nueva HU-20, Sprint 2), borrado de cuenta en la app y etiqueta de privacidad (Sprint 3).</a:t>
+            </a:r>
+            <a:endParaRPr lang="en-US" sz="1200" dirty="0"/>
+          </a:p>
+        </p:txBody>
+      </p:sp>
+      <p:sp>
+        <p:nvSpPr>
+          <p:cNvPr id="28" name="Text 26"/>
+          <p:cNvSpPr txBox="1"/>
+          <p:nvPr/>
+        </p:nvSpPr>
+        <p:spPr>
+          <a:xfrm>
+            <a:off x="3291840" y="3456432"/>
+            <a:ext cx="1280160" cy="411480"/>
+          </a:xfrm>
+          <a:prstGeom prst="rect">
+            <a:avLst/>
+          </a:prstGeom>
+          <a:noFill/>
+          <a:ln/>
+        </p:spPr>
+        <p:txBody>
+          <a:bodyPr wrap="square" lIns="0" tIns="0" rIns="0" bIns="0" rtlCol="0" anchor="t"/>
+          <a:lstStyle/>
+          <a:p>
+            <a:pPr indent="0" marL="0">
+              <a:buNone/>
+            </a:pPr>
+            <a:r>
+              <a:rPr lang="en-US" sz="2000" b="1" dirty="0">
                 <a:solidFill>
                   <a:srgbClr val="111111"/>
                 </a:solidFill>
@@ -9407,22 +10541,22 @@
                 <a:ea typeface="Arial" pitchFamily="34" charset="-122"/>
                 <a:cs typeface="Arial" pitchFamily="34" charset="-120"/>
               </a:rPr>
-              <a:t>Clientes y usuarios</a:t>
-            </a:r>
-            <a:endParaRPr lang="en-US" sz="1500" dirty="0"/>
-          </a:p>
-        </p:txBody>
-      </p:sp>
-      <p:sp>
-        <p:nvSpPr>
-          <p:cNvPr id="12" name="Text 8"/>
-          <p:cNvSpPr txBox="1"/>
-          <p:nvPr/>
-        </p:nvSpPr>
-        <p:spPr>
-          <a:xfrm>
-            <a:off x="3447288" y="1874520"/>
-            <a:ext cx="2240280" cy="2606040"/>
+              <a:t>99 USD</a:t>
+            </a:r>
+            <a:endParaRPr lang="en-US" sz="2000" dirty="0"/>
+          </a:p>
+        </p:txBody>
+      </p:sp>
+      <p:sp>
+        <p:nvSpPr>
+          <p:cNvPr id="29" name="Text 27"/>
+          <p:cNvSpPr txBox="1"/>
+          <p:nvPr/>
+        </p:nvSpPr>
+        <p:spPr>
+          <a:xfrm>
+            <a:off x="3291840" y="3886200"/>
+            <a:ext cx="1234440" cy="640080"/>
           </a:xfrm>
           <a:prstGeom prst="rect">
             <a:avLst/>
@@ -9435,206 +10569,69 @@
           <a:lstStyle/>
           <a:p>
             <a:pPr indent="0" marL="0">
-              <a:spcAft>
-                <a:spcPts val="1200"/>
-              </a:spcAft>
-              <a:buNone/>
-            </a:pPr>
-            <a:r>
-              <a:rPr lang="en-US" sz="1400" b="1" dirty="0">
+              <a:buNone/>
+            </a:pPr>
+            <a:r>
+              <a:rPr lang="en-US" sz="1100" dirty="0">
+                <a:solidFill>
+                  <a:srgbClr val="6B6B6B"/>
+                </a:solidFill>
+              </a:rPr>
+              <a:t>al año, cuenta de Apple Developer</a:t>
+            </a:r>
+            <a:endParaRPr lang="en-US" sz="1100" dirty="0"/>
+          </a:p>
+        </p:txBody>
+      </p:sp>
+      <p:sp>
+        <p:nvSpPr>
+          <p:cNvPr id="30" name="Text 28"/>
+          <p:cNvSpPr txBox="1"/>
+          <p:nvPr/>
+        </p:nvSpPr>
+        <p:spPr>
+          <a:xfrm>
+            <a:off x="4663440" y="3456432"/>
+            <a:ext cx="1280160" cy="411480"/>
+          </a:xfrm>
+          <a:prstGeom prst="rect">
+            <a:avLst/>
+          </a:prstGeom>
+          <a:noFill/>
+          <a:ln/>
+        </p:spPr>
+        <p:txBody>
+          <a:bodyPr wrap="square" lIns="0" tIns="0" rIns="0" bIns="0" rtlCol="0" anchor="t"/>
+          <a:lstStyle/>
+          <a:p>
+            <a:pPr indent="0" marL="0">
+              <a:buNone/>
+            </a:pPr>
+            <a:r>
+              <a:rPr lang="en-US" sz="2000" b="1" dirty="0">
                 <a:solidFill>
                   <a:srgbClr val="111111"/>
-                </a:solidFill>
-              </a:rPr>
-              <a:t>Paga: </a:t>
-            </a:r>
-            <a:pPr indent="0" marL="0">
-              <a:spcAft>
-                <a:spcPts val="1200"/>
-              </a:spcAft>
-              <a:buNone/>
-            </a:pPr>
-            <a:r>
-              <a:rPr lang="en-US" sz="1400" dirty="0">
-                <a:solidFill>
-                  <a:srgbClr val="111111"/>
-                </a:solidFill>
-              </a:rPr>
-              <a:t>Clancy's Cork.</a:t>
-            </a:r>
-            <a:endParaRPr lang="en-US" sz="1400" dirty="0"/>
-          </a:p>
-          <a:p>
-            <a:pPr indent="0" marL="0">
-              <a:spcAft>
-                <a:spcPts val="1200"/>
-              </a:spcAft>
-              <a:buNone/>
-            </a:pPr>
-            <a:r>
-              <a:rPr lang="en-US" sz="1400" b="1" dirty="0">
-                <a:solidFill>
-                  <a:srgbClr val="111111"/>
-                </a:solidFill>
-              </a:rPr>
-              <a:t>La usan: </a:t>
-            </a:r>
-            <a:pPr indent="0" marL="0">
-              <a:spcAft>
-                <a:spcPts val="1200"/>
-              </a:spcAft>
-              <a:buNone/>
-            </a:pPr>
-            <a:r>
-              <a:rPr lang="en-US" sz="1400" dirty="0">
-                <a:solidFill>
-                  <a:srgbClr val="111111"/>
-                </a:solidFill>
-              </a:rPr>
-              <a:t>clientes del local, meseros y administración.</a:t>
-            </a:r>
-            <a:endParaRPr lang="en-US" sz="1400" dirty="0"/>
-          </a:p>
-          <a:p>
-            <a:pPr indent="0" marL="0">
-              <a:spcAft>
-                <a:spcPts val="1200"/>
-              </a:spcAft>
-              <a:buNone/>
-            </a:pPr>
-            <a:r>
-              <a:rPr lang="en-US" sz="1400" b="1" dirty="0">
-                <a:solidFill>
-                  <a:srgbClr val="111111"/>
-                </a:solidFill>
-              </a:rPr>
-              <a:t>Sus clientes: </a:t>
-            </a:r>
-            <a:pPr indent="0" marL="0">
-              <a:spcAft>
-                <a:spcPts val="1200"/>
-              </a:spcAft>
-              <a:buNone/>
-            </a:pPr>
-            <a:r>
-              <a:rPr lang="en-US" sz="1400" dirty="0">
-                <a:solidFill>
-                  <a:srgbClr val="111111"/>
-                </a:solidFill>
-              </a:rPr>
-              <a:t>gente de Cork y turistas que visitan el pub.</a:t>
-            </a:r>
-            <a:endParaRPr lang="en-US" sz="1400" dirty="0"/>
-          </a:p>
-          <a:p>
-            <a:pPr indent="0" marL="0">
-              <a:spcAft>
-                <a:spcPts val="1200"/>
-              </a:spcAft>
-              <a:buNone/>
-            </a:pPr>
-            <a:r>
-              <a:rPr lang="en-US" sz="1400" b="1" dirty="0">
-                <a:solidFill>
-                  <a:srgbClr val="111111"/>
-                </a:solidFill>
-              </a:rPr>
-              <a:t>A futuro: </a:t>
-            </a:r>
-            <a:pPr indent="0" marL="0">
-              <a:spcAft>
-                <a:spcPts val="1200"/>
-              </a:spcAft>
-              <a:buNone/>
-            </a:pPr>
-            <a:r>
-              <a:rPr lang="en-US" sz="1400" dirty="0">
-                <a:solidFill>
-                  <a:srgbClr val="111111"/>
-                </a:solidFill>
-              </a:rPr>
-              <a:t>otros bares.</a:t>
-            </a:r>
-            <a:endParaRPr lang="en-US" sz="1400" dirty="0"/>
-          </a:p>
-        </p:txBody>
-      </p:sp>
-      <p:sp>
-        <p:nvSpPr>
-          <p:cNvPr id="13" name="Shape 9"/>
-          <p:cNvSpPr/>
-          <p:nvPr/>
-        </p:nvSpPr>
-        <p:spPr>
-          <a:xfrm>
-            <a:off x="6035040" y="1051560"/>
-            <a:ext cx="2651760" cy="3520440"/>
-          </a:xfrm>
-          <a:prstGeom prst="roundRect">
-            <a:avLst>
-              <a:gd name="adj" fmla="val 2759"/>
-            </a:avLst>
-          </a:prstGeom>
-          <a:solidFill>
-            <a:srgbClr val="111111"/>
-          </a:solidFill>
-          <a:ln w="12700">
-            <a:solidFill>
-              <a:srgbClr val="111111"/>
-            </a:solidFill>
-            <a:prstDash val="solid"/>
-          </a:ln>
-        </p:spPr>
-      </p:sp>
-      <p:sp>
-        <p:nvSpPr>
-          <p:cNvPr id="14" name="Text 10"/>
-          <p:cNvSpPr txBox="1"/>
-          <p:nvPr/>
-        </p:nvSpPr>
-        <p:spPr>
-          <a:xfrm>
-            <a:off x="6236208" y="1188720"/>
-            <a:ext cx="2286000" cy="320040"/>
-          </a:xfrm>
-          <a:prstGeom prst="rect">
-            <a:avLst/>
-          </a:prstGeom>
-          <a:noFill/>
-          <a:ln/>
-        </p:spPr>
-        <p:txBody>
-          <a:bodyPr wrap="square" lIns="0" tIns="0" rIns="0" bIns="0" rtlCol="0" anchor="t"/>
-          <a:lstStyle/>
-          <a:p>
-            <a:pPr indent="0" marL="0">
-              <a:buNone/>
-            </a:pPr>
-            <a:r>
-              <a:rPr lang="en-US" sz="1500" b="1" dirty="0">
-                <a:solidFill>
-                  <a:srgbClr val="F5C400"/>
                 </a:solidFill>
                 <a:latin typeface="Arial" pitchFamily="34" charset="0"/>
                 <a:ea typeface="Arial" pitchFamily="34" charset="-122"/>
                 <a:cs typeface="Arial" pitchFamily="34" charset="-120"/>
               </a:rPr>
-              <a:t>Sostenibilidad</a:t>
-            </a:r>
-            <a:endParaRPr lang="en-US" sz="1500" dirty="0"/>
-          </a:p>
-        </p:txBody>
-      </p:sp>
-      <p:sp>
-        <p:nvSpPr>
-          <p:cNvPr id="15" name="Text 11"/>
-          <p:cNvSpPr txBox="1"/>
-          <p:nvPr/>
-        </p:nvSpPr>
-        <p:spPr>
-          <a:xfrm>
-            <a:off x="6236208" y="1554480"/>
-            <a:ext cx="2286000" cy="548640"/>
+              <a:t>25 USD</a:t>
+            </a:r>
+            <a:endParaRPr lang="en-US" sz="2000" dirty="0"/>
+          </a:p>
+        </p:txBody>
+      </p:sp>
+      <p:sp>
+        <p:nvSpPr>
+          <p:cNvPr id="31" name="Text 29"/>
+          <p:cNvSpPr txBox="1"/>
+          <p:nvPr/>
+        </p:nvSpPr>
+        <p:spPr>
+          <a:xfrm>
+            <a:off x="4663440" y="3886200"/>
+            <a:ext cx="1234440" cy="640080"/>
           </a:xfrm>
           <a:prstGeom prst="rect">
             <a:avLst/>
@@ -9650,30 +10647,66 @@
               <a:buNone/>
             </a:pPr>
             <a:r>
-              <a:rPr lang="en-US" sz="3200" b="1" dirty="0">
-                <a:solidFill>
-                  <a:srgbClr val="FFFFFF"/>
+              <a:rPr lang="en-US" sz="1100" dirty="0">
+                <a:solidFill>
+                  <a:srgbClr val="6B6B6B"/>
+                </a:solidFill>
+              </a:rPr>
+              <a:t>una vez, cuenta de Google Play</a:t>
+            </a:r>
+            <a:endParaRPr lang="en-US" sz="1100" dirty="0"/>
+          </a:p>
+        </p:txBody>
+      </p:sp>
+      <p:sp>
+        <p:nvSpPr>
+          <p:cNvPr id="32" name="Text 30"/>
+          <p:cNvSpPr txBox="1"/>
+          <p:nvPr/>
+        </p:nvSpPr>
+        <p:spPr>
+          <a:xfrm>
+            <a:off x="6035040" y="3456432"/>
+            <a:ext cx="1280160" cy="411480"/>
+          </a:xfrm>
+          <a:prstGeom prst="rect">
+            <a:avLst/>
+          </a:prstGeom>
+          <a:noFill/>
+          <a:ln/>
+        </p:spPr>
+        <p:txBody>
+          <a:bodyPr wrap="square" lIns="0" tIns="0" rIns="0" bIns="0" rtlCol="0" anchor="t"/>
+          <a:lstStyle/>
+          <a:p>
+            <a:pPr indent="0" marL="0">
+              <a:buNone/>
+            </a:pPr>
+            <a:r>
+              <a:rPr lang="en-US" sz="2000" b="1" dirty="0">
+                <a:solidFill>
+                  <a:srgbClr val="111111"/>
                 </a:solidFill>
                 <a:latin typeface="Arial" pitchFamily="34" charset="0"/>
                 <a:ea typeface="Arial" pitchFamily="34" charset="-122"/>
                 <a:cs typeface="Arial" pitchFamily="34" charset="-120"/>
               </a:rPr>
-              <a:t>€2.500</a:t>
-            </a:r>
-            <a:endParaRPr lang="en-US" sz="3200" dirty="0"/>
-          </a:p>
-        </p:txBody>
-      </p:sp>
-      <p:sp>
-        <p:nvSpPr>
-          <p:cNvPr id="16" name="Text 12"/>
-          <p:cNvSpPr txBox="1"/>
-          <p:nvPr/>
-        </p:nvSpPr>
-        <p:spPr>
-          <a:xfrm>
-            <a:off x="6236208" y="2103120"/>
-            <a:ext cx="2286000" cy="274320"/>
+              <a:t>0 USD</a:t>
+            </a:r>
+            <a:endParaRPr lang="en-US" sz="2000" dirty="0"/>
+          </a:p>
+        </p:txBody>
+      </p:sp>
+      <p:sp>
+        <p:nvSpPr>
+          <p:cNvPr id="33" name="Text 31"/>
+          <p:cNvSpPr txBox="1"/>
+          <p:nvPr/>
+        </p:nvSpPr>
+        <p:spPr>
+          <a:xfrm>
+            <a:off x="6035040" y="3886200"/>
+            <a:ext cx="1234440" cy="640080"/>
           </a:xfrm>
           <a:prstGeom prst="rect">
             <a:avLst/>
@@ -9689,27 +10722,27 @@
               <a:buNone/>
             </a:pPr>
             <a:r>
-              <a:rPr lang="en-US" sz="1200" dirty="0">
-                <a:solidFill>
-                  <a:srgbClr val="F5C400"/>
-                </a:solidFill>
-              </a:rPr>
-              <a:t>pago inicial para terminarla y publicarla</a:t>
-            </a:r>
-            <a:endParaRPr lang="en-US" sz="1200" dirty="0"/>
-          </a:p>
-        </p:txBody>
-      </p:sp>
-      <p:sp>
-        <p:nvSpPr>
-          <p:cNvPr id="17" name="Text 13"/>
-          <p:cNvSpPr txBox="1"/>
-          <p:nvPr/>
-        </p:nvSpPr>
-        <p:spPr>
-          <a:xfrm>
-            <a:off x="6236208" y="2514600"/>
-            <a:ext cx="2286000" cy="548640"/>
+              <a:rPr lang="en-US" sz="1100" dirty="0">
+                <a:solidFill>
+                  <a:srgbClr val="6B6B6B"/>
+                </a:solidFill>
+              </a:rPr>
+              <a:t>EAS Build: 15 builds de iOS gratis al mes</a:t>
+            </a:r>
+            <a:endParaRPr lang="en-US" sz="1100" dirty="0"/>
+          </a:p>
+        </p:txBody>
+      </p:sp>
+      <p:sp>
+        <p:nvSpPr>
+          <p:cNvPr id="34" name="Text 32"/>
+          <p:cNvSpPr txBox="1"/>
+          <p:nvPr/>
+        </p:nvSpPr>
+        <p:spPr>
+          <a:xfrm>
+            <a:off x="7406640" y="3456432"/>
+            <a:ext cx="1280160" cy="411480"/>
           </a:xfrm>
           <a:prstGeom prst="rect">
             <a:avLst/>
@@ -9725,30 +10758,30 @@
               <a:buNone/>
             </a:pPr>
             <a:r>
-              <a:rPr lang="en-US" sz="3200" b="1" dirty="0">
-                <a:solidFill>
-                  <a:srgbClr val="FFFFFF"/>
+              <a:rPr lang="en-US" sz="2000" b="1" dirty="0">
+                <a:solidFill>
+                  <a:srgbClr val="111111"/>
                 </a:solidFill>
                 <a:latin typeface="Arial" pitchFamily="34" charset="0"/>
                 <a:ea typeface="Arial" pitchFamily="34" charset="-122"/>
                 <a:cs typeface="Arial" pitchFamily="34" charset="-120"/>
               </a:rPr>
-              <a:t>€75–90</a:t>
-            </a:r>
-            <a:endParaRPr lang="en-US" sz="3200" dirty="0"/>
-          </a:p>
-        </p:txBody>
-      </p:sp>
-      <p:sp>
-        <p:nvSpPr>
-          <p:cNvPr id="18" name="Text 14"/>
-          <p:cNvSpPr txBox="1"/>
-          <p:nvPr/>
-        </p:nvSpPr>
-        <p:spPr>
-          <a:xfrm>
-            <a:off x="6236208" y="3063240"/>
-            <a:ext cx="2286000" cy="274320"/>
+              <a:t>1 USD/h</a:t>
+            </a:r>
+            <a:endParaRPr lang="en-US" sz="2000" dirty="0"/>
+          </a:p>
+        </p:txBody>
+      </p:sp>
+      <p:sp>
+        <p:nvSpPr>
+          <p:cNvPr id="35" name="Text 33"/>
+          <p:cNvSpPr txBox="1"/>
+          <p:nvPr/>
+        </p:nvSpPr>
+        <p:spPr>
+          <a:xfrm>
+            <a:off x="7406640" y="3886200"/>
+            <a:ext cx="1234440" cy="640080"/>
           </a:xfrm>
           <a:prstGeom prst="rect">
             <a:avLst/>
@@ -9764,50 +10797,14 @@
               <a:buNone/>
             </a:pPr>
             <a:r>
-              <a:rPr lang="en-US" sz="1200" dirty="0">
-                <a:solidFill>
-                  <a:srgbClr val="F5C400"/>
-                </a:solidFill>
-              </a:rPr>
-              <a:t>por semana de mantención</a:t>
-            </a:r>
-            <a:endParaRPr lang="en-US" sz="1200" dirty="0"/>
-          </a:p>
-        </p:txBody>
-      </p:sp>
-      <p:sp>
-        <p:nvSpPr>
-          <p:cNvPr id="19" name="Text 15"/>
-          <p:cNvSpPr txBox="1"/>
-          <p:nvPr/>
-        </p:nvSpPr>
-        <p:spPr>
-          <a:xfrm>
-            <a:off x="6236208" y="3520440"/>
-            <a:ext cx="2286000" cy="914400"/>
-          </a:xfrm>
-          <a:prstGeom prst="rect">
-            <a:avLst/>
-          </a:prstGeom>
-          <a:noFill/>
-          <a:ln/>
-        </p:spPr>
-        <p:txBody>
-          <a:bodyPr wrap="square" lIns="0" tIns="0" rIns="0" bIns="0" rtlCol="0" anchor="t"/>
-          <a:lstStyle/>
-          <a:p>
-            <a:pPr indent="0" marL="0">
-              <a:buNone/>
-            </a:pPr>
-            <a:r>
-              <a:rPr lang="en-US" sz="1200" dirty="0">
-                <a:solidFill>
-                  <a:srgbClr val="FFFFFF"/>
-                </a:solidFill>
-              </a:rPr>
-              <a:t>Operarla cuesta poco: servidor y base de datos parten en plan gratuito, y publicar cuesta 35 a 55 USD.</a:t>
-            </a:r>
-            <a:endParaRPr lang="en-US" sz="1200" dirty="0"/>
+              <a:rPr lang="en-US" sz="1100" dirty="0">
+                <a:solidFill>
+                  <a:srgbClr val="6B6B6B"/>
+                </a:solidFill>
+              </a:rPr>
+              <a:t>Mac en la nube, solo si hace falta</a:t>
+            </a:r>
+            <a:endParaRPr lang="en-US" sz="1100" dirty="0"/>
           </a:p>
         </p:txBody>
       </p:sp>
@@ -9891,8 +10888,8 @@
         </p:nvSpPr>
         <p:spPr>
           <a:xfrm>
-            <a:off x="457200" y="201168"/>
-            <a:ext cx="8229600" cy="548640"/>
+            <a:off x="457200" y="274320"/>
+            <a:ext cx="8229600" cy="640080"/>
           </a:xfrm>
           <a:prstGeom prst="rect">
             <a:avLst/>
@@ -9908,17 +10905,17 @@
               <a:buNone/>
             </a:pPr>
             <a:r>
-              <a:rPr lang="en-US" sz="2400" b="1" dirty="0">
-                <a:solidFill>
-                  <a:srgbClr val="FFFFFF"/>
+              <a:rPr lang="en-US" sz="2600" b="1" dirty="0">
+                <a:solidFill>
+                  <a:srgbClr val="111111"/>
                 </a:solidFill>
                 <a:latin typeface="Arial" pitchFamily="34" charset="0"/>
                 <a:ea typeface="Arial" pitchFamily="34" charset="-122"/>
                 <a:cs typeface="Arial" pitchFamily="34" charset="-120"/>
               </a:rPr>
-              <a:t>Mockups de la app: el cliente</a:t>
-            </a:r>
-            <a:endParaRPr lang="en-US" sz="2400" dirty="0"/>
+              <a:t>Modelo de negocio: pago inicial y mantención</a:t>
+            </a:r>
+            <a:endParaRPr lang="en-US" sz="2600" dirty="0"/>
           </a:p>
         </p:txBody>
       </p:sp>
@@ -9930,20 +10927,20 @@
         </p:nvSpPr>
         <p:spPr>
           <a:xfrm>
-            <a:off x="402336" y="813816"/>
-            <a:ext cx="1757540" cy="256032"/>
+            <a:off x="457200" y="1051560"/>
+            <a:ext cx="2606040" cy="3520440"/>
           </a:xfrm>
           <a:prstGeom prst="roundRect">
             <a:avLst>
-              <a:gd name="adj" fmla="val 21429"/>
+              <a:gd name="adj" fmla="val 2807"/>
             </a:avLst>
           </a:prstGeom>
           <a:solidFill>
-            <a:srgbClr val="F5C400"/>
+            <a:srgbClr val="F2F2F2"/>
           </a:solidFill>
           <a:ln w="12700">
             <a:solidFill>
-              <a:srgbClr val="F5C400"/>
+              <a:srgbClr val="F2F2F2"/>
             </a:solidFill>
             <a:prstDash val="solid"/>
           </a:ln>
@@ -9951,62 +10948,24 @@
       </p:sp>
       <p:sp>
         <p:nvSpPr>
-          <p:cNvPr id="4" name="Text 2"/>
-          <p:cNvSpPr txBox="1"/>
-          <p:nvPr/>
-        </p:nvSpPr>
-        <p:spPr>
-          <a:xfrm>
-            <a:off x="402336" y="813816"/>
-            <a:ext cx="1757540" cy="256032"/>
-          </a:xfrm>
-          <a:prstGeom prst="rect">
-            <a:avLst/>
-          </a:prstGeom>
-          <a:noFill/>
-          <a:ln/>
-        </p:spPr>
-        <p:txBody>
-          <a:bodyPr wrap="square" lIns="0" tIns="0" rIns="0" bIns="0" rtlCol="0" anchor="ctr"/>
-          <a:lstStyle/>
-          <a:p>
-            <a:pPr algn="ctr" indent="0" marL="0">
-              <a:buNone/>
-            </a:pPr>
-            <a:r>
-              <a:rPr lang="en-US" sz="1100" b="1" dirty="0">
-                <a:solidFill>
-                  <a:srgbClr val="111111"/>
-                </a:solidFill>
-              </a:rPr>
-              <a:t>1. Bienvenida</a:t>
-            </a:r>
-            <a:endParaRPr lang="en-US" sz="1100" dirty="0"/>
-          </a:p>
-        </p:txBody>
-      </p:sp>
-      <p:sp>
-        <p:nvSpPr>
-          <p:cNvPr id="5" name="Shape 3"/>
+          <p:cNvPr id="4" name="Shape 2"/>
           <p:cNvSpPr/>
           <p:nvPr/>
         </p:nvSpPr>
         <p:spPr>
           <a:xfrm>
-            <a:off x="402336" y="1088136"/>
-            <a:ext cx="1757540" cy="3675888"/>
-          </a:xfrm>
-          <a:prstGeom prst="roundRect">
-            <a:avLst>
-              <a:gd name="adj" fmla="val 7284"/>
-            </a:avLst>
+            <a:off x="658368" y="1207008"/>
+            <a:ext cx="457200" cy="457200"/>
+          </a:xfrm>
+          <a:prstGeom prst="ellipse">
+            <a:avLst/>
           </a:prstGeom>
           <a:solidFill>
-            <a:srgbClr val="2B2B2B"/>
+            <a:srgbClr val="111111"/>
           </a:solidFill>
           <a:ln w="12700">
             <a:solidFill>
-              <a:srgbClr val="2B2B2B"/>
+              <a:srgbClr val="111111"/>
             </a:solidFill>
             <a:prstDash val="solid"/>
           </a:ln>
@@ -10014,7 +10973,7 @@
       </p:sp>
       <p:pic>
         <p:nvPicPr>
-          <p:cNvPr id="6" name="Image 0" descr="/mnt/user-data/uploads/Capturas_Presentacion/01 - Bienvenida.jpg">    </p:cNvPr>
+          <p:cNvPr id="5" name="Image 0" descr="preencoded.png">    </p:cNvPr>
           <p:cNvPicPr>
             <a:picLocks noChangeAspect="1"/>
           </p:cNvPicPr>
@@ -10028,8 +10987,8 @@
         </p:blipFill>
         <p:spPr>
           <a:xfrm>
-            <a:off x="457200" y="1143000"/>
-            <a:ext cx="1647812" cy="3566160"/>
+            <a:off x="772668" y="1321308"/>
+            <a:ext cx="228600" cy="228600"/>
           </a:xfrm>
           <a:prstGeom prst="rect">
             <a:avLst/>
@@ -10038,26 +10997,180 @@
       </p:pic>
       <p:sp>
         <p:nvSpPr>
-          <p:cNvPr id="7" name="Shape 4"/>
+          <p:cNvPr id="6" name="Text 3"/>
+          <p:cNvSpPr txBox="1"/>
+          <p:nvPr/>
+        </p:nvSpPr>
+        <p:spPr>
+          <a:xfrm>
+            <a:off x="1234440" y="1207008"/>
+            <a:ext cx="1737360" cy="457200"/>
+          </a:xfrm>
+          <a:prstGeom prst="rect">
+            <a:avLst/>
+          </a:prstGeom>
+          <a:noFill/>
+          <a:ln/>
+        </p:spPr>
+        <p:txBody>
+          <a:bodyPr wrap="square" lIns="0" tIns="0" rIns="0" bIns="0" rtlCol="0" anchor="ctr"/>
+          <a:lstStyle/>
+          <a:p>
+            <a:pPr indent="0" marL="0">
+              <a:buNone/>
+            </a:pPr>
+            <a:r>
+              <a:rPr lang="en-US" sz="1500" b="1" dirty="0">
+                <a:solidFill>
+                  <a:srgbClr val="111111"/>
+                </a:solidFill>
+                <a:latin typeface="Arial" pitchFamily="34" charset="0"/>
+                <a:ea typeface="Arial" pitchFamily="34" charset="-122"/>
+                <a:cs typeface="Arial" pitchFamily="34" charset="-120"/>
+              </a:rPr>
+              <a:t>Propuesta de valor</a:t>
+            </a:r>
+            <a:endParaRPr lang="en-US" sz="1500" dirty="0"/>
+          </a:p>
+        </p:txBody>
+      </p:sp>
+      <p:sp>
+        <p:nvSpPr>
+          <p:cNvPr id="7" name="Text 4"/>
+          <p:cNvSpPr txBox="1"/>
+          <p:nvPr/>
+        </p:nvSpPr>
+        <p:spPr>
+          <a:xfrm>
+            <a:off x="658368" y="1874520"/>
+            <a:ext cx="2240280" cy="2606040"/>
+          </a:xfrm>
+          <a:prstGeom prst="rect">
+            <a:avLst/>
+          </a:prstGeom>
+          <a:noFill/>
+          <a:ln/>
+        </p:spPr>
+        <p:txBody>
+          <a:bodyPr wrap="square" lIns="0" tIns="0" rIns="0" bIns="0" rtlCol="0" anchor="t"/>
+          <a:lstStyle/>
+          <a:p>
+            <a:pPr indent="0" marL="0">
+              <a:spcAft>
+                <a:spcPts val="1200"/>
+              </a:spcAft>
+              <a:buNone/>
+            </a:pPr>
+            <a:r>
+              <a:rPr lang="en-US" sz="1400" b="1" dirty="0">
+                <a:solidFill>
+                  <a:srgbClr val="111111"/>
+                </a:solidFill>
+              </a:rPr>
+              <a:t>Para el local: </a:t>
+            </a:r>
+            <a:pPr indent="0" marL="0">
+              <a:spcAft>
+                <a:spcPts val="1200"/>
+              </a:spcAft>
+              <a:buNone/>
+            </a:pPr>
+            <a:r>
+              <a:rPr lang="en-US" sz="1400" dirty="0">
+                <a:solidFill>
+                  <a:srgbClr val="111111"/>
+                </a:solidFill>
+              </a:rPr>
+              <a:t>reemplaza la tarjeta de papel y evita sellos falsos.</a:t>
+            </a:r>
+            <a:endParaRPr lang="en-US" sz="1400" dirty="0"/>
+          </a:p>
+          <a:p>
+            <a:pPr indent="0" marL="0">
+              <a:spcAft>
+                <a:spcPts val="1200"/>
+              </a:spcAft>
+              <a:buNone/>
+            </a:pPr>
+            <a:r>
+              <a:rPr lang="en-US" sz="1400" b="1" dirty="0">
+                <a:solidFill>
+                  <a:srgbClr val="111111"/>
+                </a:solidFill>
+              </a:rPr>
+              <a:t>Para el local: </a:t>
+            </a:r>
+            <a:pPr indent="0" marL="0">
+              <a:spcAft>
+                <a:spcPts val="1200"/>
+              </a:spcAft>
+              <a:buNone/>
+            </a:pPr>
+            <a:r>
+              <a:rPr lang="en-US" sz="1400" dirty="0">
+                <a:solidFill>
+                  <a:srgbClr val="111111"/>
+                </a:solidFill>
+              </a:rPr>
+              <a:t>muestra quién vuelve y qué premio funciona.</a:t>
+            </a:r>
+            <a:endParaRPr lang="en-US" sz="1400" dirty="0"/>
+          </a:p>
+          <a:p>
+            <a:pPr indent="0" marL="0">
+              <a:spcAft>
+                <a:spcPts val="1200"/>
+              </a:spcAft>
+              <a:buNone/>
+            </a:pPr>
+            <a:r>
+              <a:rPr lang="en-US" sz="1400" b="1" dirty="0">
+                <a:solidFill>
+                  <a:srgbClr val="111111"/>
+                </a:solidFill>
+              </a:rPr>
+              <a:t>Para el cliente: </a:t>
+            </a:r>
+            <a:pPr indent="0" marL="0">
+              <a:spcAft>
+                <a:spcPts val="1200"/>
+              </a:spcAft>
+              <a:buNone/>
+            </a:pPr>
+            <a:r>
+              <a:rPr lang="en-US" sz="1400" dirty="0">
+                <a:solidFill>
+                  <a:srgbClr val="111111"/>
+                </a:solidFill>
+              </a:rPr>
+              <a:t>premios por volver, sin tarjeta que perder.</a:t>
+            </a:r>
+            <a:endParaRPr lang="en-US" sz="1400" dirty="0"/>
+          </a:p>
+        </p:txBody>
+      </p:sp>
+      <p:sp>
+        <p:nvSpPr>
+          <p:cNvPr id="8" name="Shape 5"/>
           <p:cNvSpPr/>
           <p:nvPr/>
         </p:nvSpPr>
         <p:spPr>
           <a:xfrm>
-            <a:off x="2596265" y="813816"/>
-            <a:ext cx="1757540" cy="256032"/>
+            <a:off x="3246120" y="1051560"/>
+            <a:ext cx="2606040" cy="3520440"/>
           </a:xfrm>
           <a:prstGeom prst="roundRect">
             <a:avLst>
-              <a:gd name="adj" fmla="val 21429"/>
+              <a:gd name="adj" fmla="val 2807"/>
             </a:avLst>
           </a:prstGeom>
           <a:solidFill>
-            <a:srgbClr val="F5C400"/>
+            <a:srgbClr val="F2F2F2"/>
           </a:solidFill>
           <a:ln w="12700">
             <a:solidFill>
-              <a:srgbClr val="F5C400"/>
+              <a:srgbClr val="F2F2F2"/>
             </a:solidFill>
             <a:prstDash val="solid"/>
           </a:ln>
@@ -10065,62 +11178,24 @@
       </p:sp>
       <p:sp>
         <p:nvSpPr>
-          <p:cNvPr id="8" name="Text 5"/>
-          <p:cNvSpPr txBox="1"/>
-          <p:nvPr/>
-        </p:nvSpPr>
-        <p:spPr>
-          <a:xfrm>
-            <a:off x="2596265" y="813816"/>
-            <a:ext cx="1757540" cy="256032"/>
-          </a:xfrm>
-          <a:prstGeom prst="rect">
-            <a:avLst/>
-          </a:prstGeom>
-          <a:noFill/>
-          <a:ln/>
-        </p:spPr>
-        <p:txBody>
-          <a:bodyPr wrap="square" lIns="0" tIns="0" rIns="0" bIns="0" rtlCol="0" anchor="ctr"/>
-          <a:lstStyle/>
-          <a:p>
-            <a:pPr algn="ctr" indent="0" marL="0">
-              <a:buNone/>
-            </a:pPr>
-            <a:r>
-              <a:rPr lang="en-US" sz="1100" b="1" dirty="0">
-                <a:solidFill>
-                  <a:srgbClr val="111111"/>
-                </a:solidFill>
-              </a:rPr>
-              <a:t>2. Tarjeta de socio</a:t>
-            </a:r>
-            <a:endParaRPr lang="en-US" sz="1100" dirty="0"/>
-          </a:p>
-        </p:txBody>
-      </p:sp>
-      <p:sp>
-        <p:nvSpPr>
           <p:cNvPr id="9" name="Shape 6"/>
           <p:cNvSpPr/>
           <p:nvPr/>
         </p:nvSpPr>
         <p:spPr>
           <a:xfrm>
-            <a:off x="2596265" y="1088136"/>
-            <a:ext cx="1757540" cy="3675888"/>
-          </a:xfrm>
-          <a:prstGeom prst="roundRect">
-            <a:avLst>
-              <a:gd name="adj" fmla="val 7284"/>
-            </a:avLst>
+            <a:off x="3447288" y="1207008"/>
+            <a:ext cx="457200" cy="457200"/>
+          </a:xfrm>
+          <a:prstGeom prst="ellipse">
+            <a:avLst/>
           </a:prstGeom>
           <a:solidFill>
-            <a:srgbClr val="2B2B2B"/>
+            <a:srgbClr val="111111"/>
           </a:solidFill>
           <a:ln w="12700">
             <a:solidFill>
-              <a:srgbClr val="2B2B2B"/>
+              <a:srgbClr val="111111"/>
             </a:solidFill>
             <a:prstDash val="solid"/>
           </a:ln>
@@ -10128,7 +11203,7 @@
       </p:sp>
       <p:pic>
         <p:nvPicPr>
-          <p:cNvPr id="10" name="Image 1" descr="/mnt/user-data/uploads/Capturas_Presentacion/02 - Tarjeta de socio.jpg">    </p:cNvPr>
+          <p:cNvPr id="10" name="Image 1" descr="preencoded.png">    </p:cNvPr>
           <p:cNvPicPr>
             <a:picLocks noChangeAspect="1"/>
           </p:cNvPicPr>
@@ -10142,8 +11217,8 @@
         </p:blipFill>
         <p:spPr>
           <a:xfrm>
-            <a:off x="2651129" y="1143000"/>
-            <a:ext cx="1647812" cy="3566160"/>
+            <a:off x="3561588" y="1321308"/>
+            <a:ext cx="228600" cy="228600"/>
           </a:xfrm>
           <a:prstGeom prst="rect">
             <a:avLst/>
@@ -10152,26 +11227,211 @@
       </p:pic>
       <p:sp>
         <p:nvSpPr>
-          <p:cNvPr id="11" name="Shape 7"/>
+          <p:cNvPr id="11" name="Text 7"/>
+          <p:cNvSpPr txBox="1"/>
+          <p:nvPr/>
+        </p:nvSpPr>
+        <p:spPr>
+          <a:xfrm>
+            <a:off x="4023360" y="1207008"/>
+            <a:ext cx="1737360" cy="457200"/>
+          </a:xfrm>
+          <a:prstGeom prst="rect">
+            <a:avLst/>
+          </a:prstGeom>
+          <a:noFill/>
+          <a:ln/>
+        </p:spPr>
+        <p:txBody>
+          <a:bodyPr wrap="square" lIns="0" tIns="0" rIns="0" bIns="0" rtlCol="0" anchor="ctr"/>
+          <a:lstStyle/>
+          <a:p>
+            <a:pPr indent="0" marL="0">
+              <a:buNone/>
+            </a:pPr>
+            <a:r>
+              <a:rPr lang="en-US" sz="1500" b="1" dirty="0">
+                <a:solidFill>
+                  <a:srgbClr val="111111"/>
+                </a:solidFill>
+                <a:latin typeface="Arial" pitchFamily="34" charset="0"/>
+                <a:ea typeface="Arial" pitchFamily="34" charset="-122"/>
+                <a:cs typeface="Arial" pitchFamily="34" charset="-120"/>
+              </a:rPr>
+              <a:t>Clientes y usuarios</a:t>
+            </a:r>
+            <a:endParaRPr lang="en-US" sz="1500" dirty="0"/>
+          </a:p>
+        </p:txBody>
+      </p:sp>
+      <p:sp>
+        <p:nvSpPr>
+          <p:cNvPr id="12" name="Text 8"/>
+          <p:cNvSpPr txBox="1"/>
+          <p:nvPr/>
+        </p:nvSpPr>
+        <p:spPr>
+          <a:xfrm>
+            <a:off x="3447288" y="1874520"/>
+            <a:ext cx="2240280" cy="2606040"/>
+          </a:xfrm>
+          <a:prstGeom prst="rect">
+            <a:avLst/>
+          </a:prstGeom>
+          <a:noFill/>
+          <a:ln/>
+        </p:spPr>
+        <p:txBody>
+          <a:bodyPr wrap="square" lIns="0" tIns="0" rIns="0" bIns="0" rtlCol="0" anchor="t"/>
+          <a:lstStyle/>
+          <a:p>
+            <a:pPr indent="0" marL="0">
+              <a:spcAft>
+                <a:spcPts val="1200"/>
+              </a:spcAft>
+              <a:buNone/>
+            </a:pPr>
+            <a:r>
+              <a:rPr lang="en-US" sz="1400" b="1" dirty="0">
+                <a:solidFill>
+                  <a:srgbClr val="111111"/>
+                </a:solidFill>
+              </a:rPr>
+              <a:t>Paga: </a:t>
+            </a:r>
+            <a:pPr indent="0" marL="0">
+              <a:spcAft>
+                <a:spcPts val="1200"/>
+              </a:spcAft>
+              <a:buNone/>
+            </a:pPr>
+            <a:r>
+              <a:rPr lang="en-US" sz="1400" dirty="0">
+                <a:solidFill>
+                  <a:srgbClr val="111111"/>
+                </a:solidFill>
+              </a:rPr>
+              <a:t>Clancy's Cork.</a:t>
+            </a:r>
+            <a:endParaRPr lang="en-US" sz="1400" dirty="0"/>
+          </a:p>
+          <a:p>
+            <a:pPr indent="0" marL="0">
+              <a:spcAft>
+                <a:spcPts val="1200"/>
+              </a:spcAft>
+              <a:buNone/>
+            </a:pPr>
+            <a:r>
+              <a:rPr lang="en-US" sz="1400" b="1" dirty="0">
+                <a:solidFill>
+                  <a:srgbClr val="111111"/>
+                </a:solidFill>
+              </a:rPr>
+              <a:t>La usan: </a:t>
+            </a:r>
+            <a:pPr indent="0" marL="0">
+              <a:spcAft>
+                <a:spcPts val="1200"/>
+              </a:spcAft>
+              <a:buNone/>
+            </a:pPr>
+            <a:r>
+              <a:rPr lang="en-US" sz="1400" dirty="0">
+                <a:solidFill>
+                  <a:srgbClr val="111111"/>
+                </a:solidFill>
+              </a:rPr>
+              <a:t>clientes del local, meseros y administración.</a:t>
+            </a:r>
+            <a:endParaRPr lang="en-US" sz="1400" dirty="0"/>
+          </a:p>
+          <a:p>
+            <a:pPr indent="0" marL="0">
+              <a:spcAft>
+                <a:spcPts val="1200"/>
+              </a:spcAft>
+              <a:buNone/>
+            </a:pPr>
+            <a:r>
+              <a:rPr lang="en-US" sz="1400" b="1" dirty="0">
+                <a:solidFill>
+                  <a:srgbClr val="111111"/>
+                </a:solidFill>
+              </a:rPr>
+              <a:t>Sus clientes: </a:t>
+            </a:r>
+            <a:pPr indent="0" marL="0">
+              <a:spcAft>
+                <a:spcPts val="1200"/>
+              </a:spcAft>
+              <a:buNone/>
+            </a:pPr>
+            <a:r>
+              <a:rPr lang="en-US" sz="1400" dirty="0">
+                <a:solidFill>
+                  <a:srgbClr val="111111"/>
+                </a:solidFill>
+              </a:rPr>
+              <a:t>gente de Cork y turistas que visitan el pub.</a:t>
+            </a:r>
+            <a:endParaRPr lang="en-US" sz="1400" dirty="0"/>
+          </a:p>
+          <a:p>
+            <a:pPr indent="0" marL="0">
+              <a:spcAft>
+                <a:spcPts val="1200"/>
+              </a:spcAft>
+              <a:buNone/>
+            </a:pPr>
+            <a:r>
+              <a:rPr lang="en-US" sz="1400" b="1" dirty="0">
+                <a:solidFill>
+                  <a:srgbClr val="111111"/>
+                </a:solidFill>
+              </a:rPr>
+              <a:t>A futuro: </a:t>
+            </a:r>
+            <a:pPr indent="0" marL="0">
+              <a:spcAft>
+                <a:spcPts val="1200"/>
+              </a:spcAft>
+              <a:buNone/>
+            </a:pPr>
+            <a:r>
+              <a:rPr lang="en-US" sz="1400" dirty="0">
+                <a:solidFill>
+                  <a:srgbClr val="111111"/>
+                </a:solidFill>
+              </a:rPr>
+              <a:t>otros bares.</a:t>
+            </a:r>
+            <a:endParaRPr lang="en-US" sz="1400" dirty="0"/>
+          </a:p>
+        </p:txBody>
+      </p:sp>
+      <p:sp>
+        <p:nvSpPr>
+          <p:cNvPr id="13" name="Shape 9"/>
           <p:cNvSpPr/>
           <p:nvPr/>
         </p:nvSpPr>
         <p:spPr>
           <a:xfrm>
-            <a:off x="4790195" y="813816"/>
-            <a:ext cx="1757540" cy="256032"/>
+            <a:off x="6035040" y="1051560"/>
+            <a:ext cx="2651760" cy="3520440"/>
           </a:xfrm>
           <a:prstGeom prst="roundRect">
             <a:avLst>
-              <a:gd name="adj" fmla="val 21429"/>
+              <a:gd name="adj" fmla="val 2759"/>
             </a:avLst>
           </a:prstGeom>
           <a:solidFill>
-            <a:srgbClr val="F5C400"/>
+            <a:srgbClr val="111111"/>
           </a:solidFill>
           <a:ln w="12700">
             <a:solidFill>
-              <a:srgbClr val="F5C400"/>
+              <a:srgbClr val="111111"/>
             </a:solidFill>
             <a:prstDash val="solid"/>
           </a:ln>
@@ -10179,205 +11439,229 @@
       </p:sp>
       <p:sp>
         <p:nvSpPr>
-          <p:cNvPr id="12" name="Text 8"/>
-          <p:cNvSpPr txBox="1"/>
-          <p:nvPr/>
-        </p:nvSpPr>
-        <p:spPr>
-          <a:xfrm>
-            <a:off x="4790195" y="813816"/>
-            <a:ext cx="1757540" cy="256032"/>
-          </a:xfrm>
-          <a:prstGeom prst="rect">
-            <a:avLst/>
-          </a:prstGeom>
-          <a:noFill/>
-          <a:ln/>
-        </p:spPr>
-        <p:txBody>
-          <a:bodyPr wrap="square" lIns="0" tIns="0" rIns="0" bIns="0" rtlCol="0" anchor="ctr"/>
-          <a:lstStyle/>
-          <a:p>
-            <a:pPr algn="ctr" indent="0" marL="0">
-              <a:buNone/>
-            </a:pPr>
-            <a:r>
-              <a:rPr lang="en-US" sz="1100" b="1" dirty="0">
-                <a:solidFill>
-                  <a:srgbClr val="111111"/>
-                </a:solidFill>
-              </a:rPr>
-              <a:t>3. QR de un solo uso</a:t>
-            </a:r>
-            <a:endParaRPr lang="en-US" sz="1100" dirty="0"/>
-          </a:p>
-        </p:txBody>
-      </p:sp>
-      <p:sp>
-        <p:nvSpPr>
-          <p:cNvPr id="13" name="Shape 9"/>
-          <p:cNvSpPr/>
-          <p:nvPr/>
-        </p:nvSpPr>
-        <p:spPr>
-          <a:xfrm>
-            <a:off x="4790195" y="1088136"/>
-            <a:ext cx="1757540" cy="3675888"/>
-          </a:xfrm>
-          <a:prstGeom prst="roundRect">
-            <a:avLst>
-              <a:gd name="adj" fmla="val 7284"/>
-            </a:avLst>
-          </a:prstGeom>
-          <a:solidFill>
-            <a:srgbClr val="2B2B2B"/>
-          </a:solidFill>
-          <a:ln w="12700">
-            <a:solidFill>
-              <a:srgbClr val="2B2B2B"/>
-            </a:solidFill>
-            <a:prstDash val="solid"/>
-          </a:ln>
-        </p:spPr>
-      </p:sp>
-      <p:pic>
-        <p:nvPicPr>
-          <p:cNvPr id="14" name="Image 2" descr="/mnt/user-data/uploads/Capturas_Presentacion/03 - Pase QR del cliente.jpg">    </p:cNvPr>
-          <p:cNvPicPr>
-            <a:picLocks noChangeAspect="1"/>
-          </p:cNvPicPr>
-          <p:nvPr/>
-        </p:nvPicPr>
-        <p:blipFill>
-          <a:blip r:embed="rId3"/>
-          <a:stretch>
-            <a:fillRect/>
-          </a:stretch>
-        </p:blipFill>
-        <p:spPr>
-          <a:xfrm>
-            <a:off x="4845059" y="1143000"/>
-            <a:ext cx="1647812" cy="3566160"/>
-          </a:xfrm>
-          <a:prstGeom prst="rect">
-            <a:avLst/>
-          </a:prstGeom>
-        </p:spPr>
-      </p:pic>
-      <p:sp>
-        <p:nvSpPr>
-          <p:cNvPr id="15" name="Shape 10"/>
-          <p:cNvSpPr/>
-          <p:nvPr/>
-        </p:nvSpPr>
-        <p:spPr>
-          <a:xfrm>
-            <a:off x="6984124" y="813816"/>
-            <a:ext cx="1757540" cy="256032"/>
-          </a:xfrm>
-          <a:prstGeom prst="roundRect">
-            <a:avLst>
-              <a:gd name="adj" fmla="val 21429"/>
-            </a:avLst>
-          </a:prstGeom>
-          <a:solidFill>
-            <a:srgbClr val="F5C400"/>
-          </a:solidFill>
-          <a:ln w="12700">
-            <a:solidFill>
-              <a:srgbClr val="F5C400"/>
-            </a:solidFill>
-            <a:prstDash val="solid"/>
-          </a:ln>
-        </p:spPr>
-      </p:sp>
-      <p:sp>
-        <p:nvSpPr>
-          <p:cNvPr id="16" name="Text 11"/>
-          <p:cNvSpPr txBox="1"/>
-          <p:nvPr/>
-        </p:nvSpPr>
-        <p:spPr>
-          <a:xfrm>
-            <a:off x="6984124" y="813816"/>
-            <a:ext cx="1757540" cy="256032"/>
-          </a:xfrm>
-          <a:prstGeom prst="rect">
-            <a:avLst/>
-          </a:prstGeom>
-          <a:noFill/>
-          <a:ln/>
-        </p:spPr>
-        <p:txBody>
-          <a:bodyPr wrap="square" lIns="0" tIns="0" rIns="0" bIns="0" rtlCol="0" anchor="ctr"/>
-          <a:lstStyle/>
-          <a:p>
-            <a:pPr algn="ctr" indent="0" marL="0">
-              <a:buNone/>
-            </a:pPr>
-            <a:r>
-              <a:rPr lang="en-US" sz="1100" b="1" dirty="0">
-                <a:solidFill>
-                  <a:srgbClr val="111111"/>
-                </a:solidFill>
-              </a:rPr>
-              <a:t>4. Premios</a:t>
-            </a:r>
-            <a:endParaRPr lang="en-US" sz="1100" dirty="0"/>
-          </a:p>
-        </p:txBody>
-      </p:sp>
-      <p:sp>
-        <p:nvSpPr>
-          <p:cNvPr id="17" name="Shape 12"/>
-          <p:cNvSpPr/>
-          <p:nvPr/>
-        </p:nvSpPr>
-        <p:spPr>
-          <a:xfrm>
-            <a:off x="6984124" y="1088136"/>
-            <a:ext cx="1757540" cy="3675888"/>
-          </a:xfrm>
-          <a:prstGeom prst="roundRect">
-            <a:avLst>
-              <a:gd name="adj" fmla="val 7284"/>
-            </a:avLst>
-          </a:prstGeom>
-          <a:solidFill>
-            <a:srgbClr val="2B2B2B"/>
-          </a:solidFill>
-          <a:ln w="12700">
-            <a:solidFill>
-              <a:srgbClr val="2B2B2B"/>
-            </a:solidFill>
-            <a:prstDash val="solid"/>
-          </a:ln>
-        </p:spPr>
-      </p:sp>
-      <p:pic>
-        <p:nvPicPr>
-          <p:cNvPr id="18" name="Image 3" descr="/mnt/user-data/uploads/Capturas_Presentacion/06 - Recompensas del cliente.jpg">    </p:cNvPr>
-          <p:cNvPicPr>
-            <a:picLocks noChangeAspect="1"/>
-          </p:cNvPicPr>
-          <p:nvPr/>
-        </p:nvPicPr>
-        <p:blipFill>
-          <a:blip r:embed="rId4"/>
-          <a:stretch>
-            <a:fillRect/>
-          </a:stretch>
-        </p:blipFill>
-        <p:spPr>
-          <a:xfrm>
-            <a:off x="7038988" y="1143000"/>
-            <a:ext cx="1647812" cy="3566160"/>
-          </a:xfrm>
-          <a:prstGeom prst="rect">
-            <a:avLst/>
-          </a:prstGeom>
-        </p:spPr>
-      </p:pic>
+          <p:cNvPr id="14" name="Text 10"/>
+          <p:cNvSpPr txBox="1"/>
+          <p:nvPr/>
+        </p:nvSpPr>
+        <p:spPr>
+          <a:xfrm>
+            <a:off x="6236208" y="1188720"/>
+            <a:ext cx="2286000" cy="320040"/>
+          </a:xfrm>
+          <a:prstGeom prst="rect">
+            <a:avLst/>
+          </a:prstGeom>
+          <a:noFill/>
+          <a:ln/>
+        </p:spPr>
+        <p:txBody>
+          <a:bodyPr wrap="square" lIns="0" tIns="0" rIns="0" bIns="0" rtlCol="0" anchor="t"/>
+          <a:lstStyle/>
+          <a:p>
+            <a:pPr indent="0" marL="0">
+              <a:buNone/>
+            </a:pPr>
+            <a:r>
+              <a:rPr lang="en-US" sz="1500" b="1" dirty="0">
+                <a:solidFill>
+                  <a:srgbClr val="F5C400"/>
+                </a:solidFill>
+                <a:latin typeface="Arial" pitchFamily="34" charset="0"/>
+                <a:ea typeface="Arial" pitchFamily="34" charset="-122"/>
+                <a:cs typeface="Arial" pitchFamily="34" charset="-120"/>
+              </a:rPr>
+              <a:t>Sostenibilidad</a:t>
+            </a:r>
+            <a:endParaRPr lang="en-US" sz="1500" dirty="0"/>
+          </a:p>
+        </p:txBody>
+      </p:sp>
+      <p:sp>
+        <p:nvSpPr>
+          <p:cNvPr id="15" name="Text 11"/>
+          <p:cNvSpPr txBox="1"/>
+          <p:nvPr/>
+        </p:nvSpPr>
+        <p:spPr>
+          <a:xfrm>
+            <a:off x="6236208" y="1554480"/>
+            <a:ext cx="2286000" cy="548640"/>
+          </a:xfrm>
+          <a:prstGeom prst="rect">
+            <a:avLst/>
+          </a:prstGeom>
+          <a:noFill/>
+          <a:ln/>
+        </p:spPr>
+        <p:txBody>
+          <a:bodyPr wrap="square" lIns="0" tIns="0" rIns="0" bIns="0" rtlCol="0" anchor="t"/>
+          <a:lstStyle/>
+          <a:p>
+            <a:pPr indent="0" marL="0">
+              <a:buNone/>
+            </a:pPr>
+            <a:r>
+              <a:rPr lang="en-US" sz="3200" b="1" dirty="0">
+                <a:solidFill>
+                  <a:srgbClr val="FFFFFF"/>
+                </a:solidFill>
+                <a:latin typeface="Arial" pitchFamily="34" charset="0"/>
+                <a:ea typeface="Arial" pitchFamily="34" charset="-122"/>
+                <a:cs typeface="Arial" pitchFamily="34" charset="-120"/>
+              </a:rPr>
+              <a:t>€2.500</a:t>
+            </a:r>
+            <a:endParaRPr lang="en-US" sz="3200" dirty="0"/>
+          </a:p>
+        </p:txBody>
+      </p:sp>
+      <p:sp>
+        <p:nvSpPr>
+          <p:cNvPr id="16" name="Text 12"/>
+          <p:cNvSpPr txBox="1"/>
+          <p:nvPr/>
+        </p:nvSpPr>
+        <p:spPr>
+          <a:xfrm>
+            <a:off x="6236208" y="2103120"/>
+            <a:ext cx="2286000" cy="274320"/>
+          </a:xfrm>
+          <a:prstGeom prst="rect">
+            <a:avLst/>
+          </a:prstGeom>
+          <a:noFill/>
+          <a:ln/>
+        </p:spPr>
+        <p:txBody>
+          <a:bodyPr wrap="square" lIns="0" tIns="0" rIns="0" bIns="0" rtlCol="0" anchor="t"/>
+          <a:lstStyle/>
+          <a:p>
+            <a:pPr indent="0" marL="0">
+              <a:buNone/>
+            </a:pPr>
+            <a:r>
+              <a:rPr lang="en-US" sz="1200" dirty="0">
+                <a:solidFill>
+                  <a:srgbClr val="F5C400"/>
+                </a:solidFill>
+              </a:rPr>
+              <a:t>pago inicial para terminarla y publicarla</a:t>
+            </a:r>
+            <a:endParaRPr lang="en-US" sz="1200" dirty="0"/>
+          </a:p>
+        </p:txBody>
+      </p:sp>
+      <p:sp>
+        <p:nvSpPr>
+          <p:cNvPr id="17" name="Text 13"/>
+          <p:cNvSpPr txBox="1"/>
+          <p:nvPr/>
+        </p:nvSpPr>
+        <p:spPr>
+          <a:xfrm>
+            <a:off x="6236208" y="2514600"/>
+            <a:ext cx="2286000" cy="548640"/>
+          </a:xfrm>
+          <a:prstGeom prst="rect">
+            <a:avLst/>
+          </a:prstGeom>
+          <a:noFill/>
+          <a:ln/>
+        </p:spPr>
+        <p:txBody>
+          <a:bodyPr wrap="square" lIns="0" tIns="0" rIns="0" bIns="0" rtlCol="0" anchor="t"/>
+          <a:lstStyle/>
+          <a:p>
+            <a:pPr indent="0" marL="0">
+              <a:buNone/>
+            </a:pPr>
+            <a:r>
+              <a:rPr lang="en-US" sz="3200" b="1" dirty="0">
+                <a:solidFill>
+                  <a:srgbClr val="FFFFFF"/>
+                </a:solidFill>
+                <a:latin typeface="Arial" pitchFamily="34" charset="0"/>
+                <a:ea typeface="Arial" pitchFamily="34" charset="-122"/>
+                <a:cs typeface="Arial" pitchFamily="34" charset="-120"/>
+              </a:rPr>
+              <a:t>€75–90</a:t>
+            </a:r>
+            <a:endParaRPr lang="en-US" sz="3200" dirty="0"/>
+          </a:p>
+        </p:txBody>
+      </p:sp>
+      <p:sp>
+        <p:nvSpPr>
+          <p:cNvPr id="18" name="Text 14"/>
+          <p:cNvSpPr txBox="1"/>
+          <p:nvPr/>
+        </p:nvSpPr>
+        <p:spPr>
+          <a:xfrm>
+            <a:off x="6236208" y="3063240"/>
+            <a:ext cx="2286000" cy="274320"/>
+          </a:xfrm>
+          <a:prstGeom prst="rect">
+            <a:avLst/>
+          </a:prstGeom>
+          <a:noFill/>
+          <a:ln/>
+        </p:spPr>
+        <p:txBody>
+          <a:bodyPr wrap="square" lIns="0" tIns="0" rIns="0" bIns="0" rtlCol="0" anchor="t"/>
+          <a:lstStyle/>
+          <a:p>
+            <a:pPr indent="0" marL="0">
+              <a:buNone/>
+            </a:pPr>
+            <a:r>
+              <a:rPr lang="en-US" sz="1200" dirty="0">
+                <a:solidFill>
+                  <a:srgbClr val="F5C400"/>
+                </a:solidFill>
+              </a:rPr>
+              <a:t>por semana de mantención</a:t>
+            </a:r>
+            <a:endParaRPr lang="en-US" sz="1200" dirty="0"/>
+          </a:p>
+        </p:txBody>
+      </p:sp>
+      <p:sp>
+        <p:nvSpPr>
+          <p:cNvPr id="19" name="Text 15"/>
+          <p:cNvSpPr txBox="1"/>
+          <p:nvPr/>
+        </p:nvSpPr>
+        <p:spPr>
+          <a:xfrm>
+            <a:off x="6236208" y="3474720"/>
+            <a:ext cx="2286000" cy="1005840"/>
+          </a:xfrm>
+          <a:prstGeom prst="rect">
+            <a:avLst/>
+          </a:prstGeom>
+          <a:noFill/>
+          <a:ln/>
+        </p:spPr>
+        <p:txBody>
+          <a:bodyPr wrap="square" lIns="0" tIns="0" rIns="0" bIns="0" rtlCol="0" anchor="t"/>
+          <a:lstStyle/>
+          <a:p>
+            <a:pPr indent="0" marL="0">
+              <a:buNone/>
+            </a:pPr>
+            <a:r>
+              <a:rPr lang="en-US" sz="1200" dirty="0">
+                <a:solidFill>
+                  <a:srgbClr val="FFFFFF"/>
+                </a:solidFill>
+              </a:rPr>
+              <a:t>Publicar en las dos tiendas: Google Play 25 USD (una vez) y Apple 99 USD al año. Servidor y base de datos parten en plan gratuito.</a:t>
+            </a:r>
+            <a:endParaRPr lang="en-US" sz="1200" dirty="0"/>
+          </a:p>
+        </p:txBody>
+      </p:sp>
       <p:sp>
         <p:nvSpPr>
           <p:cNvPr id="25" name="Slide Number Placeholder 0"/>
@@ -10390,8 +11674,8 @@
         </p:nvSpPr>
         <p:spPr>
           <a:xfrm>
-            <a:off x="8229600" y="4800600"/>
-            <a:ext cx="457200" cy="228600"/>
+            <a:off x="8229600" y="4754880"/>
+            <a:ext cx="457200" cy="274320"/>
           </a:xfrm>
           <a:prstGeom prst="rect">
             <a:avLst/>
@@ -10408,7 +11692,7 @@
             <a:lvl1pPr>
               <a:defRPr sz="1000">
                 <a:solidFill>
-                  <a:srgbClr val="A6A6A6"/>
+                  <a:srgbClr val="6B6B6B"/>
                 </a:solidFill>
               </a:defRPr>
             </a:lvl1pPr>
@@ -10483,7 +11767,7 @@
                 <a:ea typeface="Arial" pitchFamily="34" charset="-122"/>
                 <a:cs typeface="Arial" pitchFamily="34" charset="-120"/>
               </a:rPr>
-              <a:t>Mockups de la app: el personal en el local</a:t>
+              <a:t>Mockups de la app: el cliente</a:t>
             </a:r>
             <a:endParaRPr lang="en-US" sz="2400" dirty="0"/>
           </a:p>
@@ -10546,7 +11830,7 @@
                   <a:srgbClr val="111111"/>
                 </a:solidFill>
               </a:rPr>
-              <a:t>1. Escáner</a:t>
+              <a:t>1. Bienvenida</a:t>
             </a:r>
             <a:endParaRPr lang="en-US" sz="1100" dirty="0"/>
           </a:p>
@@ -10581,7 +11865,7 @@
       </p:sp>
       <p:pic>
         <p:nvPicPr>
-          <p:cNvPr id="6" name="Image 0" descr="/mnt/user-data/uploads/Capturas_Presentacion/04 - Escaner del mesero.jpg">    </p:cNvPr>
+          <p:cNvPr id="6" name="Image 0" descr="/mnt/user-data/uploads/Capturas_Presentacion/01 - Bienvenida.jpg">    </p:cNvPr>
           <p:cNvPicPr>
             <a:picLocks noChangeAspect="1"/>
           </p:cNvPicPr>
@@ -10660,7 +11944,7 @@
                   <a:srgbClr val="111111"/>
                 </a:solidFill>
               </a:rPr>
-              <a:t>2. Visita sumada</a:t>
+              <a:t>2. Tarjeta de socio</a:t>
             </a:r>
             <a:endParaRPr lang="en-US" sz="1100" dirty="0"/>
           </a:p>
@@ -10695,7 +11979,7 @@
       </p:sp>
       <p:pic>
         <p:nvPicPr>
-          <p:cNvPr id="10" name="Image 1" descr="/mnt/user-data/uploads/Capturas_Presentacion/05 - Resultado de visita.jpg">    </p:cNvPr>
+          <p:cNvPr id="10" name="Image 1" descr="/mnt/user-data/uploads/Capturas_Presentacion/02 - Tarjeta de socio.jpg">    </p:cNvPr>
           <p:cNvPicPr>
             <a:picLocks noChangeAspect="1"/>
           </p:cNvPicPr>
@@ -10774,7 +12058,7 @@
                   <a:srgbClr val="111111"/>
                 </a:solidFill>
               </a:rPr>
-              <a:t>3. QR de canje</a:t>
+              <a:t>3. QR de un solo uso</a:t>
             </a:r>
             <a:endParaRPr lang="en-US" sz="1100" dirty="0"/>
           </a:p>
@@ -10809,7 +12093,7 @@
       </p:sp>
       <p:pic>
         <p:nvPicPr>
-          <p:cNvPr id="14" name="Image 2" descr="/mnt/user-data/uploads/Capturas_Presentacion/07 - QR de canje.jpg">    </p:cNvPr>
+          <p:cNvPr id="14" name="Image 2" descr="/mnt/user-data/uploads/Capturas_Presentacion/03 - Pase QR del cliente.jpg">    </p:cNvPr>
           <p:cNvPicPr>
             <a:picLocks noChangeAspect="1"/>
           </p:cNvPicPr>
@@ -10888,7 +12172,7 @@
                   <a:srgbClr val="111111"/>
                 </a:solidFill>
               </a:rPr>
-              <a:t>4. Entregar premio</a:t>
+              <a:t>4. Premios</a:t>
             </a:r>
             <a:endParaRPr lang="en-US" sz="1100" dirty="0"/>
           </a:p>
@@ -10923,7 +12207,7 @@
       </p:sp>
       <p:pic>
         <p:nvPicPr>
-          <p:cNvPr id="18" name="Image 3" descr="/mnt/user-data/uploads/Capturas_Presentacion/08 - Canje - entregar al cliente.jpg">    </p:cNvPr>
+          <p:cNvPr id="18" name="Image 3" descr="/mnt/user-data/uploads/Capturas_Presentacion/06 - Recompensas del cliente.jpg">    </p:cNvPr>
           <p:cNvPicPr>
             <a:picLocks noChangeAspect="1"/>
           </p:cNvPicPr>

</xml_diff>

<commit_message>
Reflejar la inscripción en Apple adelantada al Sprint 1
</commit_message>
<xml_diff>
--- a/Fase 2/Evidencias Proyecto/Presentación Proyecto.pptx
+++ b/Fase 2/Evidencias Proyecto/Presentación Proyecto.pptx
@@ -118,7 +118,7 @@
   <p:extLst>
     <p:ext uri="{521415D9-36F7-43E2-AB2F-B90AF26B5E84}">
       <p14:sectionLst xmlns:p14="http://schemas.microsoft.com/office/powerpoint/2010/main">
-        <p14:section name="Evaluación 2" id="{d68fcb68-8712-0bb7-1b48-41bf5127b62e}">
+        <p14:section name="Evaluación 2" id="{447fa549-7995-ebb3-169d-68e884676cc5}">
           <p14:sldIdLst>
             <p14:sldId id="256"/>
             <p14:sldId id="257"/>
@@ -1330,7 +1330,7 @@
           <a:p>
             <a:r>
               <a:rPr lang="en-US" dirty="0"/>
-              <a:t>La profesora me hizo ver que publicar solo en Google Play dejaba fuera a mucha gente: en Irlanda, casi la mitad de los teléfonos son iPhone. Por eso la app también se va a publicar en la App Store. Para compilar para iPhone normalmente se necesita un Mac, y no tengo uno. Pero como la app está hecha con Expo, se compila en la nube con EAS Build, se prueba en iPhones reales con TestFlight y después pasa la revisión de Apple. Si aparece un error que solo se arregla con Xcode, arriendo un Mac en la nube por horas. Apple además exige ofrecer inicio de sesión con Apple si hay login con Google, así que lo agregué al Sprint 2. El costo nuevo es la cuenta de Apple, noventa y nueve dólares al año, que entra en el presupuesto inicial.</a:t>
+              <a:t>La profesora me hizo ver que publicar solo en Google Play dejaba fuera a mucha gente: en Irlanda, casi la mitad de los teléfonos son iPhone. Por eso la app también se va a publicar en la App Store. Para compilar para iPhone normalmente se necesita un Mac, y no tengo uno. Pero como la app está hecha con Expo, se compila en la nube con EAS Build, se prueba en iPhones reales con TestFlight y después pasa la revisión de Apple. Si aparece un error que solo se arregla con Xcode, arriendo un Mac en la nube por horas. La cuenta de Apple la saco en el Sprint 1, porque su verificación puede tardar y bloquea todo lo de iOS. Apple además exige ofrecer inicio de sesión con Apple si hay login con Google, así que lo agregué al Sprint 2. El costo nuevo es la cuenta de Apple, noventa y nueve dólares al año, que entra en el presupuesto inicial.</a:t>
             </a:r>
             <a:endParaRPr lang="en-US" dirty="0"/>
           </a:p>
@@ -10577,7 +10577,7 @@
                   <a:srgbClr val="6B6B6B"/>
                 </a:solidFill>
               </a:rPr>
-              <a:t>al año, cuenta de Apple Developer</a:t>
+              <a:t>al año, cuenta de Apple (se inscribe en el Sprint 1)</a:t>
             </a:r>
             <a:endParaRPr lang="en-US" sz="1100" dirty="0"/>
           </a:p>

</xml_diff>

<commit_message>
Actualizar el avance del Sprint 1: CORS, límite de intentos y primeras pruebas
- Matriz de requisitos: RNF-05 implementado y RNF-11 parcial, con su evidencia.
- Informe de avance: fecha de corte 29 de octubre, estado del Sprint 1 y de las pruebas.
- Presentación: RNF-05 listo y línea de avance del Sprint 1.
- Arquitectura y README: seguridad aplicada y cómo correr las pruebas.
</commit_message>
<xml_diff>
--- a/Fase 2/Evidencias Proyecto/Presentación Proyecto.pptx
+++ b/Fase 2/Evidencias Proyecto/Presentación Proyecto.pptx
@@ -118,7 +118,7 @@
   <p:extLst>
     <p:ext uri="{521415D9-36F7-43E2-AB2F-B90AF26B5E84}">
       <p14:sectionLst xmlns:p14="http://schemas.microsoft.com/office/powerpoint/2010/main">
-        <p14:section name="Evaluación 2" id="{447fa549-7995-ebb3-169d-68e884676cc5}">
+        <p14:section name="Evaluación 2" id="{8a3d9c55-dc61-d26d-5c7f-b6dce6f0aab8}">
           <p14:sldIdLst>
             <p14:sldId id="256"/>
             <p14:sldId id="257"/>
@@ -1066,7 +1066,7 @@
           <a:p>
             <a:r>
               <a:rPr lang="en-US" dirty="0"/>
-              <a:t>Estos son los requisitos principales; la matriz completa, con veintiocho requisitos y sus criterios de aceptación, está en Excel en el repositorio. A la izquierda, los funcionales: registro, tarjeta de socio, QR de un solo uso, escaneo, canje en dos pasos y edición del menú y los premios. Todos ya funcionan. A la derecha, los no funcionales: la seguridad básica ya está, y lo que falta, como limitar intentos, la nube, la ley de datos europea y la publicación en las dos tiendas, ya tiene su sprint.</a:t>
+              <a:t>Estos son los requisitos principales; la matriz completa, con veintiocho requisitos y sus criterios de aceptación, está en Excel en el repositorio. A la izquierda, los funcionales: registro, tarjeta de socio, QR de un solo uso, escaneo, canje en dos pasos y edición del menú y los premios. Todos ya funcionan. A la derecha, los no funcionales: la seguridad básica ya está, y ya terminé el límite de intentos y CORS. Lo que falta, como la nube, la ley de datos europea y la publicación en las dos tiendas, ya tiene su sprint.</a:t>
             </a:r>
             <a:endParaRPr lang="en-US" dirty="0"/>
           </a:p>
@@ -5838,7 +5838,7 @@
                   <a:srgbClr val="111111"/>
                 </a:solidFill>
               </a:rPr>
-              <a:t>Registro e inicio de sesión con correo o Google</a:t>
+              <a:t>Registro e inicio de sesión con correo</a:t>
             </a:r>
             <a:endParaRPr lang="en-US" sz="1200" dirty="0"/>
           </a:p>
@@ -7007,11 +7007,11 @@
             </a:avLst>
           </a:prstGeom>
           <a:solidFill>
-            <a:srgbClr val="F5C400"/>
+            <a:srgbClr val="111111"/>
           </a:solidFill>
           <a:ln w="12700">
             <a:solidFill>
-              <a:srgbClr val="F5C400"/>
+              <a:srgbClr val="111111"/>
             </a:solidFill>
             <a:prstDash val="solid"/>
           </a:ln>
@@ -7044,10 +7044,10 @@
             <a:r>
               <a:rPr lang="en-US" sz="1000" b="1" dirty="0">
                 <a:solidFill>
-                  <a:srgbClr val="111111"/>
-                </a:solidFill>
-              </a:rPr>
-              <a:t>Sprint 1</a:t>
+                  <a:srgbClr val="F5C400"/>
+                </a:solidFill>
+              </a:rPr>
+              <a:t>Listo</a:t>
             </a:r>
             <a:endParaRPr lang="en-US" sz="1000" dirty="0"/>
           </a:p>
@@ -8403,7 +8403,7 @@
                   <a:srgbClr val="111111"/>
                 </a:solidFill>
               </a:rPr>
-              <a:t>Sprint 0 completado y Sprint 1 en curso. Backlog en GitHub: un milestone por sprint y un issue por tarea.</a:t>
+              <a:t>Sprint 0 completado. Sprint 1 en curso, con CORS y límite de intentos listos. Backlog en GitHub: un milestone por sprint y un issue por tarea.</a:t>
             </a:r>
             <a:endParaRPr lang="en-US" sz="1300" dirty="0"/>
           </a:p>

</xml_diff>

<commit_message>
Actualizar capturas de la app con la versión actual
Capturas nuevas del flujo completo (cliente, personal y administración)
tomadas el 29 de octubre. Se reemplazan en la presentación y en el anexo
del informe de avance; en ambos se usa la visita sumada en lugar de la
pantalla del escáner de la versión web.
</commit_message>
<xml_diff>
--- a/Fase 2/Evidencias Proyecto/Presentación Proyecto.pptx
+++ b/Fase 2/Evidencias Proyecto/Presentación Proyecto.pptx
@@ -118,7 +118,7 @@
   <p:extLst>
     <p:ext uri="{521415D9-36F7-43E2-AB2F-B90AF26B5E84}">
       <p14:sectionLst xmlns:p14="http://schemas.microsoft.com/office/powerpoint/2010/main">
-        <p14:section name="Evaluación 2" id="{8a3d9c55-dc61-d26d-5c7f-b6dce6f0aab8}">
+        <p14:section name="Evaluación 2" id="{9b539a90-19b0-7415-6be1-089134c58d51}">
           <p14:sldIdLst>
             <p14:sldId id="256"/>
             <p14:sldId id="257"/>
@@ -626,7 +626,7 @@
           <a:p>
             <a:r>
               <a:rPr lang="en-US" dirty="0"/>
-              <a:t>Esta es la parte del personal. El mesero abre el escáner y lee el QR del cliente con la cámara. La visita se suma al instante y la pantalla del cliente cambia sola. Para canjear, el cliente abre un QR de canje; el mesero lo escanea y el premio queda reservado. Cuando lo lleva a la mesa, confirma la entrega. Por eso el canje es en dos pasos.</a:t>
+              <a:t>Esta es la parte del personal. El cliente muestra su QR y el mesero lo lee con la cámara del teléfono. La visita se suma al instante y la pantalla del cliente cambia sola. Para canjear, el cliente abre un QR de canje; el mesero lo escanea y el premio queda reservado. Cuando lo lleva a la mesa, confirma la entrega. Por eso el canje es en dos pasos.</a:t>
             </a:r>
             <a:endParaRPr lang="en-US" dirty="0"/>
           </a:p>
@@ -1506,7 +1506,7 @@
           <a:p>
             <a:r>
               <a:rPr lang="en-US" dirty="0"/>
-              <a:t>Ahora les muestro las pantallas de la app. Esto es lo que ve el cliente. Primero la bienvenida, donde se registra o entra con Google. Después su tarjeta de socio, con las visitas que lleva y el próximo premio. Cuando llega al local, abre su QR, que dura tres minutos y sirve una sola vez. Y en premios ve todo lo que puede canjear.</a:t>
+              <a:t>Ahora les muestro las pantallas de la app. Esto es lo que ve el cliente. Primero la bienvenida, donde se registra o inicia sesión. Después su tarjeta de socio, con las visitas que lleva y el próximo premio. Cuando llega al local, abre su QR, que dura tres minutos y sirve una sola vez. Y en premios ve todo lo que puede canjear.</a:t>
             </a:r>
             <a:endParaRPr lang="en-US" dirty="0"/>
           </a:p>
@@ -2500,7 +2500,7 @@
       </p:sp>
       <p:pic>
         <p:nvPicPr>
-          <p:cNvPr id="7" name="Image 1" descr="/mnt/user-data/uploads/Capturas_Presentacion/01 - Bienvenida.jpg">    </p:cNvPr>
+          <p:cNvPr id="7" name="Image 1" descr="Captura de la app: Bienvenida">    </p:cNvPr>
           <p:cNvPicPr>
             <a:picLocks noChangeAspect="1"/>
           </p:cNvPicPr>
@@ -2551,7 +2551,7 @@
       </p:sp>
       <p:pic>
         <p:nvPicPr>
-          <p:cNvPr id="9" name="Image 2" descr="/mnt/user-data/uploads/Capturas_Presentacion/03 - Pase QR del cliente.jpg">    </p:cNvPr>
+          <p:cNvPr id="9" name="Image 2" descr="Captura de la app: Pase QR del cliente">    </p:cNvPr>
           <p:cNvPicPr>
             <a:picLocks noChangeAspect="1"/>
           </p:cNvPicPr>
@@ -2602,7 +2602,7 @@
       </p:sp>
       <p:pic>
         <p:nvPicPr>
-          <p:cNvPr id="11" name="Image 3" descr="/mnt/user-data/uploads/Capturas_Presentacion/02 - Tarjeta de socio.jpg">    </p:cNvPr>
+          <p:cNvPr id="11" name="Image 3" descr="Captura de la app: Tarjeta de socio">    </p:cNvPr>
           <p:cNvPicPr>
             <a:picLocks noChangeAspect="1"/>
           </p:cNvPicPr>
@@ -2822,7 +2822,7 @@
                   <a:srgbClr val="111111"/>
                 </a:solidFill>
               </a:rPr>
-              <a:t>1. Escáner</a:t>
+              <a:t>1. QR del cliente</a:t>
             </a:r>
             <a:endParaRPr lang="en-US" sz="1100" dirty="0"/>
           </a:p>
@@ -2857,7 +2857,7 @@
       </p:sp>
       <p:pic>
         <p:nvPicPr>
-          <p:cNvPr id="6" name="Image 0" descr="/mnt/user-data/uploads/Capturas_Presentacion/04 - Escaner del mesero.jpg">    </p:cNvPr>
+          <p:cNvPr id="6" name="Image 0" descr="Captura de la app: Pase QR del cliente">    </p:cNvPr>
           <p:cNvPicPr>
             <a:picLocks noChangeAspect="1"/>
           </p:cNvPicPr>
@@ -2971,7 +2971,7 @@
       </p:sp>
       <p:pic>
         <p:nvPicPr>
-          <p:cNvPr id="10" name="Image 1" descr="/mnt/user-data/uploads/Capturas_Presentacion/05 - Resultado de visita.jpg">    </p:cNvPr>
+          <p:cNvPr id="10" name="Image 1" descr="Captura de la app: Resultado de visita">    </p:cNvPr>
           <p:cNvPicPr>
             <a:picLocks noChangeAspect="1"/>
           </p:cNvPicPr>
@@ -3085,7 +3085,7 @@
       </p:sp>
       <p:pic>
         <p:nvPicPr>
-          <p:cNvPr id="14" name="Image 2" descr="/mnt/user-data/uploads/Capturas_Presentacion/07 - QR de canje.jpg">    </p:cNvPr>
+          <p:cNvPr id="14" name="Image 2" descr="Captura de la app: QR de canje">    </p:cNvPr>
           <p:cNvPicPr>
             <a:picLocks noChangeAspect="1"/>
           </p:cNvPicPr>
@@ -3199,7 +3199,7 @@
       </p:sp>
       <p:pic>
         <p:nvPicPr>
-          <p:cNvPr id="18" name="Image 3" descr="/mnt/user-data/uploads/Capturas_Presentacion/08 - Canje - entregar al cliente.jpg">    </p:cNvPr>
+          <p:cNvPr id="18" name="Image 3" descr="Captura de la app: Canje - entregar al cliente">    </p:cNvPr>
           <p:cNvPicPr>
             <a:picLocks noChangeAspect="1"/>
           </p:cNvPicPr>
@@ -3361,7 +3361,7 @@
       </p:sp>
       <p:pic>
         <p:nvPicPr>
-          <p:cNvPr id="4" name="Image 0" descr="/mnt/user-data/uploads/Capturas_Presentacion/10 - Panel del dueno.jpg">    </p:cNvPr>
+          <p:cNvPr id="4" name="Image 0" descr="Captura de la app: Panel del dueno">    </p:cNvPr>
           <p:cNvPicPr>
             <a:picLocks noChangeAspect="1"/>
           </p:cNvPicPr>
@@ -3412,7 +3412,7 @@
       </p:sp>
       <p:pic>
         <p:nvPicPr>
-          <p:cNvPr id="6" name="Image 1" descr="/mnt/user-data/uploads/Capturas_Presentacion/09 - Menu de la casa.jpg">    </p:cNvPr>
+          <p:cNvPr id="6" name="Image 1" descr="Captura de la app: Menu de la casa">    </p:cNvPr>
           <p:cNvPicPr>
             <a:picLocks noChangeAspect="1"/>
           </p:cNvPicPr>
@@ -4741,7 +4741,7 @@
       </p:sp>
       <p:pic>
         <p:nvPicPr>
-          <p:cNvPr id="5" name="Image 0" descr="/mnt/user-data/uploads/Capturas_Presentacion/03 - Pase QR del cliente.jpg">    </p:cNvPr>
+          <p:cNvPr id="5" name="Image 0" descr="Captura de la app: Pase QR del cliente">    </p:cNvPr>
           <p:cNvPicPr>
             <a:picLocks noChangeAspect="1"/>
           </p:cNvPicPr>
@@ -4894,7 +4894,7 @@
       </p:sp>
       <p:pic>
         <p:nvPicPr>
-          <p:cNvPr id="10" name="Image 1" descr="/mnt/user-data/uploads/Capturas_Presentacion/04 - Escaner del mesero.jpg">    </p:cNvPr>
+          <p:cNvPr id="10" name="Image 1" descr="Captura de la app: Resultado de visita">    </p:cNvPr>
           <p:cNvPicPr>
             <a:picLocks noChangeAspect="1"/>
           </p:cNvPicPr>
@@ -4985,7 +4985,7 @@
                   <a:srgbClr val="111111"/>
                 </a:solidFill>
               </a:rPr>
-              <a:t>Escanea el QR con la cámara del teléfono.</a:t>
+              <a:t>Escanea el QR del cliente y suma la visita al instante.</a:t>
             </a:r>
             <a:endParaRPr lang="en-US" sz="1300" dirty="0"/>
           </a:p>
@@ -5047,7 +5047,7 @@
       </p:sp>
       <p:pic>
         <p:nvPicPr>
-          <p:cNvPr id="15" name="Image 2" descr="/mnt/user-data/uploads/Capturas_Presentacion/10 - Panel del dueno.jpg">    </p:cNvPr>
+          <p:cNvPr id="15" name="Image 2" descr="Captura de la app: Panel del dueno">    </p:cNvPr>
           <p:cNvPicPr>
             <a:picLocks noChangeAspect="1"/>
           </p:cNvPicPr>
@@ -11865,7 +11865,7 @@
       </p:sp>
       <p:pic>
         <p:nvPicPr>
-          <p:cNvPr id="6" name="Image 0" descr="/mnt/user-data/uploads/Capturas_Presentacion/01 - Bienvenida.jpg">    </p:cNvPr>
+          <p:cNvPr id="6" name="Image 0" descr="Captura de la app: Bienvenida">    </p:cNvPr>
           <p:cNvPicPr>
             <a:picLocks noChangeAspect="1"/>
           </p:cNvPicPr>
@@ -11979,7 +11979,7 @@
       </p:sp>
       <p:pic>
         <p:nvPicPr>
-          <p:cNvPr id="10" name="Image 1" descr="/mnt/user-data/uploads/Capturas_Presentacion/02 - Tarjeta de socio.jpg">    </p:cNvPr>
+          <p:cNvPr id="10" name="Image 1" descr="Captura de la app: Tarjeta de socio">    </p:cNvPr>
           <p:cNvPicPr>
             <a:picLocks noChangeAspect="1"/>
           </p:cNvPicPr>
@@ -12093,7 +12093,7 @@
       </p:sp>
       <p:pic>
         <p:nvPicPr>
-          <p:cNvPr id="14" name="Image 2" descr="/mnt/user-data/uploads/Capturas_Presentacion/03 - Pase QR del cliente.jpg">    </p:cNvPr>
+          <p:cNvPr id="14" name="Image 2" descr="Captura de la app: Pase QR del cliente">    </p:cNvPr>
           <p:cNvPicPr>
             <a:picLocks noChangeAspect="1"/>
           </p:cNvPicPr>
@@ -12207,7 +12207,7 @@
       </p:sp>
       <p:pic>
         <p:nvPicPr>
-          <p:cNvPr id="18" name="Image 3" descr="/mnt/user-data/uploads/Capturas_Presentacion/06 - Recompensas del cliente.jpg">    </p:cNvPr>
+          <p:cNvPr id="18" name="Image 3" descr="Captura de la app: Recompensas del cliente">    </p:cNvPr>
           <p:cNvPicPr>
             <a:picLocks noChangeAspect="1"/>
           </p:cNvPicPr>

</xml_diff>

<commit_message>
Enfocar la presentación en los cambios desde la Fase 1
Contexto y solución quedan en una sola lámina de recordatorio, y se agrega
una lámina con la retroalimentación recibida, lo que se hizo y el avance
del Sprint 1. Las láminas que responden al feedback llevan una etiqueta.
</commit_message>
<xml_diff>
--- a/Fase 2/Evidencias Proyecto/Presentación Proyecto.pptx
+++ b/Fase 2/Evidencias Proyecto/Presentación Proyecto.pptx
@@ -118,7 +118,7 @@
   <p:extLst>
     <p:ext uri="{521415D9-36F7-43E2-AB2F-B90AF26B5E84}">
       <p14:sectionLst xmlns:p14="http://schemas.microsoft.com/office/powerpoint/2010/main">
-        <p14:section name="Evaluación 2" id="{9b539a90-19b0-7415-6be1-089134c58d51}">
+        <p14:section name="Evaluación 2" id="{ef6f3ec9-0317-660d-7424-09ca94aead26}">
           <p14:sldIdLst>
             <p14:sldId id="256"/>
             <p14:sldId id="257"/>
@@ -890,7 +890,7 @@
           <a:p>
             <a:r>
               <a:rPr lang="en-US" dirty="0"/>
-              <a:t>Parto por el contexto. Clancy's es un pub y restaurante del centro de Cork y no tiene ninguna forma digital de premiar a los clientes que vuelven. Lo típico en el rubro es la tarjeta de sellos de papel, y tiene tres problemas: el cliente la pierde, un sello se puede copiar, y el local no se queda con ningún dato. No sabe quién vuelve ni qué premio le funciona.</a:t>
+              <a:t>Parto con un recordatorio rápido, porque esto ya lo presenté en la Fase 1. Clancy's es un pub y restaurante de Cork que no tiene una forma digital de premiar a sus clientes frecuentes, y lo típico en el rubro, la tarjeta de sellos de papel, se pierde, se falsifica y no deja datos. Mi solución es una app con tres roles: el cliente muestra un QR de un solo uso, el mesero lo escanea y suma la visita, y la administración maneja el menú, los premios y los indicadores.</a:t>
             </a:r>
             <a:endParaRPr lang="en-US" dirty="0"/>
           </a:p>
@@ -978,7 +978,7 @@
           <a:p>
             <a:r>
               <a:rPr lang="en-US" dirty="0"/>
-              <a:t>Mi solución es una sola app con tres roles. El cliente muestra un código QR en su teléfono, el mesero lo escanea y la visita se suma al instante. El administrador maneja el menú, los premios y las promociones. El código dura tres minutos y sirve una sola vez, así nadie puede sacarle una foto y usarlo de nuevo. Cuando el cliente llega a la meta, canjea su premio de la misma forma.</a:t>
+              <a:t>Desde la presentación anterior hice cambios a partir de lo que me dijo la profesora. Faltaba una tabla de requisitos, y ahora está la matriz en Excel. Las imágenes no se veían y la demo falló, así que ahora muestro mockups con capturas de la versión actual. La planificación tenía demasiado detalle, y ahora va por metas, con la razón del orden. Y como mucha gente en Irlanda usa iPhone, la app también va a la App Store. Además avancé: terminé el Sprint 0 y en el Sprint 1 ya están CORS, el límite de intentos y las primeras pruebas automatizadas.</a:t>
             </a:r>
             <a:endParaRPr lang="en-US" dirty="0"/>
           </a:p>
@@ -1066,7 +1066,7 @@
           <a:p>
             <a:r>
               <a:rPr lang="en-US" dirty="0"/>
-              <a:t>Estos son los requisitos principales; la matriz completa, con veintiocho requisitos y sus criterios de aceptación, está en Excel en el repositorio. A la izquierda, los funcionales: registro, tarjeta de socio, QR de un solo uso, escaneo, canje en dos pasos y edición del menú y los premios. Todos ya funcionan. A la derecha, los no funcionales: la seguridad básica ya está, y ya terminé el límite de intentos y CORS. Lo que falta, como la nube, la ley de datos europea y la publicación en las dos tiendas, ya tiene su sprint.</a:t>
+              <a:t>La matriz completa tiene veintiocho requisitos, cada uno con su criterio de aceptación y su sprint. Aquí están los principales. Los funcionales, como el registro, la tarjeta, el QR de un solo uso, el escaneo y el canje en dos pasos, ya funcionan. En los no funcionales, la seguridad básica está lista, incluidos el límite de intentos y CORS. Lo que falta, como la nube, la ley de datos europea y la publicación, ya tiene su sprint.</a:t>
             </a:r>
             <a:endParaRPr lang="en-US" dirty="0"/>
           </a:p>
@@ -1154,7 +1154,7 @@
           <a:p>
             <a:r>
               <a:rPr lang="en-US" dirty="0"/>
-              <a:t>Trabajo con Scrum, en sprints de dos semanas, porque cada dos semanas tengo algo funcionando para mostrar, recibo feedback y ajusto el sprint siguiente. La regla del orden es simple: primero lo que impide publicar. Por eso parto por la seguridad. Después viene la nube y el build para Android e iPhone, porque Google Play pide catorce días de prueba cerrada y Apple una cuenta verificada. Luego privacidad y pruebas, y al final la publicación. Hoy el Sprint 0 está completado y estoy en el Sprint 1. Todo está en GitHub: cada sprint es un milestone y cada tarea un issue.</a:t>
+              <a:t>Sigo con Scrum, en sprints de dos semanas, porque cada dos semanas tengo algo funcionando, recibo feedback y ajusto el siguiente. Lo que cambié fue la forma de planificar: ahora cada sprint tiene una meta y una razón. Primero lo que impide publicar, que es la seguridad. Después la nube y los builds de Android e iPhone, porque Google Play pide catorce días de prueba cerrada y Apple una cuenta verificada. Luego privacidad y pruebas, y al final la publicación. Todo está en GitHub, con un milestone por sprint y un issue por tarea.</a:t>
             </a:r>
             <a:endParaRPr lang="en-US" dirty="0"/>
           </a:p>
@@ -1330,7 +1330,7 @@
           <a:p>
             <a:r>
               <a:rPr lang="en-US" dirty="0"/>
-              <a:t>La profesora me hizo ver que publicar solo en Google Play dejaba fuera a mucha gente: en Irlanda, casi la mitad de los teléfonos son iPhone. Por eso la app también se va a publicar en la App Store. Para compilar para iPhone normalmente se necesita un Mac, y no tengo uno. Pero como la app está hecha con Expo, se compila en la nube con EAS Build, se prueba en iPhones reales con TestFlight y después pasa la revisión de Apple. Si aparece un error que solo se arregla con Xcode, arriendo un Mac en la nube por horas. La cuenta de Apple la saco en el Sprint 1, porque su verificación puede tardar y bloquea todo lo de iOS. Apple además exige ofrecer inicio de sesión con Apple si hay login con Google, así que lo agregué al Sprint 2. El costo nuevo es la cuenta de Apple, noventa y nueve dólares al año, que entra en el presupuesto inicial.</a:t>
+              <a:t>Sobre el iPhone: en Irlanda casi la mitad de los teléfonos usan iOS, así que la app también va a la App Store. Para compilar para iPhone normalmente se necesita un Mac, y no tengo uno. Como la app está hecha con Expo, se compila en la nube con EAS Build, se prueba en iPhones reales con TestFlight y después pasa la revisión de Apple. Si aparece un error que solo se arregla con Xcode, arriendo un Mac en la nube por horas. Apple además exige inicio de sesión con Apple, que agregué al Sprint 2. El costo nuevo es la cuenta de Apple, noventa y nueve dólares al año, que entra en el presupuesto inicial.</a:t>
             </a:r>
             <a:endParaRPr lang="en-US" dirty="0"/>
           </a:p>
@@ -4032,7 +4032,7 @@
                 <a:ea typeface="Arial" pitchFamily="34" charset="-122"/>
                 <a:cs typeface="Arial" pitchFamily="34" charset="-120"/>
               </a:rPr>
-              <a:t>Contexto y problemática</a:t>
+              <a:t>Contexto: el problema y la solución</a:t>
             </a:r>
             <a:endParaRPr lang="en-US" sz="2600" dirty="0"/>
           </a:p>
@@ -4040,54 +4040,18 @@
       </p:sp>
       <p:sp>
         <p:nvSpPr>
-          <p:cNvPr id="3" name="Text 1"/>
-          <p:cNvSpPr txBox="1"/>
-          <p:nvPr/>
-        </p:nvSpPr>
-        <p:spPr>
-          <a:xfrm>
-            <a:off x="457200" y="1005840"/>
-            <a:ext cx="8229600" cy="640080"/>
-          </a:xfrm>
-          <a:prstGeom prst="rect">
-            <a:avLst/>
-          </a:prstGeom>
-          <a:noFill/>
-          <a:ln/>
-        </p:spPr>
-        <p:txBody>
-          <a:bodyPr wrap="square" lIns="0" tIns="0" rIns="0" bIns="0" rtlCol="0" anchor="t"/>
-          <a:lstStyle/>
-          <a:p>
-            <a:pPr indent="0" marL="0">
-              <a:buNone/>
-            </a:pPr>
-            <a:r>
-              <a:rPr lang="en-US" sz="1500" dirty="0">
-                <a:solidFill>
-                  <a:srgbClr val="111111"/>
-                </a:solidFill>
-              </a:rPr>
-              <a:t>Clancy's es un pub y restaurante del centro de Cork, Irlanda. No tiene una herramienta digital para premiar a sus clientes frecuentes. La alternativa típica, la tarjeta de sellos de papel:</a:t>
-            </a:r>
-            <a:endParaRPr lang="en-US" sz="1500" dirty="0"/>
-          </a:p>
-        </p:txBody>
-      </p:sp>
-      <p:sp>
-        <p:nvSpPr>
-          <p:cNvPr id="4" name="Shape 2"/>
+          <p:cNvPr id="3" name="Shape 1"/>
           <p:cNvSpPr/>
           <p:nvPr/>
         </p:nvSpPr>
         <p:spPr>
           <a:xfrm>
-            <a:off x="457200" y="1783080"/>
-            <a:ext cx="2606040" cy="1920240"/>
+            <a:off x="457200" y="1051560"/>
+            <a:ext cx="3977640" cy="3520440"/>
           </a:xfrm>
           <a:prstGeom prst="roundRect">
             <a:avLst>
-              <a:gd name="adj" fmla="val 3810"/>
+              <a:gd name="adj" fmla="val 2078"/>
             </a:avLst>
           </a:prstGeom>
           <a:solidFill>
@@ -4103,14 +4067,89 @@
       </p:sp>
       <p:sp>
         <p:nvSpPr>
-          <p:cNvPr id="5" name="Shape 3"/>
+          <p:cNvPr id="4" name="Text 2"/>
+          <p:cNvSpPr txBox="1"/>
+          <p:nvPr/>
+        </p:nvSpPr>
+        <p:spPr>
+          <a:xfrm>
+            <a:off x="685800" y="1188720"/>
+            <a:ext cx="3566160" cy="347472"/>
+          </a:xfrm>
+          <a:prstGeom prst="rect">
+            <a:avLst/>
+          </a:prstGeom>
+          <a:noFill/>
+          <a:ln/>
+        </p:spPr>
+        <p:txBody>
+          <a:bodyPr wrap="square" lIns="0" tIns="0" rIns="0" bIns="0" rtlCol="0" anchor="t"/>
+          <a:lstStyle/>
+          <a:p>
+            <a:pPr indent="0" marL="0">
+              <a:buNone/>
+            </a:pPr>
+            <a:r>
+              <a:rPr lang="en-US" sz="1700" b="1" dirty="0">
+                <a:solidFill>
+                  <a:srgbClr val="111111"/>
+                </a:solidFill>
+                <a:latin typeface="Arial" pitchFamily="34" charset="0"/>
+                <a:ea typeface="Arial" pitchFamily="34" charset="-122"/>
+                <a:cs typeface="Arial" pitchFamily="34" charset="-120"/>
+              </a:rPr>
+              <a:t>El problema</a:t>
+            </a:r>
+            <a:endParaRPr lang="en-US" sz="1700" dirty="0"/>
+          </a:p>
+        </p:txBody>
+      </p:sp>
+      <p:sp>
+        <p:nvSpPr>
+          <p:cNvPr id="5" name="Text 3"/>
+          <p:cNvSpPr txBox="1"/>
+          <p:nvPr/>
+        </p:nvSpPr>
+        <p:spPr>
+          <a:xfrm>
+            <a:off x="685800" y="1572768"/>
+            <a:ext cx="3566160" cy="777240"/>
+          </a:xfrm>
+          <a:prstGeom prst="rect">
+            <a:avLst/>
+          </a:prstGeom>
+          <a:noFill/>
+          <a:ln/>
+        </p:spPr>
+        <p:txBody>
+          <a:bodyPr wrap="square" lIns="0" tIns="0" rIns="0" bIns="0" rtlCol="0" anchor="t"/>
+          <a:lstStyle/>
+          <a:p>
+            <a:pPr indent="0" marL="0">
+              <a:buNone/>
+            </a:pPr>
+            <a:r>
+              <a:rPr lang="en-US" sz="1300" dirty="0">
+                <a:solidFill>
+                  <a:srgbClr val="111111"/>
+                </a:solidFill>
+              </a:rPr>
+              <a:t>Clancy's, pub y restaurante del centro de Cork, no tiene una forma digital de premiar a sus clientes frecuentes. Lo típico en el rubro, la tarjeta de sellos de papel:</a:t>
+            </a:r>
+            <a:endParaRPr lang="en-US" sz="1300" dirty="0"/>
+          </a:p>
+        </p:txBody>
+      </p:sp>
+      <p:sp>
+        <p:nvSpPr>
+          <p:cNvPr id="6" name="Shape 4"/>
           <p:cNvSpPr/>
           <p:nvPr/>
         </p:nvSpPr>
         <p:spPr>
           <a:xfrm>
-            <a:off x="685800" y="1965960"/>
-            <a:ext cx="502920" cy="502920"/>
+            <a:off x="685800" y="2468880"/>
+            <a:ext cx="457200" cy="457200"/>
           </a:xfrm>
           <a:prstGeom prst="ellipse">
             <a:avLst/>
@@ -4128,7 +4167,7 @@
       </p:sp>
       <p:pic>
         <p:nvPicPr>
-          <p:cNvPr id="6" name="Image 0" descr="preencoded.png">    </p:cNvPr>
+          <p:cNvPr id="7" name="Image 0" descr="preencoded.png">    </p:cNvPr>
           <p:cNvPicPr>
             <a:picLocks noChangeAspect="1"/>
           </p:cNvPicPr>
@@ -4142,8 +4181,8 @@
         </p:blipFill>
         <p:spPr>
           <a:xfrm>
-            <a:off x="811530" y="2091690"/>
-            <a:ext cx="251460" cy="251460"/>
+            <a:off x="800100" y="2583180"/>
+            <a:ext cx="228600" cy="228600"/>
           </a:xfrm>
           <a:prstGeom prst="rect">
             <a:avLst/>
@@ -4152,76 +4191,48 @@
       </p:pic>
       <p:sp>
         <p:nvSpPr>
-          <p:cNvPr id="7" name="Text 4"/>
-          <p:cNvSpPr txBox="1"/>
-          <p:nvPr/>
-        </p:nvSpPr>
-        <p:spPr>
-          <a:xfrm>
-            <a:off x="685800" y="2606040"/>
-            <a:ext cx="2194560" cy="320040"/>
-          </a:xfrm>
-          <a:prstGeom prst="rect">
-            <a:avLst/>
-          </a:prstGeom>
-          <a:noFill/>
-          <a:ln/>
-        </p:spPr>
-        <p:txBody>
-          <a:bodyPr wrap="square" lIns="0" tIns="0" rIns="0" bIns="0" rtlCol="0" anchor="t"/>
+          <p:cNvPr id="8" name="Text 5"/>
+          <p:cNvSpPr txBox="1"/>
+          <p:nvPr/>
+        </p:nvSpPr>
+        <p:spPr>
+          <a:xfrm>
+            <a:off x="1280160" y="2468880"/>
+            <a:ext cx="3017520" cy="457200"/>
+          </a:xfrm>
+          <a:prstGeom prst="rect">
+            <a:avLst/>
+          </a:prstGeom>
+          <a:noFill/>
+          <a:ln/>
+        </p:spPr>
+        <p:txBody>
+          <a:bodyPr wrap="square" lIns="0" tIns="0" rIns="0" bIns="0" rtlCol="0" anchor="ctr"/>
           <a:lstStyle/>
           <a:p>
             <a:pPr indent="0" marL="0">
               <a:buNone/>
             </a:pPr>
             <a:r>
-              <a:rPr lang="en-US" sz="1800" b="1" dirty="0">
+              <a:rPr lang="en-US" sz="1300" b="1" dirty="0">
                 <a:solidFill>
                   <a:srgbClr val="111111"/>
                 </a:solidFill>
-                <a:latin typeface="Arial" pitchFamily="34" charset="0"/>
-                <a:ea typeface="Arial" pitchFamily="34" charset="-122"/>
-                <a:cs typeface="Arial" pitchFamily="34" charset="-120"/>
-              </a:rPr>
-              <a:t>Se pierde</a:t>
-            </a:r>
-            <a:endParaRPr lang="en-US" sz="1800" dirty="0"/>
-          </a:p>
-        </p:txBody>
-      </p:sp>
-      <p:sp>
-        <p:nvSpPr>
-          <p:cNvPr id="8" name="Text 5"/>
-          <p:cNvSpPr txBox="1"/>
-          <p:nvPr/>
-        </p:nvSpPr>
-        <p:spPr>
-          <a:xfrm>
-            <a:off x="685800" y="2971800"/>
-            <a:ext cx="2194560" cy="594360"/>
-          </a:xfrm>
-          <a:prstGeom prst="rect">
-            <a:avLst/>
-          </a:prstGeom>
-          <a:noFill/>
-          <a:ln/>
-        </p:spPr>
-        <p:txBody>
-          <a:bodyPr wrap="square" lIns="0" tIns="0" rIns="0" bIns="0" rtlCol="0" anchor="t"/>
-          <a:lstStyle/>
-          <a:p>
+              </a:rPr>
+              <a:t>Se pierde </a:t>
+            </a:r>
             <a:pPr indent="0" marL="0">
               <a:buNone/>
             </a:pPr>
             <a:r>
-              <a:rPr lang="en-US" sz="1400" dirty="0">
+              <a:rPr lang="en-US" sz="1300" dirty="0">
                 <a:solidFill>
                   <a:srgbClr val="111111"/>
                 </a:solidFill>
               </a:rPr>
-              <a:t>El cliente la olvida y pierde su avance.</a:t>
-            </a:r>
-            <a:endParaRPr lang="en-US" sz="1400" dirty="0"/>
+              <a:t>y el cliente pierde su avance.</a:t>
+            </a:r>
+            <a:endParaRPr lang="en-US" sz="1300" dirty="0"/>
           </a:p>
         </p:txBody>
       </p:sp>
@@ -4233,35 +4244,8 @@
         </p:nvSpPr>
         <p:spPr>
           <a:xfrm>
-            <a:off x="3246120" y="1783080"/>
-            <a:ext cx="2606040" cy="1920240"/>
-          </a:xfrm>
-          <a:prstGeom prst="roundRect">
-            <a:avLst>
-              <a:gd name="adj" fmla="val 3810"/>
-            </a:avLst>
-          </a:prstGeom>
-          <a:solidFill>
-            <a:srgbClr val="F2F2F2"/>
-          </a:solidFill>
-          <a:ln w="12700">
-            <a:solidFill>
-              <a:srgbClr val="F2F2F2"/>
-            </a:solidFill>
-            <a:prstDash val="solid"/>
-          </a:ln>
-        </p:spPr>
-      </p:sp>
-      <p:sp>
-        <p:nvSpPr>
-          <p:cNvPr id="10" name="Shape 7"/>
-          <p:cNvSpPr/>
-          <p:nvPr/>
-        </p:nvSpPr>
-        <p:spPr>
-          <a:xfrm>
-            <a:off x="3474720" y="1965960"/>
-            <a:ext cx="502920" cy="502920"/>
+            <a:off x="685800" y="3127248"/>
+            <a:ext cx="457200" cy="457200"/>
           </a:xfrm>
           <a:prstGeom prst="ellipse">
             <a:avLst/>
@@ -4279,7 +4263,7 @@
       </p:sp>
       <p:pic>
         <p:nvPicPr>
-          <p:cNvPr id="11" name="Image 1" descr="preencoded.png">    </p:cNvPr>
+          <p:cNvPr id="10" name="Image 1" descr="preencoded.png">    </p:cNvPr>
           <p:cNvPicPr>
             <a:picLocks noChangeAspect="1"/>
           </p:cNvPicPr>
@@ -4293,8 +4277,8 @@
         </p:blipFill>
         <p:spPr>
           <a:xfrm>
-            <a:off x="3600450" y="2091690"/>
-            <a:ext cx="251460" cy="251460"/>
+            <a:off x="800100" y="3241548"/>
+            <a:ext cx="228600" cy="228600"/>
           </a:xfrm>
           <a:prstGeom prst="rect">
             <a:avLst/>
@@ -4303,116 +4287,61 @@
       </p:pic>
       <p:sp>
         <p:nvSpPr>
-          <p:cNvPr id="12" name="Text 8"/>
-          <p:cNvSpPr txBox="1"/>
-          <p:nvPr/>
-        </p:nvSpPr>
-        <p:spPr>
-          <a:xfrm>
-            <a:off x="3474720" y="2606040"/>
-            <a:ext cx="2194560" cy="320040"/>
-          </a:xfrm>
-          <a:prstGeom prst="rect">
-            <a:avLst/>
-          </a:prstGeom>
-          <a:noFill/>
-          <a:ln/>
-        </p:spPr>
-        <p:txBody>
-          <a:bodyPr wrap="square" lIns="0" tIns="0" rIns="0" bIns="0" rtlCol="0" anchor="t"/>
+          <p:cNvPr id="11" name="Text 7"/>
+          <p:cNvSpPr txBox="1"/>
+          <p:nvPr/>
+        </p:nvSpPr>
+        <p:spPr>
+          <a:xfrm>
+            <a:off x="1280160" y="3127248"/>
+            <a:ext cx="3017520" cy="457200"/>
+          </a:xfrm>
+          <a:prstGeom prst="rect">
+            <a:avLst/>
+          </a:prstGeom>
+          <a:noFill/>
+          <a:ln/>
+        </p:spPr>
+        <p:txBody>
+          <a:bodyPr wrap="square" lIns="0" tIns="0" rIns="0" bIns="0" rtlCol="0" anchor="ctr"/>
           <a:lstStyle/>
           <a:p>
             <a:pPr indent="0" marL="0">
               <a:buNone/>
             </a:pPr>
             <a:r>
-              <a:rPr lang="en-US" sz="1800" b="1" dirty="0">
+              <a:rPr lang="en-US" sz="1300" b="1" dirty="0">
                 <a:solidFill>
                   <a:srgbClr val="111111"/>
                 </a:solidFill>
-                <a:latin typeface="Arial" pitchFamily="34" charset="0"/>
-                <a:ea typeface="Arial" pitchFamily="34" charset="-122"/>
-                <a:cs typeface="Arial" pitchFamily="34" charset="-120"/>
-              </a:rPr>
-              <a:t>Se falsifica</a:t>
-            </a:r>
-            <a:endParaRPr lang="en-US" sz="1800" dirty="0"/>
-          </a:p>
-        </p:txBody>
-      </p:sp>
-      <p:sp>
-        <p:nvSpPr>
-          <p:cNvPr id="13" name="Text 9"/>
-          <p:cNvSpPr txBox="1"/>
-          <p:nvPr/>
-        </p:nvSpPr>
-        <p:spPr>
-          <a:xfrm>
-            <a:off x="3474720" y="2971800"/>
-            <a:ext cx="2194560" cy="594360"/>
-          </a:xfrm>
-          <a:prstGeom prst="rect">
-            <a:avLst/>
-          </a:prstGeom>
-          <a:noFill/>
-          <a:ln/>
-        </p:spPr>
-        <p:txBody>
-          <a:bodyPr wrap="square" lIns="0" tIns="0" rIns="0" bIns="0" rtlCol="0" anchor="t"/>
-          <a:lstStyle/>
-          <a:p>
+              </a:rPr>
+              <a:t>Se falsifica </a:t>
+            </a:r>
             <a:pPr indent="0" marL="0">
               <a:buNone/>
             </a:pPr>
             <a:r>
-              <a:rPr lang="en-US" sz="1400" dirty="0">
+              <a:rPr lang="en-US" sz="1300" dirty="0">
                 <a:solidFill>
                   <a:srgbClr val="111111"/>
                 </a:solidFill>
               </a:rPr>
-              <a:t>Un sello se copia y nadie controla quién lo puso.</a:t>
-            </a:r>
-            <a:endParaRPr lang="en-US" sz="1400" dirty="0"/>
-          </a:p>
-        </p:txBody>
-      </p:sp>
-      <p:sp>
-        <p:nvSpPr>
-          <p:cNvPr id="14" name="Shape 10"/>
+              <a:t>y nadie controla quién puso el sello.</a:t>
+            </a:r>
+            <a:endParaRPr lang="en-US" sz="1300" dirty="0"/>
+          </a:p>
+        </p:txBody>
+      </p:sp>
+      <p:sp>
+        <p:nvSpPr>
+          <p:cNvPr id="12" name="Shape 8"/>
           <p:cNvSpPr/>
           <p:nvPr/>
         </p:nvSpPr>
         <p:spPr>
           <a:xfrm>
-            <a:off x="6035040" y="1783080"/>
-            <a:ext cx="2606040" cy="1920240"/>
-          </a:xfrm>
-          <a:prstGeom prst="roundRect">
-            <a:avLst>
-              <a:gd name="adj" fmla="val 3810"/>
-            </a:avLst>
-          </a:prstGeom>
-          <a:solidFill>
-            <a:srgbClr val="F2F2F2"/>
-          </a:solidFill>
-          <a:ln w="12700">
-            <a:solidFill>
-              <a:srgbClr val="F2F2F2"/>
-            </a:solidFill>
-            <a:prstDash val="solid"/>
-          </a:ln>
-        </p:spPr>
-      </p:sp>
-      <p:sp>
-        <p:nvSpPr>
-          <p:cNvPr id="15" name="Shape 11"/>
-          <p:cNvSpPr/>
-          <p:nvPr/>
-        </p:nvSpPr>
-        <p:spPr>
-          <a:xfrm>
-            <a:off x="6263640" y="1965960"/>
-            <a:ext cx="502920" cy="502920"/>
+            <a:off x="685800" y="3785616"/>
+            <a:ext cx="457200" cy="457200"/>
           </a:xfrm>
           <a:prstGeom prst="ellipse">
             <a:avLst/>
@@ -4430,7 +4359,7 @@
       </p:sp>
       <p:pic>
         <p:nvPicPr>
-          <p:cNvPr id="16" name="Image 2" descr="preencoded.png">    </p:cNvPr>
+          <p:cNvPr id="13" name="Image 2" descr="preencoded.png">    </p:cNvPr>
           <p:cNvPicPr>
             <a:picLocks noChangeAspect="1"/>
           </p:cNvPicPr>
@@ -4444,8 +4373,8 @@
         </p:blipFill>
         <p:spPr>
           <a:xfrm>
-            <a:off x="6389370" y="2091690"/>
-            <a:ext cx="251460" cy="251460"/>
+            <a:off x="800100" y="3899916"/>
+            <a:ext cx="228600" cy="228600"/>
           </a:xfrm>
           <a:prstGeom prst="rect">
             <a:avLst/>
@@ -4454,14 +4383,88 @@
       </p:pic>
       <p:sp>
         <p:nvSpPr>
-          <p:cNvPr id="17" name="Text 12"/>
-          <p:cNvSpPr txBox="1"/>
-          <p:nvPr/>
-        </p:nvSpPr>
-        <p:spPr>
-          <a:xfrm>
-            <a:off x="6263640" y="2606040"/>
-            <a:ext cx="2194560" cy="320040"/>
+          <p:cNvPr id="14" name="Text 9"/>
+          <p:cNvSpPr txBox="1"/>
+          <p:nvPr/>
+        </p:nvSpPr>
+        <p:spPr>
+          <a:xfrm>
+            <a:off x="1280160" y="3785616"/>
+            <a:ext cx="3017520" cy="457200"/>
+          </a:xfrm>
+          <a:prstGeom prst="rect">
+            <a:avLst/>
+          </a:prstGeom>
+          <a:noFill/>
+          <a:ln/>
+        </p:spPr>
+        <p:txBody>
+          <a:bodyPr wrap="square" lIns="0" tIns="0" rIns="0" bIns="0" rtlCol="0" anchor="ctr"/>
+          <a:lstStyle/>
+          <a:p>
+            <a:pPr indent="0" marL="0">
+              <a:buNone/>
+            </a:pPr>
+            <a:r>
+              <a:rPr lang="en-US" sz="1300" b="1" dirty="0">
+                <a:solidFill>
+                  <a:srgbClr val="111111"/>
+                </a:solidFill>
+              </a:rPr>
+              <a:t>No deja datos </a:t>
+            </a:r>
+            <a:pPr indent="0" marL="0">
+              <a:buNone/>
+            </a:pPr>
+            <a:r>
+              <a:rPr lang="en-US" sz="1300" dirty="0">
+                <a:solidFill>
+                  <a:srgbClr val="111111"/>
+                </a:solidFill>
+              </a:rPr>
+              <a:t>y el local no sabe quién vuelve.</a:t>
+            </a:r>
+            <a:endParaRPr lang="en-US" sz="1300" dirty="0"/>
+          </a:p>
+        </p:txBody>
+      </p:sp>
+      <p:sp>
+        <p:nvSpPr>
+          <p:cNvPr id="15" name="Shape 10"/>
+          <p:cNvSpPr/>
+          <p:nvPr/>
+        </p:nvSpPr>
+        <p:spPr>
+          <a:xfrm>
+            <a:off x="4709160" y="1051560"/>
+            <a:ext cx="3977640" cy="3520440"/>
+          </a:xfrm>
+          <a:prstGeom prst="roundRect">
+            <a:avLst>
+              <a:gd name="adj" fmla="val 2078"/>
+            </a:avLst>
+          </a:prstGeom>
+          <a:solidFill>
+            <a:srgbClr val="111111"/>
+          </a:solidFill>
+          <a:ln w="12700">
+            <a:solidFill>
+              <a:srgbClr val="111111"/>
+            </a:solidFill>
+            <a:prstDash val="solid"/>
+          </a:ln>
+        </p:spPr>
+      </p:sp>
+      <p:sp>
+        <p:nvSpPr>
+          <p:cNvPr id="16" name="Text 11"/>
+          <p:cNvSpPr txBox="1"/>
+          <p:nvPr/>
+        </p:nvSpPr>
+        <p:spPr>
+          <a:xfrm>
+            <a:off x="4937760" y="1188720"/>
+            <a:ext cx="3566160" cy="347472"/>
           </a:xfrm>
           <a:prstGeom prst="rect">
             <a:avLst/>
@@ -4477,30 +4480,79 @@
               <a:buNone/>
             </a:pPr>
             <a:r>
-              <a:rPr lang="en-US" sz="1800" b="1" dirty="0">
-                <a:solidFill>
-                  <a:srgbClr val="111111"/>
+              <a:rPr lang="en-US" sz="1700" b="1" dirty="0">
+                <a:solidFill>
+                  <a:srgbClr val="F5C400"/>
                 </a:solidFill>
                 <a:latin typeface="Arial" pitchFamily="34" charset="0"/>
                 <a:ea typeface="Arial" pitchFamily="34" charset="-122"/>
                 <a:cs typeface="Arial" pitchFamily="34" charset="-120"/>
               </a:rPr>
-              <a:t>No deja datos</a:t>
-            </a:r>
-            <a:endParaRPr lang="en-US" sz="1800" dirty="0"/>
-          </a:p>
-        </p:txBody>
-      </p:sp>
-      <p:sp>
-        <p:nvSpPr>
-          <p:cNvPr id="18" name="Text 13"/>
-          <p:cNvSpPr txBox="1"/>
-          <p:nvPr/>
-        </p:nvSpPr>
-        <p:spPr>
-          <a:xfrm>
-            <a:off x="6263640" y="2971800"/>
-            <a:ext cx="2194560" cy="594360"/>
+              <a:t>La solución: una app, tres roles</a:t>
+            </a:r>
+            <a:endParaRPr lang="en-US" sz="1700" dirty="0"/>
+          </a:p>
+        </p:txBody>
+      </p:sp>
+      <p:sp>
+        <p:nvSpPr>
+          <p:cNvPr id="17" name="Shape 12"/>
+          <p:cNvSpPr/>
+          <p:nvPr/>
+        </p:nvSpPr>
+        <p:spPr>
+          <a:xfrm>
+            <a:off x="4937760" y="1737360"/>
+            <a:ext cx="502920" cy="502920"/>
+          </a:xfrm>
+          <a:prstGeom prst="ellipse">
+            <a:avLst/>
+          </a:prstGeom>
+          <a:solidFill>
+            <a:srgbClr val="F5C400"/>
+          </a:solidFill>
+          <a:ln w="12700">
+            <a:solidFill>
+              <a:srgbClr val="F5C400"/>
+            </a:solidFill>
+            <a:prstDash val="solid"/>
+          </a:ln>
+        </p:spPr>
+      </p:sp>
+      <p:pic>
+        <p:nvPicPr>
+          <p:cNvPr id="18" name="Image 3" descr="preencoded.png">    </p:cNvPr>
+          <p:cNvPicPr>
+            <a:picLocks noChangeAspect="1"/>
+          </p:cNvPicPr>
+          <p:nvPr/>
+        </p:nvPicPr>
+        <p:blipFill>
+          <a:blip r:embed="rId4"/>
+          <a:stretch>
+            <a:fillRect/>
+          </a:stretch>
+        </p:blipFill>
+        <p:spPr>
+          <a:xfrm>
+            <a:off x="5063490" y="1863090"/>
+            <a:ext cx="251460" cy="251460"/>
+          </a:xfrm>
+          <a:prstGeom prst="rect">
+            <a:avLst/>
+          </a:prstGeom>
+        </p:spPr>
+      </p:pic>
+      <p:sp>
+        <p:nvSpPr>
+          <p:cNvPr id="19" name="Text 13"/>
+          <p:cNvSpPr txBox="1"/>
+          <p:nvPr/>
+        </p:nvSpPr>
+        <p:spPr>
+          <a:xfrm>
+            <a:off x="5577840" y="1709928"/>
+            <a:ext cx="2926080" cy="274320"/>
           </a:xfrm>
           <a:prstGeom prst="rect">
             <a:avLst/>
@@ -4516,12 +4568,12 @@
               <a:buNone/>
             </a:pPr>
             <a:r>
-              <a:rPr lang="en-US" sz="1400" dirty="0">
-                <a:solidFill>
-                  <a:srgbClr val="111111"/>
-                </a:solidFill>
-              </a:rPr>
-              <a:t>El local no sabe quién vuelve ni qué premio funciona.</a:t>
+              <a:rPr lang="en-US" sz="1400" b="1" dirty="0">
+                <a:solidFill>
+                  <a:srgbClr val="FFFFFF"/>
+                </a:solidFill>
+              </a:rPr>
+              <a:t>Cliente</a:t>
             </a:r>
             <a:endParaRPr lang="en-US" sz="1400" dirty="0"/>
           </a:p>
@@ -4529,14 +4581,14 @@
       </p:sp>
       <p:sp>
         <p:nvSpPr>
-          <p:cNvPr id="19" name="Text 14"/>
-          <p:cNvSpPr txBox="1"/>
-          <p:nvPr/>
-        </p:nvSpPr>
-        <p:spPr>
-          <a:xfrm>
-            <a:off x="457200" y="3931920"/>
-            <a:ext cx="8229600" cy="548640"/>
+          <p:cNvPr id="20" name="Text 14"/>
+          <p:cNvSpPr txBox="1"/>
+          <p:nvPr/>
+        </p:nvSpPr>
+        <p:spPr>
+          <a:xfrm>
+            <a:off x="5577840" y="1984248"/>
+            <a:ext cx="2926080" cy="457200"/>
           </a:xfrm>
           <a:prstGeom prst="rect">
             <a:avLst/>
@@ -4552,25 +4604,256 @@
               <a:buNone/>
             </a:pPr>
             <a:r>
+              <a:rPr lang="en-US" sz="1200" dirty="0">
+                <a:solidFill>
+                  <a:srgbClr val="FFFFFF"/>
+                </a:solidFill>
+              </a:rPr>
+              <a:t>muestra un QR que dura 3 minutos y sirve una sola vez.</a:t>
+            </a:r>
+            <a:endParaRPr lang="en-US" sz="1200" dirty="0"/>
+          </a:p>
+        </p:txBody>
+      </p:sp>
+      <p:sp>
+        <p:nvSpPr>
+          <p:cNvPr id="21" name="Shape 15"/>
+          <p:cNvSpPr/>
+          <p:nvPr/>
+        </p:nvSpPr>
+        <p:spPr>
+          <a:xfrm>
+            <a:off x="4937760" y="2651760"/>
+            <a:ext cx="502920" cy="502920"/>
+          </a:xfrm>
+          <a:prstGeom prst="ellipse">
+            <a:avLst/>
+          </a:prstGeom>
+          <a:solidFill>
+            <a:srgbClr val="F5C400"/>
+          </a:solidFill>
+          <a:ln w="12700">
+            <a:solidFill>
+              <a:srgbClr val="F5C400"/>
+            </a:solidFill>
+            <a:prstDash val="solid"/>
+          </a:ln>
+        </p:spPr>
+      </p:sp>
+      <p:pic>
+        <p:nvPicPr>
+          <p:cNvPr id="22" name="Image 4" descr="preencoded.png">    </p:cNvPr>
+          <p:cNvPicPr>
+            <a:picLocks noChangeAspect="1"/>
+          </p:cNvPicPr>
+          <p:nvPr/>
+        </p:nvPicPr>
+        <p:blipFill>
+          <a:blip r:embed="rId5"/>
+          <a:stretch>
+            <a:fillRect/>
+          </a:stretch>
+        </p:blipFill>
+        <p:spPr>
+          <a:xfrm>
+            <a:off x="5063490" y="2777490"/>
+            <a:ext cx="251460" cy="251460"/>
+          </a:xfrm>
+          <a:prstGeom prst="rect">
+            <a:avLst/>
+          </a:prstGeom>
+        </p:spPr>
+      </p:pic>
+      <p:sp>
+        <p:nvSpPr>
+          <p:cNvPr id="23" name="Text 16"/>
+          <p:cNvSpPr txBox="1"/>
+          <p:nvPr/>
+        </p:nvSpPr>
+        <p:spPr>
+          <a:xfrm>
+            <a:off x="5577840" y="2624328"/>
+            <a:ext cx="2926080" cy="274320"/>
+          </a:xfrm>
+          <a:prstGeom prst="rect">
+            <a:avLst/>
+          </a:prstGeom>
+          <a:noFill/>
+          <a:ln/>
+        </p:spPr>
+        <p:txBody>
+          <a:bodyPr wrap="square" lIns="0" tIns="0" rIns="0" bIns="0" rtlCol="0" anchor="t"/>
+          <a:lstStyle/>
+          <a:p>
+            <a:pPr indent="0" marL="0">
+              <a:buNone/>
+            </a:pPr>
+            <a:r>
               <a:rPr lang="en-US" sz="1400" b="1" dirty="0">
                 <a:solidFill>
-                  <a:srgbClr val="111111"/>
-                </a:solidFill>
-              </a:rPr>
-              <a:t>Afecta a dos grupos: </a:t>
-            </a:r>
+                  <a:srgbClr val="FFFFFF"/>
+                </a:solidFill>
+              </a:rPr>
+              <a:t>Personal</a:t>
+            </a:r>
+            <a:endParaRPr lang="en-US" sz="1400" dirty="0"/>
+          </a:p>
+        </p:txBody>
+      </p:sp>
+      <p:sp>
+        <p:nvSpPr>
+          <p:cNvPr id="24" name="Text 17"/>
+          <p:cNvSpPr txBox="1"/>
+          <p:nvPr/>
+        </p:nvSpPr>
+        <p:spPr>
+          <a:xfrm>
+            <a:off x="5577840" y="2898648"/>
+            <a:ext cx="2926080" cy="457200"/>
+          </a:xfrm>
+          <a:prstGeom prst="rect">
+            <a:avLst/>
+          </a:prstGeom>
+          <a:noFill/>
+          <a:ln/>
+        </p:spPr>
+        <p:txBody>
+          <a:bodyPr wrap="square" lIns="0" tIns="0" rIns="0" bIns="0" rtlCol="0" anchor="t"/>
+          <a:lstStyle/>
+          <a:p>
             <a:pPr indent="0" marL="0">
               <a:buNone/>
             </a:pPr>
             <a:r>
-              <a:rPr lang="en-US" sz="1400" dirty="0">
-                <a:solidFill>
-                  <a:srgbClr val="111111"/>
-                </a:solidFill>
-              </a:rPr>
-              <a:t>los clientes frecuentes, que no reciben nada por volver, y la administración, que decide sus promociones sin datos.</a:t>
+              <a:rPr lang="en-US" sz="1200" dirty="0">
+                <a:solidFill>
+                  <a:srgbClr val="FFFFFF"/>
+                </a:solidFill>
+              </a:rPr>
+              <a:t>escanea el QR y suma la visita o entrega el premio.</a:t>
+            </a:r>
+            <a:endParaRPr lang="en-US" sz="1200" dirty="0"/>
+          </a:p>
+        </p:txBody>
+      </p:sp>
+      <p:sp>
+        <p:nvSpPr>
+          <p:cNvPr id="25" name="Shape 18"/>
+          <p:cNvSpPr/>
+          <p:nvPr/>
+        </p:nvSpPr>
+        <p:spPr>
+          <a:xfrm>
+            <a:off x="4937760" y="3566160"/>
+            <a:ext cx="502920" cy="502920"/>
+          </a:xfrm>
+          <a:prstGeom prst="ellipse">
+            <a:avLst/>
+          </a:prstGeom>
+          <a:solidFill>
+            <a:srgbClr val="F5C400"/>
+          </a:solidFill>
+          <a:ln w="12700">
+            <a:solidFill>
+              <a:srgbClr val="F5C400"/>
+            </a:solidFill>
+            <a:prstDash val="solid"/>
+          </a:ln>
+        </p:spPr>
+      </p:sp>
+      <p:pic>
+        <p:nvPicPr>
+          <p:cNvPr id="26" name="Image 5" descr="preencoded.png">    </p:cNvPr>
+          <p:cNvPicPr>
+            <a:picLocks noChangeAspect="1"/>
+          </p:cNvPicPr>
+          <p:nvPr/>
+        </p:nvPicPr>
+        <p:blipFill>
+          <a:blip r:embed="rId6"/>
+          <a:stretch>
+            <a:fillRect/>
+          </a:stretch>
+        </p:blipFill>
+        <p:spPr>
+          <a:xfrm>
+            <a:off x="5063490" y="3691890"/>
+            <a:ext cx="251460" cy="251460"/>
+          </a:xfrm>
+          <a:prstGeom prst="rect">
+            <a:avLst/>
+          </a:prstGeom>
+        </p:spPr>
+      </p:pic>
+      <p:sp>
+        <p:nvSpPr>
+          <p:cNvPr id="27" name="Text 19"/>
+          <p:cNvSpPr txBox="1"/>
+          <p:nvPr/>
+        </p:nvSpPr>
+        <p:spPr>
+          <a:xfrm>
+            <a:off x="5577840" y="3538728"/>
+            <a:ext cx="2926080" cy="274320"/>
+          </a:xfrm>
+          <a:prstGeom prst="rect">
+            <a:avLst/>
+          </a:prstGeom>
+          <a:noFill/>
+          <a:ln/>
+        </p:spPr>
+        <p:txBody>
+          <a:bodyPr wrap="square" lIns="0" tIns="0" rIns="0" bIns="0" rtlCol="0" anchor="t"/>
+          <a:lstStyle/>
+          <a:p>
+            <a:pPr indent="0" marL="0">
+              <a:buNone/>
+            </a:pPr>
+            <a:r>
+              <a:rPr lang="en-US" sz="1400" b="1" dirty="0">
+                <a:solidFill>
+                  <a:srgbClr val="FFFFFF"/>
+                </a:solidFill>
+              </a:rPr>
+              <a:t>Administración</a:t>
             </a:r>
             <a:endParaRPr lang="en-US" sz="1400" dirty="0"/>
+          </a:p>
+        </p:txBody>
+      </p:sp>
+      <p:sp>
+        <p:nvSpPr>
+          <p:cNvPr id="28" name="Text 20"/>
+          <p:cNvSpPr txBox="1"/>
+          <p:nvPr/>
+        </p:nvSpPr>
+        <p:spPr>
+          <a:xfrm>
+            <a:off x="5577840" y="3813048"/>
+            <a:ext cx="2926080" cy="457200"/>
+          </a:xfrm>
+          <a:prstGeom prst="rect">
+            <a:avLst/>
+          </a:prstGeom>
+          <a:noFill/>
+          <a:ln/>
+        </p:spPr>
+        <p:txBody>
+          <a:bodyPr wrap="square" lIns="0" tIns="0" rIns="0" bIns="0" rtlCol="0" anchor="t"/>
+          <a:lstStyle/>
+          <a:p>
+            <a:pPr indent="0" marL="0">
+              <a:buNone/>
+            </a:pPr>
+            <a:r>
+              <a:rPr lang="en-US" sz="1200" dirty="0">
+                <a:solidFill>
+                  <a:srgbClr val="FFFFFF"/>
+                </a:solidFill>
+              </a:rPr>
+              <a:t>edita menú, premios y promociones, y ve indicadores.</a:t>
+            </a:r>
+            <a:endParaRPr lang="en-US" sz="1200" dirty="0"/>
           </a:p>
         </p:txBody>
       </p:sp>
@@ -4679,7 +4962,7 @@
                 <a:ea typeface="Arial" pitchFamily="34" charset="-122"/>
                 <a:cs typeface="Arial" pitchFamily="34" charset="-120"/>
               </a:rPr>
-              <a:t>Solución: una app con tres roles</a:t>
+              <a:t>Qué cambió desde la Fase 1</a:t>
             </a:r>
             <a:endParaRPr lang="en-US" sz="2600" dirty="0"/>
           </a:p>
@@ -4687,18 +4970,90 @@
       </p:sp>
       <p:sp>
         <p:nvSpPr>
-          <p:cNvPr id="3" name="Shape 1"/>
+          <p:cNvPr id="3" name="Text 1"/>
+          <p:cNvSpPr txBox="1"/>
+          <p:nvPr/>
+        </p:nvSpPr>
+        <p:spPr>
+          <a:xfrm>
+            <a:off x="457200" y="987552"/>
+            <a:ext cx="3291840" cy="292608"/>
+          </a:xfrm>
+          <a:prstGeom prst="rect">
+            <a:avLst/>
+          </a:prstGeom>
+          <a:noFill/>
+          <a:ln/>
+        </p:spPr>
+        <p:txBody>
+          <a:bodyPr wrap="square" lIns="0" tIns="0" rIns="0" bIns="0" rtlCol="0" anchor="t"/>
+          <a:lstStyle/>
+          <a:p>
+            <a:pPr indent="0" marL="0">
+              <a:buNone/>
+            </a:pPr>
+            <a:r>
+              <a:rPr lang="en-US" sz="1300" b="1" dirty="0">
+                <a:solidFill>
+                  <a:srgbClr val="6B6B6B"/>
+                </a:solidFill>
+              </a:rPr>
+              <a:t>Retroalimentación recibida</a:t>
+            </a:r>
+            <a:endParaRPr lang="en-US" sz="1300" dirty="0"/>
+          </a:p>
+        </p:txBody>
+      </p:sp>
+      <p:sp>
+        <p:nvSpPr>
+          <p:cNvPr id="4" name="Text 2"/>
+          <p:cNvSpPr txBox="1"/>
+          <p:nvPr/>
+        </p:nvSpPr>
+        <p:spPr>
+          <a:xfrm>
+            <a:off x="4069080" y="987552"/>
+            <a:ext cx="4572000" cy="292608"/>
+          </a:xfrm>
+          <a:prstGeom prst="rect">
+            <a:avLst/>
+          </a:prstGeom>
+          <a:noFill/>
+          <a:ln/>
+        </p:spPr>
+        <p:txBody>
+          <a:bodyPr wrap="square" lIns="0" tIns="0" rIns="0" bIns="0" rtlCol="0" anchor="t"/>
+          <a:lstStyle/>
+          <a:p>
+            <a:pPr indent="0" marL="0">
+              <a:buNone/>
+            </a:pPr>
+            <a:r>
+              <a:rPr lang="en-US" sz="1300" b="1" dirty="0">
+                <a:solidFill>
+                  <a:srgbClr val="6B6B6B"/>
+                </a:solidFill>
+              </a:rPr>
+              <a:t>Qué hice</a:t>
+            </a:r>
+            <a:endParaRPr lang="en-US" sz="1300" dirty="0"/>
+          </a:p>
+        </p:txBody>
+      </p:sp>
+      <p:sp>
+        <p:nvSpPr>
+          <p:cNvPr id="5" name="Shape 3"/>
           <p:cNvSpPr/>
           <p:nvPr/>
         </p:nvSpPr>
         <p:spPr>
           <a:xfrm>
-            <a:off x="457200" y="1051560"/>
-            <a:ext cx="2606040" cy="2011680"/>
+            <a:off x="457200" y="1325880"/>
+            <a:ext cx="3429000" cy="438912"/>
           </a:xfrm>
           <a:prstGeom prst="roundRect">
             <a:avLst>
-              <a:gd name="adj" fmla="val 3636"/>
+              <a:gd name="adj" fmla="val 16667"/>
             </a:avLst>
           </a:prstGeom>
           <a:solidFill>
@@ -4714,18 +5069,746 @@
       </p:sp>
       <p:sp>
         <p:nvSpPr>
-          <p:cNvPr id="4" name="Shape 2"/>
+          <p:cNvPr id="6" name="Text 4"/>
+          <p:cNvSpPr txBox="1"/>
+          <p:nvPr/>
+        </p:nvSpPr>
+        <p:spPr>
+          <a:xfrm>
+            <a:off x="621792" y="1325880"/>
+            <a:ext cx="3200400" cy="438912"/>
+          </a:xfrm>
+          <a:prstGeom prst="rect">
+            <a:avLst/>
+          </a:prstGeom>
+          <a:noFill/>
+          <a:ln/>
+        </p:spPr>
+        <p:txBody>
+          <a:bodyPr wrap="square" lIns="0" tIns="0" rIns="0" bIns="0" rtlCol="0" anchor="ctr"/>
+          <a:lstStyle/>
+          <a:p>
+            <a:pPr indent="0" marL="0">
+              <a:buNone/>
+            </a:pPr>
+            <a:r>
+              <a:rPr lang="en-US" sz="1200" b="1" dirty="0">
+                <a:solidFill>
+                  <a:srgbClr val="111111"/>
+                </a:solidFill>
+              </a:rPr>
+              <a:t>Faltaba una tabla de requisitos</a:t>
+            </a:r>
+            <a:endParaRPr lang="en-US" sz="1200" dirty="0"/>
+          </a:p>
+        </p:txBody>
+      </p:sp>
+      <p:sp>
+        <p:nvSpPr>
+          <p:cNvPr id="7" name="Shape 5"/>
           <p:cNvSpPr/>
           <p:nvPr/>
         </p:nvSpPr>
         <p:spPr>
           <a:xfrm>
-            <a:off x="585216" y="1133856"/>
-            <a:ext cx="912508" cy="1847088"/>
+            <a:off x="3931920" y="1417320"/>
+            <a:ext cx="91440" cy="256032"/>
+          </a:xfrm>
+          <a:prstGeom prst="rightArrow">
+            <a:avLst/>
+          </a:prstGeom>
+          <a:solidFill>
+            <a:srgbClr val="F5C400"/>
+          </a:solidFill>
+          <a:ln w="12700">
+            <a:solidFill>
+              <a:srgbClr val="F5C400"/>
+            </a:solidFill>
+            <a:prstDash val="solid"/>
+          </a:ln>
+        </p:spPr>
+      </p:sp>
+      <p:sp>
+        <p:nvSpPr>
+          <p:cNvPr id="8" name="Shape 6"/>
+          <p:cNvSpPr/>
+          <p:nvPr/>
+        </p:nvSpPr>
+        <p:spPr>
+          <a:xfrm>
+            <a:off x="4069080" y="1325880"/>
+            <a:ext cx="4617720" cy="438912"/>
           </a:xfrm>
           <a:prstGeom prst="roundRect">
             <a:avLst>
-              <a:gd name="adj" fmla="val 14029"/>
+              <a:gd name="adj" fmla="val 16667"/>
+            </a:avLst>
+          </a:prstGeom>
+          <a:solidFill>
+            <a:srgbClr val="FFF4BF"/>
+          </a:solidFill>
+          <a:ln w="12700">
+            <a:solidFill>
+              <a:srgbClr val="FFF4BF"/>
+            </a:solidFill>
+            <a:prstDash val="solid"/>
+          </a:ln>
+        </p:spPr>
+      </p:sp>
+      <p:sp>
+        <p:nvSpPr>
+          <p:cNvPr id="9" name="Text 7"/>
+          <p:cNvSpPr txBox="1"/>
+          <p:nvPr/>
+        </p:nvSpPr>
+        <p:spPr>
+          <a:xfrm>
+            <a:off x="4224528" y="1325880"/>
+            <a:ext cx="4389120" cy="438912"/>
+          </a:xfrm>
+          <a:prstGeom prst="rect">
+            <a:avLst/>
+          </a:prstGeom>
+          <a:noFill/>
+          <a:ln/>
+        </p:spPr>
+        <p:txBody>
+          <a:bodyPr wrap="square" lIns="0" tIns="0" rIns="0" bIns="0" rtlCol="0" anchor="ctr"/>
+          <a:lstStyle/>
+          <a:p>
+            <a:pPr indent="0" marL="0">
+              <a:buNone/>
+            </a:pPr>
+            <a:r>
+              <a:rPr lang="en-US" sz="1200" dirty="0">
+                <a:solidFill>
+                  <a:srgbClr val="111111"/>
+                </a:solidFill>
+              </a:rPr>
+              <a:t>Matriz en Excel: 28 requisitos con criterio de aceptación, estado y sprint.</a:t>
+            </a:r>
+            <a:endParaRPr lang="en-US" sz="1200" dirty="0"/>
+          </a:p>
+        </p:txBody>
+      </p:sp>
+      <p:sp>
+        <p:nvSpPr>
+          <p:cNvPr id="10" name="Shape 8"/>
+          <p:cNvSpPr/>
+          <p:nvPr/>
+        </p:nvSpPr>
+        <p:spPr>
+          <a:xfrm>
+            <a:off x="457200" y="1837944"/>
+            <a:ext cx="3429000" cy="438912"/>
+          </a:xfrm>
+          <a:prstGeom prst="roundRect">
+            <a:avLst>
+              <a:gd name="adj" fmla="val 16667"/>
+            </a:avLst>
+          </a:prstGeom>
+          <a:solidFill>
+            <a:srgbClr val="F2F2F2"/>
+          </a:solidFill>
+          <a:ln w="12700">
+            <a:solidFill>
+              <a:srgbClr val="F2F2F2"/>
+            </a:solidFill>
+            <a:prstDash val="solid"/>
+          </a:ln>
+        </p:spPr>
+      </p:sp>
+      <p:sp>
+        <p:nvSpPr>
+          <p:cNvPr id="11" name="Text 9"/>
+          <p:cNvSpPr txBox="1"/>
+          <p:nvPr/>
+        </p:nvSpPr>
+        <p:spPr>
+          <a:xfrm>
+            <a:off x="621792" y="1837944"/>
+            <a:ext cx="3200400" cy="438912"/>
+          </a:xfrm>
+          <a:prstGeom prst="rect">
+            <a:avLst/>
+          </a:prstGeom>
+          <a:noFill/>
+          <a:ln/>
+        </p:spPr>
+        <p:txBody>
+          <a:bodyPr wrap="square" lIns="0" tIns="0" rIns="0" bIns="0" rtlCol="0" anchor="ctr"/>
+          <a:lstStyle/>
+          <a:p>
+            <a:pPr indent="0" marL="0">
+              <a:buNone/>
+            </a:pPr>
+            <a:r>
+              <a:rPr lang="en-US" sz="1200" b="1" dirty="0">
+                <a:solidFill>
+                  <a:srgbClr val="111111"/>
+                </a:solidFill>
+              </a:rPr>
+              <a:t>Las imágenes no se veían y la demo falló</a:t>
+            </a:r>
+            <a:endParaRPr lang="en-US" sz="1200" dirty="0"/>
+          </a:p>
+        </p:txBody>
+      </p:sp>
+      <p:sp>
+        <p:nvSpPr>
+          <p:cNvPr id="12" name="Shape 10"/>
+          <p:cNvSpPr/>
+          <p:nvPr/>
+        </p:nvSpPr>
+        <p:spPr>
+          <a:xfrm>
+            <a:off x="3931920" y="1929384"/>
+            <a:ext cx="91440" cy="256032"/>
+          </a:xfrm>
+          <a:prstGeom prst="rightArrow">
+            <a:avLst/>
+          </a:prstGeom>
+          <a:solidFill>
+            <a:srgbClr val="F5C400"/>
+          </a:solidFill>
+          <a:ln w="12700">
+            <a:solidFill>
+              <a:srgbClr val="F5C400"/>
+            </a:solidFill>
+            <a:prstDash val="solid"/>
+          </a:ln>
+        </p:spPr>
+      </p:sp>
+      <p:sp>
+        <p:nvSpPr>
+          <p:cNvPr id="13" name="Shape 11"/>
+          <p:cNvSpPr/>
+          <p:nvPr/>
+        </p:nvSpPr>
+        <p:spPr>
+          <a:xfrm>
+            <a:off x="4069080" y="1837944"/>
+            <a:ext cx="4617720" cy="438912"/>
+          </a:xfrm>
+          <a:prstGeom prst="roundRect">
+            <a:avLst>
+              <a:gd name="adj" fmla="val 16667"/>
+            </a:avLst>
+          </a:prstGeom>
+          <a:solidFill>
+            <a:srgbClr val="FFF4BF"/>
+          </a:solidFill>
+          <a:ln w="12700">
+            <a:solidFill>
+              <a:srgbClr val="FFF4BF"/>
+            </a:solidFill>
+            <a:prstDash val="solid"/>
+          </a:ln>
+        </p:spPr>
+      </p:sp>
+      <p:sp>
+        <p:nvSpPr>
+          <p:cNvPr id="14" name="Text 12"/>
+          <p:cNvSpPr txBox="1"/>
+          <p:nvPr/>
+        </p:nvSpPr>
+        <p:spPr>
+          <a:xfrm>
+            <a:off x="4224528" y="1837944"/>
+            <a:ext cx="4389120" cy="438912"/>
+          </a:xfrm>
+          <a:prstGeom prst="rect">
+            <a:avLst/>
+          </a:prstGeom>
+          <a:noFill/>
+          <a:ln/>
+        </p:spPr>
+        <p:txBody>
+          <a:bodyPr wrap="square" lIns="0" tIns="0" rIns="0" bIns="0" rtlCol="0" anchor="ctr"/>
+          <a:lstStyle/>
+          <a:p>
+            <a:pPr indent="0" marL="0">
+              <a:buNone/>
+            </a:pPr>
+            <a:r>
+              <a:rPr lang="en-US" sz="1200" dirty="0">
+                <a:solidFill>
+                  <a:srgbClr val="111111"/>
+                </a:solidFill>
+              </a:rPr>
+              <a:t>Mockups grandes con capturas de la versión actual de la app.</a:t>
+            </a:r>
+            <a:endParaRPr lang="en-US" sz="1200" dirty="0"/>
+          </a:p>
+        </p:txBody>
+      </p:sp>
+      <p:sp>
+        <p:nvSpPr>
+          <p:cNvPr id="15" name="Shape 13"/>
+          <p:cNvSpPr/>
+          <p:nvPr/>
+        </p:nvSpPr>
+        <p:spPr>
+          <a:xfrm>
+            <a:off x="457200" y="2350008"/>
+            <a:ext cx="3429000" cy="438912"/>
+          </a:xfrm>
+          <a:prstGeom prst="roundRect">
+            <a:avLst>
+              <a:gd name="adj" fmla="val 16667"/>
+            </a:avLst>
+          </a:prstGeom>
+          <a:solidFill>
+            <a:srgbClr val="F2F2F2"/>
+          </a:solidFill>
+          <a:ln w="12700">
+            <a:solidFill>
+              <a:srgbClr val="F2F2F2"/>
+            </a:solidFill>
+            <a:prstDash val="solid"/>
+          </a:ln>
+        </p:spPr>
+      </p:sp>
+      <p:sp>
+        <p:nvSpPr>
+          <p:cNvPr id="16" name="Text 14"/>
+          <p:cNvSpPr txBox="1"/>
+          <p:nvPr/>
+        </p:nvSpPr>
+        <p:spPr>
+          <a:xfrm>
+            <a:off x="621792" y="2350008"/>
+            <a:ext cx="3200400" cy="438912"/>
+          </a:xfrm>
+          <a:prstGeom prst="rect">
+            <a:avLst/>
+          </a:prstGeom>
+          <a:noFill/>
+          <a:ln/>
+        </p:spPr>
+        <p:txBody>
+          <a:bodyPr wrap="square" lIns="0" tIns="0" rIns="0" bIns="0" rtlCol="0" anchor="ctr"/>
+          <a:lstStyle/>
+          <a:p>
+            <a:pPr indent="0" marL="0">
+              <a:buNone/>
+            </a:pPr>
+            <a:r>
+              <a:rPr lang="en-US" sz="1200" b="1" dirty="0">
+                <a:solidFill>
+                  <a:srgbClr val="111111"/>
+                </a:solidFill>
+              </a:rPr>
+              <a:t>La planificación tenía demasiado detalle</a:t>
+            </a:r>
+            <a:endParaRPr lang="en-US" sz="1200" dirty="0"/>
+          </a:p>
+        </p:txBody>
+      </p:sp>
+      <p:sp>
+        <p:nvSpPr>
+          <p:cNvPr id="17" name="Shape 15"/>
+          <p:cNvSpPr/>
+          <p:nvPr/>
+        </p:nvSpPr>
+        <p:spPr>
+          <a:xfrm>
+            <a:off x="3931920" y="2441448"/>
+            <a:ext cx="91440" cy="256032"/>
+          </a:xfrm>
+          <a:prstGeom prst="rightArrow">
+            <a:avLst/>
+          </a:prstGeom>
+          <a:solidFill>
+            <a:srgbClr val="F5C400"/>
+          </a:solidFill>
+          <a:ln w="12700">
+            <a:solidFill>
+              <a:srgbClr val="F5C400"/>
+            </a:solidFill>
+            <a:prstDash val="solid"/>
+          </a:ln>
+        </p:spPr>
+      </p:sp>
+      <p:sp>
+        <p:nvSpPr>
+          <p:cNvPr id="18" name="Shape 16"/>
+          <p:cNvSpPr/>
+          <p:nvPr/>
+        </p:nvSpPr>
+        <p:spPr>
+          <a:xfrm>
+            <a:off x="4069080" y="2350008"/>
+            <a:ext cx="4617720" cy="438912"/>
+          </a:xfrm>
+          <a:prstGeom prst="roundRect">
+            <a:avLst>
+              <a:gd name="adj" fmla="val 16667"/>
+            </a:avLst>
+          </a:prstGeom>
+          <a:solidFill>
+            <a:srgbClr val="FFF4BF"/>
+          </a:solidFill>
+          <a:ln w="12700">
+            <a:solidFill>
+              <a:srgbClr val="FFF4BF"/>
+            </a:solidFill>
+            <a:prstDash val="solid"/>
+          </a:ln>
+        </p:spPr>
+      </p:sp>
+      <p:sp>
+        <p:nvSpPr>
+          <p:cNvPr id="19" name="Text 17"/>
+          <p:cNvSpPr txBox="1"/>
+          <p:nvPr/>
+        </p:nvSpPr>
+        <p:spPr>
+          <a:xfrm>
+            <a:off x="4224528" y="2350008"/>
+            <a:ext cx="4389120" cy="438912"/>
+          </a:xfrm>
+          <a:prstGeom prst="rect">
+            <a:avLst/>
+          </a:prstGeom>
+          <a:noFill/>
+          <a:ln/>
+        </p:spPr>
+        <p:txBody>
+          <a:bodyPr wrap="square" lIns="0" tIns="0" rIns="0" bIns="0" rtlCol="0" anchor="ctr"/>
+          <a:lstStyle/>
+          <a:p>
+            <a:pPr indent="0" marL="0">
+              <a:buNone/>
+            </a:pPr>
+            <a:r>
+              <a:rPr lang="en-US" sz="1200" dirty="0">
+                <a:solidFill>
+                  <a:srgbClr val="111111"/>
+                </a:solidFill>
+              </a:rPr>
+              <a:t>Plan por metas de sprint, con la razón de su orden.</a:t>
+            </a:r>
+            <a:endParaRPr lang="en-US" sz="1200" dirty="0"/>
+          </a:p>
+        </p:txBody>
+      </p:sp>
+      <p:sp>
+        <p:nvSpPr>
+          <p:cNvPr id="20" name="Shape 18"/>
+          <p:cNvSpPr/>
+          <p:nvPr/>
+        </p:nvSpPr>
+        <p:spPr>
+          <a:xfrm>
+            <a:off x="457200" y="2862072"/>
+            <a:ext cx="3429000" cy="438912"/>
+          </a:xfrm>
+          <a:prstGeom prst="roundRect">
+            <a:avLst>
+              <a:gd name="adj" fmla="val 16667"/>
+            </a:avLst>
+          </a:prstGeom>
+          <a:solidFill>
+            <a:srgbClr val="F2F2F2"/>
+          </a:solidFill>
+          <a:ln w="12700">
+            <a:solidFill>
+              <a:srgbClr val="F2F2F2"/>
+            </a:solidFill>
+            <a:prstDash val="solid"/>
+          </a:ln>
+        </p:spPr>
+      </p:sp>
+      <p:sp>
+        <p:nvSpPr>
+          <p:cNvPr id="21" name="Text 19"/>
+          <p:cNvSpPr txBox="1"/>
+          <p:nvPr/>
+        </p:nvSpPr>
+        <p:spPr>
+          <a:xfrm>
+            <a:off x="621792" y="2862072"/>
+            <a:ext cx="3200400" cy="438912"/>
+          </a:xfrm>
+          <a:prstGeom prst="rect">
+            <a:avLst/>
+          </a:prstGeom>
+          <a:noFill/>
+          <a:ln/>
+        </p:spPr>
+        <p:txBody>
+          <a:bodyPr wrap="square" lIns="0" tIns="0" rIns="0" bIns="0" rtlCol="0" anchor="ctr"/>
+          <a:lstStyle/>
+          <a:p>
+            <a:pPr indent="0" marL="0">
+              <a:buNone/>
+            </a:pPr>
+            <a:r>
+              <a:rPr lang="en-US" sz="1200" b="1" dirty="0">
+                <a:solidFill>
+                  <a:srgbClr val="111111"/>
+                </a:solidFill>
+              </a:rPr>
+              <a:t>Muchos clientes en Irlanda usan iPhone</a:t>
+            </a:r>
+            <a:endParaRPr lang="en-US" sz="1200" dirty="0"/>
+          </a:p>
+        </p:txBody>
+      </p:sp>
+      <p:sp>
+        <p:nvSpPr>
+          <p:cNvPr id="22" name="Shape 20"/>
+          <p:cNvSpPr/>
+          <p:nvPr/>
+        </p:nvSpPr>
+        <p:spPr>
+          <a:xfrm>
+            <a:off x="3931920" y="2953512"/>
+            <a:ext cx="91440" cy="256032"/>
+          </a:xfrm>
+          <a:prstGeom prst="rightArrow">
+            <a:avLst/>
+          </a:prstGeom>
+          <a:solidFill>
+            <a:srgbClr val="F5C400"/>
+          </a:solidFill>
+          <a:ln w="12700">
+            <a:solidFill>
+              <a:srgbClr val="F5C400"/>
+            </a:solidFill>
+            <a:prstDash val="solid"/>
+          </a:ln>
+        </p:spPr>
+      </p:sp>
+      <p:sp>
+        <p:nvSpPr>
+          <p:cNvPr id="23" name="Shape 21"/>
+          <p:cNvSpPr/>
+          <p:nvPr/>
+        </p:nvSpPr>
+        <p:spPr>
+          <a:xfrm>
+            <a:off x="4069080" y="2862072"/>
+            <a:ext cx="4617720" cy="438912"/>
+          </a:xfrm>
+          <a:prstGeom prst="roundRect">
+            <a:avLst>
+              <a:gd name="adj" fmla="val 16667"/>
+            </a:avLst>
+          </a:prstGeom>
+          <a:solidFill>
+            <a:srgbClr val="FFF4BF"/>
+          </a:solidFill>
+          <a:ln w="12700">
+            <a:solidFill>
+              <a:srgbClr val="FFF4BF"/>
+            </a:solidFill>
+            <a:prstDash val="solid"/>
+          </a:ln>
+        </p:spPr>
+      </p:sp>
+      <p:sp>
+        <p:nvSpPr>
+          <p:cNvPr id="24" name="Text 22"/>
+          <p:cNvSpPr txBox="1"/>
+          <p:nvPr/>
+        </p:nvSpPr>
+        <p:spPr>
+          <a:xfrm>
+            <a:off x="4224528" y="2862072"/>
+            <a:ext cx="4389120" cy="438912"/>
+          </a:xfrm>
+          <a:prstGeom prst="rect">
+            <a:avLst/>
+          </a:prstGeom>
+          <a:noFill/>
+          <a:ln/>
+        </p:spPr>
+        <p:txBody>
+          <a:bodyPr wrap="square" lIns="0" tIns="0" rIns="0" bIns="0" rtlCol="0" anchor="ctr"/>
+          <a:lstStyle/>
+          <a:p>
+            <a:pPr indent="0" marL="0">
+              <a:buNone/>
+            </a:pPr>
+            <a:r>
+              <a:rPr lang="en-US" sz="1200" dirty="0">
+                <a:solidFill>
+                  <a:srgbClr val="111111"/>
+                </a:solidFill>
+              </a:rPr>
+              <a:t>Publicación también en App Store, compilando en la nube, sin Mac.</a:t>
+            </a:r>
+            <a:endParaRPr lang="en-US" sz="1200" dirty="0"/>
+          </a:p>
+        </p:txBody>
+      </p:sp>
+      <p:sp>
+        <p:nvSpPr>
+          <p:cNvPr id="25" name="Shape 23"/>
+          <p:cNvSpPr/>
+          <p:nvPr/>
+        </p:nvSpPr>
+        <p:spPr>
+          <a:xfrm>
+            <a:off x="457200" y="3374136"/>
+            <a:ext cx="3429000" cy="438912"/>
+          </a:xfrm>
+          <a:prstGeom prst="roundRect">
+            <a:avLst>
+              <a:gd name="adj" fmla="val 16667"/>
+            </a:avLst>
+          </a:prstGeom>
+          <a:solidFill>
+            <a:srgbClr val="F2F2F2"/>
+          </a:solidFill>
+          <a:ln w="12700">
+            <a:solidFill>
+              <a:srgbClr val="F2F2F2"/>
+            </a:solidFill>
+            <a:prstDash val="solid"/>
+          </a:ln>
+        </p:spPr>
+      </p:sp>
+      <p:sp>
+        <p:nvSpPr>
+          <p:cNvPr id="26" name="Text 24"/>
+          <p:cNvSpPr txBox="1"/>
+          <p:nvPr/>
+        </p:nvSpPr>
+        <p:spPr>
+          <a:xfrm>
+            <a:off x="621792" y="3374136"/>
+            <a:ext cx="3200400" cy="438912"/>
+          </a:xfrm>
+          <a:prstGeom prst="rect">
+            <a:avLst/>
+          </a:prstGeom>
+          <a:noFill/>
+          <a:ln/>
+        </p:spPr>
+        <p:txBody>
+          <a:bodyPr wrap="square" lIns="0" tIns="0" rIns="0" bIns="0" rtlCol="0" anchor="ctr"/>
+          <a:lstStyle/>
+          <a:p>
+            <a:pPr indent="0" marL="0">
+              <a:buNone/>
+            </a:pPr>
+            <a:r>
+              <a:rPr lang="en-US" sz="1200" b="1" dirty="0">
+                <a:solidFill>
+                  <a:srgbClr val="111111"/>
+                </a:solidFill>
+              </a:rPr>
+              <a:t>Subir todo a GitHub</a:t>
+            </a:r>
+            <a:endParaRPr lang="en-US" sz="1200" dirty="0"/>
+          </a:p>
+        </p:txBody>
+      </p:sp>
+      <p:sp>
+        <p:nvSpPr>
+          <p:cNvPr id="27" name="Shape 25"/>
+          <p:cNvSpPr/>
+          <p:nvPr/>
+        </p:nvSpPr>
+        <p:spPr>
+          <a:xfrm>
+            <a:off x="3931920" y="3465576"/>
+            <a:ext cx="91440" cy="256032"/>
+          </a:xfrm>
+          <a:prstGeom prst="rightArrow">
+            <a:avLst/>
+          </a:prstGeom>
+          <a:solidFill>
+            <a:srgbClr val="F5C400"/>
+          </a:solidFill>
+          <a:ln w="12700">
+            <a:solidFill>
+              <a:srgbClr val="F5C400"/>
+            </a:solidFill>
+            <a:prstDash val="solid"/>
+          </a:ln>
+        </p:spPr>
+      </p:sp>
+      <p:sp>
+        <p:nvSpPr>
+          <p:cNvPr id="28" name="Shape 26"/>
+          <p:cNvSpPr/>
+          <p:nvPr/>
+        </p:nvSpPr>
+        <p:spPr>
+          <a:xfrm>
+            <a:off x="4069080" y="3374136"/>
+            <a:ext cx="4617720" cy="438912"/>
+          </a:xfrm>
+          <a:prstGeom prst="roundRect">
+            <a:avLst>
+              <a:gd name="adj" fmla="val 16667"/>
+            </a:avLst>
+          </a:prstGeom>
+          <a:solidFill>
+            <a:srgbClr val="FFF4BF"/>
+          </a:solidFill>
+          <a:ln w="12700">
+            <a:solidFill>
+              <a:srgbClr val="FFF4BF"/>
+            </a:solidFill>
+            <a:prstDash val="solid"/>
+          </a:ln>
+        </p:spPr>
+      </p:sp>
+      <p:sp>
+        <p:nvSpPr>
+          <p:cNvPr id="29" name="Text 27"/>
+          <p:cNvSpPr txBox="1"/>
+          <p:nvPr/>
+        </p:nvSpPr>
+        <p:spPr>
+          <a:xfrm>
+            <a:off x="4224528" y="3374136"/>
+            <a:ext cx="4389120" cy="438912"/>
+          </a:xfrm>
+          <a:prstGeom prst="rect">
+            <a:avLst/>
+          </a:prstGeom>
+          <a:noFill/>
+          <a:ln/>
+        </p:spPr>
+        <p:txBody>
+          <a:bodyPr wrap="square" lIns="0" tIns="0" rIns="0" bIns="0" rtlCol="0" anchor="ctr"/>
+          <a:lstStyle/>
+          <a:p>
+            <a:pPr indent="0" marL="0">
+              <a:buNone/>
+            </a:pPr>
+            <a:r>
+              <a:rPr lang="en-US" sz="1200" dirty="0">
+                <a:solidFill>
+                  <a:srgbClr val="111111"/>
+                </a:solidFill>
+              </a:rPr>
+              <a:t>Repositorio público con código, informes, matriz y backlog.</a:t>
+            </a:r>
+            <a:endParaRPr lang="en-US" sz="1200" dirty="0"/>
+          </a:p>
+        </p:txBody>
+      </p:sp>
+      <p:sp>
+        <p:nvSpPr>
+          <p:cNvPr id="30" name="Shape 28"/>
+          <p:cNvSpPr/>
+          <p:nvPr/>
+        </p:nvSpPr>
+        <p:spPr>
+          <a:xfrm>
+            <a:off x="457200" y="3977640"/>
+            <a:ext cx="8229600" cy="640080"/>
+          </a:xfrm>
+          <a:prstGeom prst="roundRect">
+            <a:avLst>
+              <a:gd name="adj" fmla="val 11429"/>
             </a:avLst>
           </a:prstGeom>
           <a:solidFill>
@@ -4739,859 +5822,50 @@
           </a:ln>
         </p:spPr>
       </p:sp>
-      <p:pic>
-        <p:nvPicPr>
-          <p:cNvPr id="5" name="Image 0" descr="Captura de la app: Pase QR del cliente">    </p:cNvPr>
-          <p:cNvPicPr>
-            <a:picLocks noChangeAspect="1"/>
-          </p:cNvPicPr>
-          <p:nvPr/>
-        </p:nvPicPr>
-        <p:blipFill>
-          <a:blip r:embed="rId1"/>
-          <a:stretch>
-            <a:fillRect/>
-          </a:stretch>
-        </p:blipFill>
-        <p:spPr>
-          <a:xfrm>
-            <a:off x="640080" y="1188720"/>
-            <a:ext cx="802780" cy="1737360"/>
-          </a:xfrm>
-          <a:prstGeom prst="rect">
-            <a:avLst/>
-          </a:prstGeom>
-        </p:spPr>
-      </p:pic>
-      <p:sp>
-        <p:nvSpPr>
-          <p:cNvPr id="6" name="Text 3"/>
-          <p:cNvSpPr txBox="1"/>
-          <p:nvPr/>
-        </p:nvSpPr>
-        <p:spPr>
-          <a:xfrm>
-            <a:off x="1554480" y="1234440"/>
-            <a:ext cx="1463040" cy="365760"/>
-          </a:xfrm>
-          <a:prstGeom prst="rect">
-            <a:avLst/>
-          </a:prstGeom>
-          <a:noFill/>
-          <a:ln/>
-        </p:spPr>
-        <p:txBody>
-          <a:bodyPr wrap="square" lIns="0" tIns="0" rIns="0" bIns="0" rtlCol="0" anchor="t"/>
+      <p:sp>
+        <p:nvSpPr>
+          <p:cNvPr id="31" name="Text 29"/>
+          <p:cNvSpPr txBox="1"/>
+          <p:nvPr/>
+        </p:nvSpPr>
+        <p:spPr>
+          <a:xfrm>
+            <a:off x="658368" y="3977640"/>
+            <a:ext cx="7863840" cy="640080"/>
+          </a:xfrm>
+          <a:prstGeom prst="rect">
+            <a:avLst/>
+          </a:prstGeom>
+          <a:noFill/>
+          <a:ln/>
+        </p:spPr>
+        <p:txBody>
+          <a:bodyPr wrap="square" lIns="0" tIns="0" rIns="0" bIns="0" rtlCol="0" anchor="ctr"/>
           <a:lstStyle/>
           <a:p>
             <a:pPr indent="0" marL="0">
               <a:buNone/>
             </a:pPr>
             <a:r>
-              <a:rPr lang="en-US" sz="1500" b="1" dirty="0">
-                <a:solidFill>
-                  <a:srgbClr val="111111"/>
-                </a:solidFill>
-                <a:latin typeface="Arial" pitchFamily="34" charset="0"/>
-                <a:ea typeface="Arial" pitchFamily="34" charset="-122"/>
-                <a:cs typeface="Arial" pitchFamily="34" charset="-120"/>
-              </a:rPr>
-              <a:t>Cliente</a:t>
-            </a:r>
-            <a:endParaRPr lang="en-US" sz="1500" dirty="0"/>
-          </a:p>
-        </p:txBody>
-      </p:sp>
-      <p:sp>
-        <p:nvSpPr>
-          <p:cNvPr id="7" name="Text 4"/>
-          <p:cNvSpPr txBox="1"/>
-          <p:nvPr/>
-        </p:nvSpPr>
-        <p:spPr>
-          <a:xfrm>
-            <a:off x="1554480" y="1645920"/>
-            <a:ext cx="1417320" cy="1325880"/>
-          </a:xfrm>
-          <a:prstGeom prst="rect">
-            <a:avLst/>
-          </a:prstGeom>
-          <a:noFill/>
-          <a:ln/>
-        </p:spPr>
-        <p:txBody>
-          <a:bodyPr wrap="square" lIns="0" tIns="0" rIns="0" bIns="0" rtlCol="0" anchor="t"/>
-          <a:lstStyle/>
-          <a:p>
+              <a:rPr lang="en-US" sz="1300" b="1" dirty="0">
+                <a:solidFill>
+                  <a:srgbClr val="F5C400"/>
+                </a:solidFill>
+              </a:rPr>
+              <a:t>Avance desde el 15 de octubre: </a:t>
+            </a:r>
             <a:pPr indent="0" marL="0">
               <a:buNone/>
             </a:pPr>
             <a:r>
               <a:rPr lang="en-US" sz="1300" dirty="0">
                 <a:solidFill>
-                  <a:srgbClr val="111111"/>
-                </a:solidFill>
-              </a:rPr>
-              <a:t>Muestra su QR para sumar visitas y canjear premios.</a:t>
+                  <a:srgbClr val="FFFFFF"/>
+                </a:solidFill>
+              </a:rPr>
+              <a:t>Sprint 0 completado. En el Sprint 1 ya están CORS, el límite de intentos en login y escaneo, y las primeras 10 pruebas automatizadas.</a:t>
             </a:r>
             <a:endParaRPr lang="en-US" sz="1300" dirty="0"/>
-          </a:p>
-        </p:txBody>
-      </p:sp>
-      <p:sp>
-        <p:nvSpPr>
-          <p:cNvPr id="8" name="Shape 5"/>
-          <p:cNvSpPr/>
-          <p:nvPr/>
-        </p:nvSpPr>
-        <p:spPr>
-          <a:xfrm>
-            <a:off x="3246120" y="1051560"/>
-            <a:ext cx="2606040" cy="2011680"/>
-          </a:xfrm>
-          <a:prstGeom prst="roundRect">
-            <a:avLst>
-              <a:gd name="adj" fmla="val 3636"/>
-            </a:avLst>
-          </a:prstGeom>
-          <a:solidFill>
-            <a:srgbClr val="F2F2F2"/>
-          </a:solidFill>
-          <a:ln w="12700">
-            <a:solidFill>
-              <a:srgbClr val="F2F2F2"/>
-            </a:solidFill>
-            <a:prstDash val="solid"/>
-          </a:ln>
-        </p:spPr>
-      </p:sp>
-      <p:sp>
-        <p:nvSpPr>
-          <p:cNvPr id="9" name="Shape 6"/>
-          <p:cNvSpPr/>
-          <p:nvPr/>
-        </p:nvSpPr>
-        <p:spPr>
-          <a:xfrm>
-            <a:off x="3374136" y="1133856"/>
-            <a:ext cx="912508" cy="1847088"/>
-          </a:xfrm>
-          <a:prstGeom prst="roundRect">
-            <a:avLst>
-              <a:gd name="adj" fmla="val 14029"/>
-            </a:avLst>
-          </a:prstGeom>
-          <a:solidFill>
-            <a:srgbClr val="111111"/>
-          </a:solidFill>
-          <a:ln w="12700">
-            <a:solidFill>
-              <a:srgbClr val="111111"/>
-            </a:solidFill>
-            <a:prstDash val="solid"/>
-          </a:ln>
-        </p:spPr>
-      </p:sp>
-      <p:pic>
-        <p:nvPicPr>
-          <p:cNvPr id="10" name="Image 1" descr="Captura de la app: Resultado de visita">    </p:cNvPr>
-          <p:cNvPicPr>
-            <a:picLocks noChangeAspect="1"/>
-          </p:cNvPicPr>
-          <p:nvPr/>
-        </p:nvPicPr>
-        <p:blipFill>
-          <a:blip r:embed="rId2"/>
-          <a:stretch>
-            <a:fillRect/>
-          </a:stretch>
-        </p:blipFill>
-        <p:spPr>
-          <a:xfrm>
-            <a:off x="3429000" y="1188720"/>
-            <a:ext cx="802780" cy="1737360"/>
-          </a:xfrm>
-          <a:prstGeom prst="rect">
-            <a:avLst/>
-          </a:prstGeom>
-        </p:spPr>
-      </p:pic>
-      <p:sp>
-        <p:nvSpPr>
-          <p:cNvPr id="11" name="Text 7"/>
-          <p:cNvSpPr txBox="1"/>
-          <p:nvPr/>
-        </p:nvSpPr>
-        <p:spPr>
-          <a:xfrm>
-            <a:off x="4343400" y="1234440"/>
-            <a:ext cx="1463040" cy="365760"/>
-          </a:xfrm>
-          <a:prstGeom prst="rect">
-            <a:avLst/>
-          </a:prstGeom>
-          <a:noFill/>
-          <a:ln/>
-        </p:spPr>
-        <p:txBody>
-          <a:bodyPr wrap="square" lIns="0" tIns="0" rIns="0" bIns="0" rtlCol="0" anchor="t"/>
-          <a:lstStyle/>
-          <a:p>
-            <a:pPr indent="0" marL="0">
-              <a:buNone/>
-            </a:pPr>
-            <a:r>
-              <a:rPr lang="en-US" sz="1500" b="1" dirty="0">
-                <a:solidFill>
-                  <a:srgbClr val="111111"/>
-                </a:solidFill>
-                <a:latin typeface="Arial" pitchFamily="34" charset="0"/>
-                <a:ea typeface="Arial" pitchFamily="34" charset="-122"/>
-                <a:cs typeface="Arial" pitchFamily="34" charset="-120"/>
-              </a:rPr>
-              <a:t>Personal</a:t>
-            </a:r>
-            <a:endParaRPr lang="en-US" sz="1500" dirty="0"/>
-          </a:p>
-        </p:txBody>
-      </p:sp>
-      <p:sp>
-        <p:nvSpPr>
-          <p:cNvPr id="12" name="Text 8"/>
-          <p:cNvSpPr txBox="1"/>
-          <p:nvPr/>
-        </p:nvSpPr>
-        <p:spPr>
-          <a:xfrm>
-            <a:off x="4343400" y="1645920"/>
-            <a:ext cx="1417320" cy="1325880"/>
-          </a:xfrm>
-          <a:prstGeom prst="rect">
-            <a:avLst/>
-          </a:prstGeom>
-          <a:noFill/>
-          <a:ln/>
-        </p:spPr>
-        <p:txBody>
-          <a:bodyPr wrap="square" lIns="0" tIns="0" rIns="0" bIns="0" rtlCol="0" anchor="t"/>
-          <a:lstStyle/>
-          <a:p>
-            <a:pPr indent="0" marL="0">
-              <a:buNone/>
-            </a:pPr>
-            <a:r>
-              <a:rPr lang="en-US" sz="1300" dirty="0">
-                <a:solidFill>
-                  <a:srgbClr val="111111"/>
-                </a:solidFill>
-              </a:rPr>
-              <a:t>Escanea el QR del cliente y suma la visita al instante.</a:t>
-            </a:r>
-            <a:endParaRPr lang="en-US" sz="1300" dirty="0"/>
-          </a:p>
-        </p:txBody>
-      </p:sp>
-      <p:sp>
-        <p:nvSpPr>
-          <p:cNvPr id="13" name="Shape 9"/>
-          <p:cNvSpPr/>
-          <p:nvPr/>
-        </p:nvSpPr>
-        <p:spPr>
-          <a:xfrm>
-            <a:off x="6035040" y="1051560"/>
-            <a:ext cx="2606040" cy="2011680"/>
-          </a:xfrm>
-          <a:prstGeom prst="roundRect">
-            <a:avLst>
-              <a:gd name="adj" fmla="val 3636"/>
-            </a:avLst>
-          </a:prstGeom>
-          <a:solidFill>
-            <a:srgbClr val="F2F2F2"/>
-          </a:solidFill>
-          <a:ln w="12700">
-            <a:solidFill>
-              <a:srgbClr val="F2F2F2"/>
-            </a:solidFill>
-            <a:prstDash val="solid"/>
-          </a:ln>
-        </p:spPr>
-      </p:sp>
-      <p:sp>
-        <p:nvSpPr>
-          <p:cNvPr id="14" name="Shape 10"/>
-          <p:cNvSpPr/>
-          <p:nvPr/>
-        </p:nvSpPr>
-        <p:spPr>
-          <a:xfrm>
-            <a:off x="6163056" y="1133856"/>
-            <a:ext cx="912508" cy="1847088"/>
-          </a:xfrm>
-          <a:prstGeom prst="roundRect">
-            <a:avLst>
-              <a:gd name="adj" fmla="val 14029"/>
-            </a:avLst>
-          </a:prstGeom>
-          <a:solidFill>
-            <a:srgbClr val="111111"/>
-          </a:solidFill>
-          <a:ln w="12700">
-            <a:solidFill>
-              <a:srgbClr val="111111"/>
-            </a:solidFill>
-            <a:prstDash val="solid"/>
-          </a:ln>
-        </p:spPr>
-      </p:sp>
-      <p:pic>
-        <p:nvPicPr>
-          <p:cNvPr id="15" name="Image 2" descr="Captura de la app: Panel del dueno">    </p:cNvPr>
-          <p:cNvPicPr>
-            <a:picLocks noChangeAspect="1"/>
-          </p:cNvPicPr>
-          <p:nvPr/>
-        </p:nvPicPr>
-        <p:blipFill>
-          <a:blip r:embed="rId3"/>
-          <a:stretch>
-            <a:fillRect/>
-          </a:stretch>
-        </p:blipFill>
-        <p:spPr>
-          <a:xfrm>
-            <a:off x="6217920" y="1188720"/>
-            <a:ext cx="802780" cy="1737360"/>
-          </a:xfrm>
-          <a:prstGeom prst="rect">
-            <a:avLst/>
-          </a:prstGeom>
-        </p:spPr>
-      </p:pic>
-      <p:sp>
-        <p:nvSpPr>
-          <p:cNvPr id="16" name="Text 11"/>
-          <p:cNvSpPr txBox="1"/>
-          <p:nvPr/>
-        </p:nvSpPr>
-        <p:spPr>
-          <a:xfrm>
-            <a:off x="7132320" y="1234440"/>
-            <a:ext cx="1463040" cy="365760"/>
-          </a:xfrm>
-          <a:prstGeom prst="rect">
-            <a:avLst/>
-          </a:prstGeom>
-          <a:noFill/>
-          <a:ln/>
-        </p:spPr>
-        <p:txBody>
-          <a:bodyPr wrap="square" lIns="0" tIns="0" rIns="0" bIns="0" rtlCol="0" anchor="t"/>
-          <a:lstStyle/>
-          <a:p>
-            <a:pPr indent="0" marL="0">
-              <a:buNone/>
-            </a:pPr>
-            <a:r>
-              <a:rPr lang="en-US" sz="1500" b="1" dirty="0">
-                <a:solidFill>
-                  <a:srgbClr val="111111"/>
-                </a:solidFill>
-                <a:latin typeface="Arial" pitchFamily="34" charset="0"/>
-                <a:ea typeface="Arial" pitchFamily="34" charset="-122"/>
-                <a:cs typeface="Arial" pitchFamily="34" charset="-120"/>
-              </a:rPr>
-              <a:t>Administrador</a:t>
-            </a:r>
-            <a:endParaRPr lang="en-US" sz="1500" dirty="0"/>
-          </a:p>
-        </p:txBody>
-      </p:sp>
-      <p:sp>
-        <p:nvSpPr>
-          <p:cNvPr id="17" name="Text 12"/>
-          <p:cNvSpPr txBox="1"/>
-          <p:nvPr/>
-        </p:nvSpPr>
-        <p:spPr>
-          <a:xfrm>
-            <a:off x="7132320" y="1645920"/>
-            <a:ext cx="1417320" cy="1325880"/>
-          </a:xfrm>
-          <a:prstGeom prst="rect">
-            <a:avLst/>
-          </a:prstGeom>
-          <a:noFill/>
-          <a:ln/>
-        </p:spPr>
-        <p:txBody>
-          <a:bodyPr wrap="square" lIns="0" tIns="0" rIns="0" bIns="0" rtlCol="0" anchor="t"/>
-          <a:lstStyle/>
-          <a:p>
-            <a:pPr indent="0" marL="0">
-              <a:buNone/>
-            </a:pPr>
-            <a:r>
-              <a:rPr lang="en-US" sz="1300" dirty="0">
-                <a:solidFill>
-                  <a:srgbClr val="111111"/>
-                </a:solidFill>
-              </a:rPr>
-              <a:t>Gestiona menú, premios y promociones, y ve indicadores.</a:t>
-            </a:r>
-            <a:endParaRPr lang="en-US" sz="1300" dirty="0"/>
-          </a:p>
-        </p:txBody>
-      </p:sp>
-      <p:sp>
-        <p:nvSpPr>
-          <p:cNvPr id="18" name="Shape 13"/>
-          <p:cNvSpPr/>
-          <p:nvPr/>
-        </p:nvSpPr>
-        <p:spPr>
-          <a:xfrm>
-            <a:off x="457200" y="3246120"/>
-            <a:ext cx="8229600" cy="1280160"/>
-          </a:xfrm>
-          <a:prstGeom prst="roundRect">
-            <a:avLst>
-              <a:gd name="adj" fmla="val 5714"/>
-            </a:avLst>
-          </a:prstGeom>
-          <a:solidFill>
-            <a:srgbClr val="111111"/>
-          </a:solidFill>
-          <a:ln w="12700">
-            <a:solidFill>
-              <a:srgbClr val="111111"/>
-            </a:solidFill>
-            <a:prstDash val="solid"/>
-          </a:ln>
-        </p:spPr>
-      </p:sp>
-      <p:sp>
-        <p:nvSpPr>
-          <p:cNvPr id="19" name="Text 14"/>
-          <p:cNvSpPr txBox="1"/>
-          <p:nvPr/>
-        </p:nvSpPr>
-        <p:spPr>
-          <a:xfrm>
-            <a:off x="685800" y="3364992"/>
-            <a:ext cx="3657600" cy="274320"/>
-          </a:xfrm>
-          <a:prstGeom prst="rect">
-            <a:avLst/>
-          </a:prstGeom>
-          <a:noFill/>
-          <a:ln/>
-        </p:spPr>
-        <p:txBody>
-          <a:bodyPr wrap="square" lIns="0" tIns="0" rIns="0" bIns="0" rtlCol="0" anchor="t"/>
-          <a:lstStyle/>
-          <a:p>
-            <a:pPr indent="0" marL="0">
-              <a:buNone/>
-            </a:pPr>
-            <a:r>
-              <a:rPr lang="en-US" sz="1400" b="1" dirty="0">
-                <a:solidFill>
-                  <a:srgbClr val="F5C400"/>
-                </a:solidFill>
-              </a:rPr>
-              <a:t>Cómo se registra una visita</a:t>
-            </a:r>
-            <a:endParaRPr lang="en-US" sz="1400" dirty="0"/>
-          </a:p>
-        </p:txBody>
-      </p:sp>
-      <p:sp>
-        <p:nvSpPr>
-          <p:cNvPr id="20" name="Shape 15"/>
-          <p:cNvSpPr/>
-          <p:nvPr/>
-        </p:nvSpPr>
-        <p:spPr>
-          <a:xfrm>
-            <a:off x="685800" y="3767328"/>
-            <a:ext cx="365760" cy="365760"/>
-          </a:xfrm>
-          <a:prstGeom prst="ellipse">
-            <a:avLst/>
-          </a:prstGeom>
-          <a:solidFill>
-            <a:srgbClr val="F5C400"/>
-          </a:solidFill>
-          <a:ln w="12700">
-            <a:solidFill>
-              <a:srgbClr val="F5C400"/>
-            </a:solidFill>
-            <a:prstDash val="solid"/>
-          </a:ln>
-        </p:spPr>
-      </p:sp>
-      <p:sp>
-        <p:nvSpPr>
-          <p:cNvPr id="21" name="Text 16"/>
-          <p:cNvSpPr txBox="1"/>
-          <p:nvPr/>
-        </p:nvSpPr>
-        <p:spPr>
-          <a:xfrm>
-            <a:off x="685800" y="3767328"/>
-            <a:ext cx="365760" cy="365760"/>
-          </a:xfrm>
-          <a:prstGeom prst="rect">
-            <a:avLst/>
-          </a:prstGeom>
-          <a:noFill/>
-          <a:ln/>
-        </p:spPr>
-        <p:txBody>
-          <a:bodyPr wrap="square" lIns="0" tIns="0" rIns="0" bIns="0" rtlCol="0" anchor="ctr"/>
-          <a:lstStyle/>
-          <a:p>
-            <a:pPr algn="ctr" indent="0" marL="0">
-              <a:buNone/>
-            </a:pPr>
-            <a:r>
-              <a:rPr lang="en-US" sz="1400" b="1" dirty="0">
-                <a:solidFill>
-                  <a:srgbClr val="111111"/>
-                </a:solidFill>
-              </a:rPr>
-              <a:t>1</a:t>
-            </a:r>
-            <a:endParaRPr lang="en-US" sz="1400" dirty="0"/>
-          </a:p>
-        </p:txBody>
-      </p:sp>
-      <p:sp>
-        <p:nvSpPr>
-          <p:cNvPr id="22" name="Text 17"/>
-          <p:cNvSpPr txBox="1"/>
-          <p:nvPr/>
-        </p:nvSpPr>
-        <p:spPr>
-          <a:xfrm>
-            <a:off x="1143000" y="3703320"/>
-            <a:ext cx="1417320" cy="731520"/>
-          </a:xfrm>
-          <a:prstGeom prst="rect">
-            <a:avLst/>
-          </a:prstGeom>
-          <a:noFill/>
-          <a:ln/>
-        </p:spPr>
-        <p:txBody>
-          <a:bodyPr wrap="square" lIns="0" tIns="0" rIns="0" bIns="0" rtlCol="0" anchor="ctr"/>
-          <a:lstStyle/>
-          <a:p>
-            <a:pPr indent="0" marL="0">
-              <a:buNone/>
-            </a:pPr>
-            <a:r>
-              <a:rPr lang="en-US" sz="1200" dirty="0">
-                <a:solidFill>
-                  <a:srgbClr val="FFFFFF"/>
-                </a:solidFill>
-              </a:rPr>
-              <a:t>El cliente abre su QR: dura 3 minutos y sirve una vez</a:t>
-            </a:r>
-            <a:endParaRPr lang="en-US" sz="1200" dirty="0"/>
-          </a:p>
-        </p:txBody>
-      </p:sp>
-      <p:sp>
-        <p:nvSpPr>
-          <p:cNvPr id="23" name="Shape 18"/>
-          <p:cNvSpPr/>
-          <p:nvPr/>
-        </p:nvSpPr>
-        <p:spPr>
-          <a:xfrm>
-            <a:off x="2697480" y="3767328"/>
-            <a:ext cx="365760" cy="365760"/>
-          </a:xfrm>
-          <a:prstGeom prst="ellipse">
-            <a:avLst/>
-          </a:prstGeom>
-          <a:solidFill>
-            <a:srgbClr val="F5C400"/>
-          </a:solidFill>
-          <a:ln w="12700">
-            <a:solidFill>
-              <a:srgbClr val="F5C400"/>
-            </a:solidFill>
-            <a:prstDash val="solid"/>
-          </a:ln>
-        </p:spPr>
-      </p:sp>
-      <p:sp>
-        <p:nvSpPr>
-          <p:cNvPr id="24" name="Text 19"/>
-          <p:cNvSpPr txBox="1"/>
-          <p:nvPr/>
-        </p:nvSpPr>
-        <p:spPr>
-          <a:xfrm>
-            <a:off x="2697480" y="3767328"/>
-            <a:ext cx="365760" cy="365760"/>
-          </a:xfrm>
-          <a:prstGeom prst="rect">
-            <a:avLst/>
-          </a:prstGeom>
-          <a:noFill/>
-          <a:ln/>
-        </p:spPr>
-        <p:txBody>
-          <a:bodyPr wrap="square" lIns="0" tIns="0" rIns="0" bIns="0" rtlCol="0" anchor="ctr"/>
-          <a:lstStyle/>
-          <a:p>
-            <a:pPr algn="ctr" indent="0" marL="0">
-              <a:buNone/>
-            </a:pPr>
-            <a:r>
-              <a:rPr lang="en-US" sz="1400" b="1" dirty="0">
-                <a:solidFill>
-                  <a:srgbClr val="111111"/>
-                </a:solidFill>
-              </a:rPr>
-              <a:t>2</a:t>
-            </a:r>
-            <a:endParaRPr lang="en-US" sz="1400" dirty="0"/>
-          </a:p>
-        </p:txBody>
-      </p:sp>
-      <p:sp>
-        <p:nvSpPr>
-          <p:cNvPr id="25" name="Text 20"/>
-          <p:cNvSpPr txBox="1"/>
-          <p:nvPr/>
-        </p:nvSpPr>
-        <p:spPr>
-          <a:xfrm>
-            <a:off x="3154680" y="3703320"/>
-            <a:ext cx="1417320" cy="731520"/>
-          </a:xfrm>
-          <a:prstGeom prst="rect">
-            <a:avLst/>
-          </a:prstGeom>
-          <a:noFill/>
-          <a:ln/>
-        </p:spPr>
-        <p:txBody>
-          <a:bodyPr wrap="square" lIns="0" tIns="0" rIns="0" bIns="0" rtlCol="0" anchor="ctr"/>
-          <a:lstStyle/>
-          <a:p>
-            <a:pPr indent="0" marL="0">
-              <a:buNone/>
-            </a:pPr>
-            <a:r>
-              <a:rPr lang="en-US" sz="1200" dirty="0">
-                <a:solidFill>
-                  <a:srgbClr val="FFFFFF"/>
-                </a:solidFill>
-              </a:rPr>
-              <a:t>El mesero lo escanea</a:t>
-            </a:r>
-            <a:endParaRPr lang="en-US" sz="1200" dirty="0"/>
-          </a:p>
-        </p:txBody>
-      </p:sp>
-      <p:sp>
-        <p:nvSpPr>
-          <p:cNvPr id="26" name="Shape 21"/>
-          <p:cNvSpPr/>
-          <p:nvPr/>
-        </p:nvSpPr>
-        <p:spPr>
-          <a:xfrm>
-            <a:off x="4709160" y="3767328"/>
-            <a:ext cx="365760" cy="365760"/>
-          </a:xfrm>
-          <a:prstGeom prst="ellipse">
-            <a:avLst/>
-          </a:prstGeom>
-          <a:solidFill>
-            <a:srgbClr val="F5C400"/>
-          </a:solidFill>
-          <a:ln w="12700">
-            <a:solidFill>
-              <a:srgbClr val="F5C400"/>
-            </a:solidFill>
-            <a:prstDash val="solid"/>
-          </a:ln>
-        </p:spPr>
-      </p:sp>
-      <p:sp>
-        <p:nvSpPr>
-          <p:cNvPr id="27" name="Text 22"/>
-          <p:cNvSpPr txBox="1"/>
-          <p:nvPr/>
-        </p:nvSpPr>
-        <p:spPr>
-          <a:xfrm>
-            <a:off x="4709160" y="3767328"/>
-            <a:ext cx="365760" cy="365760"/>
-          </a:xfrm>
-          <a:prstGeom prst="rect">
-            <a:avLst/>
-          </a:prstGeom>
-          <a:noFill/>
-          <a:ln/>
-        </p:spPr>
-        <p:txBody>
-          <a:bodyPr wrap="square" lIns="0" tIns="0" rIns="0" bIns="0" rtlCol="0" anchor="ctr"/>
-          <a:lstStyle/>
-          <a:p>
-            <a:pPr algn="ctr" indent="0" marL="0">
-              <a:buNone/>
-            </a:pPr>
-            <a:r>
-              <a:rPr lang="en-US" sz="1400" b="1" dirty="0">
-                <a:solidFill>
-                  <a:srgbClr val="111111"/>
-                </a:solidFill>
-              </a:rPr>
-              <a:t>3</a:t>
-            </a:r>
-            <a:endParaRPr lang="en-US" sz="1400" dirty="0"/>
-          </a:p>
-        </p:txBody>
-      </p:sp>
-      <p:sp>
-        <p:nvSpPr>
-          <p:cNvPr id="28" name="Text 23"/>
-          <p:cNvSpPr txBox="1"/>
-          <p:nvPr/>
-        </p:nvSpPr>
-        <p:spPr>
-          <a:xfrm>
-            <a:off x="5166360" y="3703320"/>
-            <a:ext cx="1417320" cy="731520"/>
-          </a:xfrm>
-          <a:prstGeom prst="rect">
-            <a:avLst/>
-          </a:prstGeom>
-          <a:noFill/>
-          <a:ln/>
-        </p:spPr>
-        <p:txBody>
-          <a:bodyPr wrap="square" lIns="0" tIns="0" rIns="0" bIns="0" rtlCol="0" anchor="ctr"/>
-          <a:lstStyle/>
-          <a:p>
-            <a:pPr indent="0" marL="0">
-              <a:buNone/>
-            </a:pPr>
-            <a:r>
-              <a:rPr lang="en-US" sz="1200" dirty="0">
-                <a:solidFill>
-                  <a:srgbClr val="FFFFFF"/>
-                </a:solidFill>
-              </a:rPr>
-              <a:t>El servidor lo valida y suma la visita</a:t>
-            </a:r>
-            <a:endParaRPr lang="en-US" sz="1200" dirty="0"/>
-          </a:p>
-        </p:txBody>
-      </p:sp>
-      <p:sp>
-        <p:nvSpPr>
-          <p:cNvPr id="29" name="Shape 24"/>
-          <p:cNvSpPr/>
-          <p:nvPr/>
-        </p:nvSpPr>
-        <p:spPr>
-          <a:xfrm>
-            <a:off x="6720840" y="3767328"/>
-            <a:ext cx="365760" cy="365760"/>
-          </a:xfrm>
-          <a:prstGeom prst="ellipse">
-            <a:avLst/>
-          </a:prstGeom>
-          <a:solidFill>
-            <a:srgbClr val="F5C400"/>
-          </a:solidFill>
-          <a:ln w="12700">
-            <a:solidFill>
-              <a:srgbClr val="F5C400"/>
-            </a:solidFill>
-            <a:prstDash val="solid"/>
-          </a:ln>
-        </p:spPr>
-      </p:sp>
-      <p:sp>
-        <p:nvSpPr>
-          <p:cNvPr id="30" name="Text 25"/>
-          <p:cNvSpPr txBox="1"/>
-          <p:nvPr/>
-        </p:nvSpPr>
-        <p:spPr>
-          <a:xfrm>
-            <a:off x="6720840" y="3767328"/>
-            <a:ext cx="365760" cy="365760"/>
-          </a:xfrm>
-          <a:prstGeom prst="rect">
-            <a:avLst/>
-          </a:prstGeom>
-          <a:noFill/>
-          <a:ln/>
-        </p:spPr>
-        <p:txBody>
-          <a:bodyPr wrap="square" lIns="0" tIns="0" rIns="0" bIns="0" rtlCol="0" anchor="ctr"/>
-          <a:lstStyle/>
-          <a:p>
-            <a:pPr algn="ctr" indent="0" marL="0">
-              <a:buNone/>
-            </a:pPr>
-            <a:r>
-              <a:rPr lang="en-US" sz="1400" b="1" dirty="0">
-                <a:solidFill>
-                  <a:srgbClr val="111111"/>
-                </a:solidFill>
-              </a:rPr>
-              <a:t>4</a:t>
-            </a:r>
-            <a:endParaRPr lang="en-US" sz="1400" dirty="0"/>
-          </a:p>
-        </p:txBody>
-      </p:sp>
-      <p:sp>
-        <p:nvSpPr>
-          <p:cNvPr id="31" name="Text 26"/>
-          <p:cNvSpPr txBox="1"/>
-          <p:nvPr/>
-        </p:nvSpPr>
-        <p:spPr>
-          <a:xfrm>
-            <a:off x="7178040" y="3703320"/>
-            <a:ext cx="1417320" cy="731520"/>
-          </a:xfrm>
-          <a:prstGeom prst="rect">
-            <a:avLst/>
-          </a:prstGeom>
-          <a:noFill/>
-          <a:ln/>
-        </p:spPr>
-        <p:txBody>
-          <a:bodyPr wrap="square" lIns="0" tIns="0" rIns="0" bIns="0" rtlCol="0" anchor="ctr"/>
-          <a:lstStyle/>
-          <a:p>
-            <a:pPr indent="0" marL="0">
-              <a:buNone/>
-            </a:pPr>
-            <a:r>
-              <a:rPr lang="en-US" sz="1200" dirty="0">
-                <a:solidFill>
-                  <a:srgbClr val="FFFFFF"/>
-                </a:solidFill>
-              </a:rPr>
-              <a:t>Al llegar a la meta, canjea su premio</a:t>
-            </a:r>
-            <a:endParaRPr lang="en-US" sz="1200" dirty="0"/>
           </a:p>
         </p:txBody>
       </p:sp>
@@ -7496,6 +7770,69 @@
       </p:sp>
       <p:sp>
         <p:nvSpPr>
+          <p:cNvPr id="57" name="Shape 54"/>
+          <p:cNvSpPr/>
+          <p:nvPr/>
+        </p:nvSpPr>
+        <p:spPr>
+          <a:xfrm>
+            <a:off x="6446520" y="4745736"/>
+            <a:ext cx="1600200" cy="246888"/>
+          </a:xfrm>
+          <a:prstGeom prst="roundRect">
+            <a:avLst>
+              <a:gd name="adj" fmla="val 48148"/>
+            </a:avLst>
+          </a:prstGeom>
+          <a:solidFill>
+            <a:srgbClr val="F5C400"/>
+          </a:solidFill>
+          <a:ln w="12700">
+            <a:solidFill>
+              <a:srgbClr val="F5C400"/>
+            </a:solidFill>
+            <a:prstDash val="solid"/>
+          </a:ln>
+        </p:spPr>
+      </p:sp>
+      <p:sp>
+        <p:nvSpPr>
+          <p:cNvPr id="58" name="Text 55"/>
+          <p:cNvSpPr txBox="1"/>
+          <p:nvPr/>
+        </p:nvSpPr>
+        <p:spPr>
+          <a:xfrm>
+            <a:off x="6446520" y="4745736"/>
+            <a:ext cx="1600200" cy="246888"/>
+          </a:xfrm>
+          <a:prstGeom prst="rect">
+            <a:avLst/>
+          </a:prstGeom>
+          <a:noFill/>
+          <a:ln/>
+        </p:spPr>
+        <p:txBody>
+          <a:bodyPr wrap="square" lIns="0" tIns="0" rIns="0" bIns="0" rtlCol="0" anchor="ctr"/>
+          <a:lstStyle/>
+          <a:p>
+            <a:pPr algn="ctr" indent="0" marL="0">
+              <a:buNone/>
+            </a:pPr>
+            <a:r>
+              <a:rPr lang="en-US" sz="1000" b="1" dirty="0">
+                <a:solidFill>
+                  <a:srgbClr val="111111"/>
+                </a:solidFill>
+              </a:rPr>
+              <a:t>Ajuste por feedback</a:t>
+            </a:r>
+            <a:endParaRPr lang="en-US" sz="1000" dirty="0"/>
+          </a:p>
+        </p:txBody>
+      </p:sp>
+      <p:sp>
+        <p:nvSpPr>
           <p:cNvPr id="25" name="Slide Number Placeholder 0"/>
           <p:cNvSpPr>
             <a:spLocks noGrp="1"/>
@@ -8403,9 +8740,72 @@
                   <a:srgbClr val="111111"/>
                 </a:solidFill>
               </a:rPr>
-              <a:t>Sprint 0 completado. Sprint 1 en curso, con CORS y límite de intentos listos. Backlog en GitHub: un milestone por sprint y un issue por tarea.</a:t>
+              <a:t>Sprint 0 completado y Sprint 1 en curso. Backlog en GitHub: un milestone por sprint y un issue por tarea.</a:t>
             </a:r>
             <a:endParaRPr lang="en-US" sz="1300" dirty="0"/>
+          </a:p>
+        </p:txBody>
+      </p:sp>
+      <p:sp>
+        <p:nvSpPr>
+          <p:cNvPr id="26" name="Shape 23"/>
+          <p:cNvSpPr/>
+          <p:nvPr/>
+        </p:nvSpPr>
+        <p:spPr>
+          <a:xfrm>
+            <a:off x="6446520" y="4745736"/>
+            <a:ext cx="1600200" cy="246888"/>
+          </a:xfrm>
+          <a:prstGeom prst="roundRect">
+            <a:avLst>
+              <a:gd name="adj" fmla="val 48148"/>
+            </a:avLst>
+          </a:prstGeom>
+          <a:solidFill>
+            <a:srgbClr val="F5C400"/>
+          </a:solidFill>
+          <a:ln w="12700">
+            <a:solidFill>
+              <a:srgbClr val="F5C400"/>
+            </a:solidFill>
+            <a:prstDash val="solid"/>
+          </a:ln>
+        </p:spPr>
+      </p:sp>
+      <p:sp>
+        <p:nvSpPr>
+          <p:cNvPr id="27" name="Text 24"/>
+          <p:cNvSpPr txBox="1"/>
+          <p:nvPr/>
+        </p:nvSpPr>
+        <p:spPr>
+          <a:xfrm>
+            <a:off x="6446520" y="4745736"/>
+            <a:ext cx="1600200" cy="246888"/>
+          </a:xfrm>
+          <a:prstGeom prst="rect">
+            <a:avLst/>
+          </a:prstGeom>
+          <a:noFill/>
+          <a:ln/>
+        </p:spPr>
+        <p:txBody>
+          <a:bodyPr wrap="square" lIns="0" tIns="0" rIns="0" bIns="0" rtlCol="0" anchor="ctr"/>
+          <a:lstStyle/>
+          <a:p>
+            <a:pPr algn="ctr" indent="0" marL="0">
+              <a:buNone/>
+            </a:pPr>
+            <a:r>
+              <a:rPr lang="en-US" sz="1000" b="1" dirty="0">
+                <a:solidFill>
+                  <a:srgbClr val="111111"/>
+                </a:solidFill>
+              </a:rPr>
+              <a:t>Ajuste por feedback</a:t>
+            </a:r>
+            <a:endParaRPr lang="en-US" sz="1000" dirty="0"/>
           </a:p>
         </p:txBody>
       </p:sp>
@@ -10810,6 +11210,69 @@
       </p:sp>
       <p:sp>
         <p:nvSpPr>
+          <p:cNvPr id="37" name="Shape 34"/>
+          <p:cNvSpPr/>
+          <p:nvPr/>
+        </p:nvSpPr>
+        <p:spPr>
+          <a:xfrm>
+            <a:off x="6446520" y="4745736"/>
+            <a:ext cx="1600200" cy="246888"/>
+          </a:xfrm>
+          <a:prstGeom prst="roundRect">
+            <a:avLst>
+              <a:gd name="adj" fmla="val 48148"/>
+            </a:avLst>
+          </a:prstGeom>
+          <a:solidFill>
+            <a:srgbClr val="F5C400"/>
+          </a:solidFill>
+          <a:ln w="12700">
+            <a:solidFill>
+              <a:srgbClr val="F5C400"/>
+            </a:solidFill>
+            <a:prstDash val="solid"/>
+          </a:ln>
+        </p:spPr>
+      </p:sp>
+      <p:sp>
+        <p:nvSpPr>
+          <p:cNvPr id="38" name="Text 35"/>
+          <p:cNvSpPr txBox="1"/>
+          <p:nvPr/>
+        </p:nvSpPr>
+        <p:spPr>
+          <a:xfrm>
+            <a:off x="6446520" y="4745736"/>
+            <a:ext cx="1600200" cy="246888"/>
+          </a:xfrm>
+          <a:prstGeom prst="rect">
+            <a:avLst/>
+          </a:prstGeom>
+          <a:noFill/>
+          <a:ln/>
+        </p:spPr>
+        <p:txBody>
+          <a:bodyPr wrap="square" lIns="0" tIns="0" rIns="0" bIns="0" rtlCol="0" anchor="ctr"/>
+          <a:lstStyle/>
+          <a:p>
+            <a:pPr algn="ctr" indent="0" marL="0">
+              <a:buNone/>
+            </a:pPr>
+            <a:r>
+              <a:rPr lang="en-US" sz="1000" b="1" dirty="0">
+                <a:solidFill>
+                  <a:srgbClr val="111111"/>
+                </a:solidFill>
+              </a:rPr>
+              <a:t>Ajuste por feedback</a:t>
+            </a:r>
+            <a:endParaRPr lang="en-US" sz="1000" dirty="0"/>
+          </a:p>
+        </p:txBody>
+      </p:sp>
+      <p:sp>
+        <p:nvSpPr>
           <p:cNvPr id="25" name="Slide Number Placeholder 0"/>
           <p:cNvSpPr>
             <a:spLocks noGrp="1"/>
@@ -11781,12 +12244,12 @@
         </p:nvSpPr>
         <p:spPr>
           <a:xfrm>
-            <a:off x="402336" y="813816"/>
-            <a:ext cx="1757540" cy="256032"/>
+            <a:off x="7086600" y="347472"/>
+            <a:ext cx="1600200" cy="246888"/>
           </a:xfrm>
           <a:prstGeom prst="roundRect">
             <a:avLst>
-              <a:gd name="adj" fmla="val 21429"/>
+              <a:gd name="adj" fmla="val 48148"/>
             </a:avLst>
           </a:prstGeom>
           <a:solidFill>
@@ -11808,9 +12271,72 @@
         </p:nvSpPr>
         <p:spPr>
           <a:xfrm>
+            <a:off x="7086600" y="347472"/>
+            <a:ext cx="1600200" cy="246888"/>
+          </a:xfrm>
+          <a:prstGeom prst="rect">
+            <a:avLst/>
+          </a:prstGeom>
+          <a:noFill/>
+          <a:ln/>
+        </p:spPr>
+        <p:txBody>
+          <a:bodyPr wrap="square" lIns="0" tIns="0" rIns="0" bIns="0" rtlCol="0" anchor="ctr"/>
+          <a:lstStyle/>
+          <a:p>
+            <a:pPr algn="ctr" indent="0" marL="0">
+              <a:buNone/>
+            </a:pPr>
+            <a:r>
+              <a:rPr lang="en-US" sz="1000" b="1" dirty="0">
+                <a:solidFill>
+                  <a:srgbClr val="111111"/>
+                </a:solidFill>
+              </a:rPr>
+              <a:t>Ajuste por feedback</a:t>
+            </a:r>
+            <a:endParaRPr lang="en-US" sz="1000" dirty="0"/>
+          </a:p>
+        </p:txBody>
+      </p:sp>
+      <p:sp>
+        <p:nvSpPr>
+          <p:cNvPr id="5" name="Shape 3"/>
+          <p:cNvSpPr/>
+          <p:nvPr/>
+        </p:nvSpPr>
+        <p:spPr>
+          <a:xfrm>
             <a:off x="402336" y="813816"/>
             <a:ext cx="1757540" cy="256032"/>
           </a:xfrm>
+          <a:prstGeom prst="roundRect">
+            <a:avLst>
+              <a:gd name="adj" fmla="val 21429"/>
+            </a:avLst>
+          </a:prstGeom>
+          <a:solidFill>
+            <a:srgbClr val="F5C400"/>
+          </a:solidFill>
+          <a:ln w="12700">
+            <a:solidFill>
+              <a:srgbClr val="F5C400"/>
+            </a:solidFill>
+            <a:prstDash val="solid"/>
+          </a:ln>
+        </p:spPr>
+      </p:sp>
+      <p:sp>
+        <p:nvSpPr>
+          <p:cNvPr id="6" name="Text 4"/>
+          <p:cNvSpPr txBox="1"/>
+          <p:nvPr/>
+        </p:nvSpPr>
+        <p:spPr>
+          <a:xfrm>
+            <a:off x="402336" y="813816"/>
+            <a:ext cx="1757540" cy="256032"/>
+          </a:xfrm>
           <a:prstGeom prst="rect">
             <a:avLst/>
           </a:prstGeom>
@@ -11838,7 +12364,7 @@
       </p:sp>
       <p:sp>
         <p:nvSpPr>
-          <p:cNvPr id="5" name="Shape 3"/>
+          <p:cNvPr id="7" name="Shape 5"/>
           <p:cNvSpPr/>
           <p:nvPr/>
         </p:nvSpPr>
@@ -11865,7 +12391,7 @@
       </p:sp>
       <p:pic>
         <p:nvPicPr>
-          <p:cNvPr id="6" name="Image 0" descr="Captura de la app: Bienvenida">    </p:cNvPr>
+          <p:cNvPr id="8" name="Image 0" descr="Captura de la app: Bienvenida">    </p:cNvPr>
           <p:cNvPicPr>
             <a:picLocks noChangeAspect="1"/>
           </p:cNvPicPr>
@@ -11889,7 +12415,7 @@
       </p:pic>
       <p:sp>
         <p:nvSpPr>
-          <p:cNvPr id="7" name="Shape 4"/>
+          <p:cNvPr id="9" name="Shape 6"/>
           <p:cNvSpPr/>
           <p:nvPr/>
         </p:nvSpPr>
@@ -11916,7 +12442,7 @@
       </p:sp>
       <p:sp>
         <p:nvSpPr>
-          <p:cNvPr id="8" name="Text 5"/>
+          <p:cNvPr id="10" name="Text 7"/>
           <p:cNvSpPr txBox="1"/>
           <p:nvPr/>
         </p:nvSpPr>
@@ -11952,7 +12478,7 @@
       </p:sp>
       <p:sp>
         <p:nvSpPr>
-          <p:cNvPr id="9" name="Shape 6"/>
+          <p:cNvPr id="11" name="Shape 8"/>
           <p:cNvSpPr/>
           <p:nvPr/>
         </p:nvSpPr>
@@ -11979,7 +12505,7 @@
       </p:sp>
       <p:pic>
         <p:nvPicPr>
-          <p:cNvPr id="10" name="Image 1" descr="Captura de la app: Tarjeta de socio">    </p:cNvPr>
+          <p:cNvPr id="12" name="Image 1" descr="Captura de la app: Tarjeta de socio">    </p:cNvPr>
           <p:cNvPicPr>
             <a:picLocks noChangeAspect="1"/>
           </p:cNvPicPr>
@@ -12003,7 +12529,7 @@
       </p:pic>
       <p:sp>
         <p:nvSpPr>
-          <p:cNvPr id="11" name="Shape 7"/>
+          <p:cNvPr id="13" name="Shape 9"/>
           <p:cNvSpPr/>
           <p:nvPr/>
         </p:nvSpPr>
@@ -12030,7 +12556,7 @@
       </p:sp>
       <p:sp>
         <p:nvSpPr>
-          <p:cNvPr id="12" name="Text 8"/>
+          <p:cNvPr id="14" name="Text 10"/>
           <p:cNvSpPr txBox="1"/>
           <p:nvPr/>
         </p:nvSpPr>
@@ -12066,7 +12592,7 @@
       </p:sp>
       <p:sp>
         <p:nvSpPr>
-          <p:cNvPr id="13" name="Shape 9"/>
+          <p:cNvPr id="15" name="Shape 11"/>
           <p:cNvSpPr/>
           <p:nvPr/>
         </p:nvSpPr>
@@ -12093,7 +12619,7 @@
       </p:sp>
       <p:pic>
         <p:nvPicPr>
-          <p:cNvPr id="14" name="Image 2" descr="Captura de la app: Pase QR del cliente">    </p:cNvPr>
+          <p:cNvPr id="16" name="Image 2" descr="Captura de la app: Pase QR del cliente">    </p:cNvPr>
           <p:cNvPicPr>
             <a:picLocks noChangeAspect="1"/>
           </p:cNvPicPr>
@@ -12117,7 +12643,7 @@
       </p:pic>
       <p:sp>
         <p:nvSpPr>
-          <p:cNvPr id="15" name="Shape 10"/>
+          <p:cNvPr id="17" name="Shape 12"/>
           <p:cNvSpPr/>
           <p:nvPr/>
         </p:nvSpPr>
@@ -12144,7 +12670,7 @@
       </p:sp>
       <p:sp>
         <p:nvSpPr>
-          <p:cNvPr id="16" name="Text 11"/>
+          <p:cNvPr id="18" name="Text 13"/>
           <p:cNvSpPr txBox="1"/>
           <p:nvPr/>
         </p:nvSpPr>
@@ -12180,7 +12706,7 @@
       </p:sp>
       <p:sp>
         <p:nvSpPr>
-          <p:cNvPr id="17" name="Shape 12"/>
+          <p:cNvPr id="19" name="Shape 14"/>
           <p:cNvSpPr/>
           <p:nvPr/>
         </p:nvSpPr>
@@ -12207,7 +12733,7 @@
       </p:sp>
       <p:pic>
         <p:nvPicPr>
-          <p:cNvPr id="18" name="Image 3" descr="Captura de la app: Recompensas del cliente">    </p:cNvPr>
+          <p:cNvPr id="20" name="Image 3" descr="Captura de la app: Recompensas del cliente">    </p:cNvPr>
           <p:cNvPicPr>
             <a:picLocks noChangeAspect="1"/>
           </p:cNvPicPr>

</xml_diff>